<commit_message>
Atualiza manuais e apresentacao com os registros de cotacoes e o grafico compra x alvo
Co-Authored-By: Claude Opus 5.5 <noreply@anthropic.com>
</commit_message>
<xml_diff>
--- a/docs/BolsaTrader_Manual_Operacional.pptx
+++ b/docs/BolsaTrader_Manual_Operacional.pptx
@@ -22,6 +22,7 @@
     <p:sldId id="270" r:id="rId16"/>
     <p:sldId id="271" r:id="rId17"/>
     <p:sldId id="272" r:id="rId18"/>
+    <p:sldId id="279" r:id="rId30"/>
     <p:sldId id="273" r:id="rId19"/>
     <p:sldId id="274" r:id="rId20"/>
     <p:sldId id="278" r:id="rId29"/>
@@ -2764,6 +2765,10 @@
           </a:solidFill>
           <a:ln/>
         </p:spPr>
+        <p:txBody>
+          <a:bodyPr/>
+          <a:p/>
+        </p:txBody>
       </p:sp>
       <p:sp>
         <p:nvSpPr>
@@ -2784,6 +2789,10 @@
           </a:solidFill>
           <a:ln/>
         </p:spPr>
+        <p:txBody>
+          <a:bodyPr/>
+          <a:p/>
+        </p:txBody>
       </p:sp>
       <p:sp>
         <p:nvSpPr>
@@ -2804,6 +2813,10 @@
           </a:solidFill>
           <a:ln/>
         </p:spPr>
+        <p:txBody>
+          <a:bodyPr/>
+          <a:p/>
+        </p:txBody>
       </p:sp>
       <p:sp>
         <p:nvSpPr>
@@ -2824,6 +2837,10 @@
           </a:solidFill>
           <a:ln/>
         </p:spPr>
+        <p:txBody>
+          <a:bodyPr/>
+          <a:p/>
+        </p:txBody>
       </p:sp>
       <p:pic>
         <p:nvPicPr>
@@ -3019,7 +3036,7 @@
                 <a:ea typeface="Calibri" pitchFamily="34" charset="-122"/>
                 <a:cs typeface="Calibri" pitchFamily="34" charset="-120"/>
               </a:rPr>
-              <a:t>09/2026 (revisão 22/09/2026)</a:t>
+              <a:t>10/2026 (revisão 09/10/2026)</a:t>
             </a:r>
             <a:endParaRPr lang="en-US" sz="1150" dirty="0"/>
           </a:p>
@@ -3051,6 +3068,10 @@
             <a:prstDash val="solid"/>
           </a:ln>
         </p:spPr>
+        <p:txBody>
+          <a:bodyPr/>
+          <a:p/>
+        </p:txBody>
       </p:sp>
       <p:sp>
         <p:nvSpPr>
@@ -3071,6 +3092,10 @@
           </a:solidFill>
           <a:ln/>
         </p:spPr>
+        <p:txBody>
+          <a:bodyPr/>
+          <a:p/>
+        </p:txBody>
       </p:sp>
       <p:pic>
         <p:nvPicPr>
@@ -11496,6 +11521,1113 @@
 
 <file path=ppt/slides/slide18.xml><?xml version="1.0" encoding="utf-8"?>
 <p:sld xmlns:a="http://schemas.openxmlformats.org/drawingml/2006/main" xmlns:r="http://schemas.openxmlformats.org/officeDocument/2006/relationships" xmlns:p="http://schemas.openxmlformats.org/presentationml/2006/main">
+  <p:cSld name="Slide 17">
+    <p:bg>
+      <p:bgPr>
+        <a:solidFill>
+          <a:srgbClr val="FFFFFF"/>
+        </a:solidFill>
+      </p:bgPr>
+    </p:bg>
+    <p:spTree>
+      <p:nvGrpSpPr>
+        <p:cNvPr id="1" name=""/>
+        <p:cNvGrpSpPr/>
+        <p:nvPr/>
+      </p:nvGrpSpPr>
+      <p:grpSpPr>
+        <a:xfrm>
+          <a:off x="0" y="0"/>
+          <a:ext cx="0" cy="0"/>
+          <a:chOff x="0" y="0"/>
+          <a:chExt cx="0" cy="0"/>
+        </a:xfrm>
+      </p:grpSpPr>
+      <p:sp>
+        <p:nvSpPr>
+          <p:cNvPr id="2" name="Text 0"/>
+          <p:cNvSpPr/>
+          <p:nvPr/>
+        </p:nvSpPr>
+        <p:spPr>
+          <a:xfrm>
+            <a:off x="548640" y="457200"/>
+            <a:ext cx="9144000" cy="292608"/>
+          </a:xfrm>
+          <a:prstGeom prst="rect">
+            <a:avLst/>
+          </a:prstGeom>
+          <a:noFill/>
+          <a:ln/>
+        </p:spPr>
+        <p:txBody>
+          <a:bodyPr wrap="square" lIns="0" tIns="0" rIns="0" bIns="0" rtlCol="0" anchor="ctr"/>
+          <a:lstStyle/>
+          <a:p>
+            <a:pPr indent="0" marL="0">
+              <a:buNone/>
+            </a:pPr>
+            <a:r>
+              <a:rPr lang="en-US" sz="1250" b="1" dirty="0">
+                <a:solidFill>
+                  <a:srgbClr val="00D68F"/>
+                </a:solidFill>
+                <a:latin typeface="Calibri" pitchFamily="34" charset="0"/>
+                <a:ea typeface="Calibri" pitchFamily="34" charset="-122"/>
+                <a:cs typeface="Calibri" pitchFamily="34" charset="-120"/>
+              </a:rPr>
+              <a:t>11.6 · 11.7  </a:t>
+            </a:r>
+            <a:pPr indent="0" marL="0">
+              <a:buNone/>
+            </a:pPr>
+            <a:r>
+              <a:rPr lang="en-US" sz="1250" b="1" spc="200" kern="0" dirty="0">
+                <a:solidFill>
+                  <a:srgbClr val="00D68F"/>
+                </a:solidFill>
+                <a:latin typeface="Calibri" pitchFamily="34" charset="0"/>
+                <a:ea typeface="Calibri" pitchFamily="34" charset="-122"/>
+                <a:cs typeface="Calibri" pitchFamily="34" charset="-120"/>
+              </a:rPr>
+              <a:t>REGISTROS DE COTAÇÕES</a:t>
+            </a:r>
+            <a:endParaRPr lang="en-US" sz="1250" dirty="0"/>
+          </a:p>
+        </p:txBody>
+      </p:sp>
+      <p:sp>
+        <p:nvSpPr>
+          <p:cNvPr id="3" name="Text 1"/>
+          <p:cNvSpPr/>
+          <p:nvPr/>
+        </p:nvSpPr>
+        <p:spPr>
+          <a:xfrm>
+            <a:off x="548640" y="749808"/>
+            <a:ext cx="11094415" cy="640080"/>
+          </a:xfrm>
+          <a:prstGeom prst="rect">
+            <a:avLst/>
+          </a:prstGeom>
+          <a:noFill/>
+          <a:ln/>
+        </p:spPr>
+        <p:txBody>
+          <a:bodyPr wrap="square" lIns="0" tIns="0" rIns="0" bIns="0" rtlCol="0" anchor="ctr"/>
+          <a:lstStyle/>
+          <a:p>
+            <a:pPr indent="0" marL="0">
+              <a:buNone/>
+            </a:pPr>
+            <a:r>
+              <a:rPr lang="en-US" sz="3000" b="1" dirty="0">
+                <a:solidFill>
+                  <a:srgbClr val="0D1B3E"/>
+                </a:solidFill>
+                <a:latin typeface="Calibri" pitchFamily="34" charset="0"/>
+                <a:ea typeface="Calibri" pitchFamily="34" charset="-122"/>
+                <a:cs typeface="Calibri" pitchFamily="34" charset="-120"/>
+              </a:rPr>
+              <a:t>Registros de cotações e gráfico compra x alvo</a:t>
+            </a:r>
+            <a:endParaRPr lang="en-US" sz="3000" dirty="0"/>
+          </a:p>
+        </p:txBody>
+      </p:sp>
+      <p:sp>
+        <p:nvSpPr>
+          <p:cNvPr id="4" name="Shape 2"/>
+          <p:cNvSpPr/>
+          <p:nvPr/>
+        </p:nvSpPr>
+        <p:spPr>
+          <a:xfrm>
+            <a:off x="548640" y="1463040"/>
+            <a:ext cx="5364328" cy="1600200"/>
+          </a:xfrm>
+          <a:prstGeom prst="roundRect">
+            <a:avLst>
+              <a:gd name="adj" fmla="val 5143"/>
+            </a:avLst>
+          </a:prstGeom>
+          <a:solidFill>
+            <a:srgbClr val="F3F6FC"/>
+          </a:solidFill>
+          <a:ln/>
+          <a:effectLst>
+            <a:outerShdw sx="100000" sy="100000" kx="0" ky="0" algn="bl" rotWithShape="0" blurRad="101600" dist="25400" dir="5400000">
+              <a:srgbClr val="1B2A55">
+                <a:alpha val="12000"/>
+              </a:srgbClr>
+            </a:outerShdw>
+          </a:effectLst>
+        </p:spPr>
+      </p:sp>
+      <p:sp>
+        <p:nvSpPr>
+          <p:cNvPr id="5" name="Shape 3"/>
+          <p:cNvSpPr/>
+          <p:nvPr/>
+        </p:nvSpPr>
+        <p:spPr>
+          <a:xfrm>
+            <a:off x="804672" y="1700784"/>
+            <a:ext cx="457200" cy="457200"/>
+          </a:xfrm>
+          <a:prstGeom prst="ellipse">
+            <a:avLst/>
+          </a:prstGeom>
+          <a:solidFill>
+            <a:srgbClr val="0D1B3E"/>
+          </a:solidFill>
+          <a:ln/>
+        </p:spPr>
+      </p:sp>
+      <p:pic>
+        <p:nvPicPr>
+          <p:cNvPr id="6" name="Image 0" descr="C:\Users\PC ANTONIO\AppData\Roaming\Claude\scratch-workspaces\f0f5d1bc-bf72-4611-a8ea-e50e459a0a45\08c0c592-3fff-44bf-a144-086c85aaeea0\scratch-2026-09-22-98642c\icons\trendUp.png">    </p:cNvPr>
+          <p:cNvPicPr>
+            <a:picLocks noChangeAspect="1"/>
+          </p:cNvPicPr>
+          <p:nvPr/>
+        </p:nvPicPr>
+        <p:blipFill>
+          <a:blip r:embed="rId1"/>
+          <a:stretch>
+            <a:fillRect/>
+          </a:stretch>
+        </p:blipFill>
+        <p:spPr>
+          <a:xfrm>
+            <a:off x="923544" y="1819656"/>
+            <a:ext cx="219456" cy="219456"/>
+          </a:xfrm>
+          <a:prstGeom prst="rect">
+            <a:avLst/>
+          </a:prstGeom>
+        </p:spPr>
+      </p:pic>
+      <p:sp>
+        <p:nvSpPr>
+          <p:cNvPr id="7" name="Text 4"/>
+          <p:cNvSpPr/>
+          <p:nvPr/>
+        </p:nvSpPr>
+        <p:spPr>
+          <a:xfrm>
+            <a:off x="1426464" y="1645920"/>
+            <a:ext cx="4257904" cy="365760"/>
+          </a:xfrm>
+          <a:prstGeom prst="rect">
+            <a:avLst/>
+          </a:prstGeom>
+          <a:noFill/>
+          <a:ln/>
+        </p:spPr>
+        <p:txBody>
+          <a:bodyPr wrap="square" lIns="0" tIns="0" rIns="0" bIns="0" rtlCol="0" anchor="ctr"/>
+          <a:lstStyle/>
+          <a:p>
+            <a:pPr indent="0" marL="0">
+              <a:buNone/>
+            </a:pPr>
+            <a:r>
+              <a:rPr lang="en-US" sz="1400" b="1" dirty="0">
+                <a:solidFill>
+                  <a:srgbClr val="0D1B3E"/>
+                </a:solidFill>
+                <a:latin typeface="Calibri" pitchFamily="34" charset="0"/>
+                <a:ea typeface="Calibri" pitchFamily="34" charset="-122"/>
+                <a:cs typeface="Calibri" pitchFamily="34" charset="-120"/>
+              </a:rPr>
+              <a:t>Registro a cada atualização</a:t>
+            </a:r>
+            <a:endParaRPr lang="en-US" sz="1400" dirty="0"/>
+          </a:p>
+        </p:txBody>
+      </p:sp>
+      <p:sp>
+        <p:nvSpPr>
+          <p:cNvPr id="8" name="Text 5"/>
+          <p:cNvSpPr/>
+          <p:nvPr/>
+        </p:nvSpPr>
+        <p:spPr>
+          <a:xfrm>
+            <a:off x="804672" y="2286000"/>
+            <a:ext cx="4852264" cy="612648"/>
+          </a:xfrm>
+          <a:prstGeom prst="rect">
+            <a:avLst/>
+          </a:prstGeom>
+          <a:noFill/>
+          <a:ln/>
+        </p:spPr>
+        <p:txBody>
+          <a:bodyPr wrap="square" lIns="0" tIns="0" rIns="0" bIns="0" rtlCol="0" anchor="t"/>
+          <a:lstStyle/>
+          <a:p>
+            <a:pPr indent="0" marL="0">
+              <a:lnSpc>
+                <a:spcPct val="112000"/>
+              </a:lnSpc>
+              <a:buNone/>
+            </a:pPr>
+            <a:r>
+              <a:rPr lang="en-US" sz="1050" dirty="0">
+                <a:solidFill>
+                  <a:srgbClr val="40496B"/>
+                </a:solidFill>
+                <a:latin typeface="Calibri" pitchFamily="34" charset="0"/>
+                <a:ea typeface="Calibri" pitchFamily="34" charset="-122"/>
+                <a:cs typeface="Calibri" pitchFamily="34" charset="-120"/>
+              </a:rPr>
+              <a:t>Ativo, data, hora e valor de cada ativo em carteira, gravados pela rotina automática (Automática) e pelo botão ou consulta avulsa (Manual).</a:t>
+            </a:r>
+            <a:endParaRPr lang="en-US" sz="1050" dirty="0"/>
+          </a:p>
+        </p:txBody>
+      </p:sp>
+      <p:sp>
+        <p:nvSpPr>
+          <p:cNvPr id="9" name="Shape 6"/>
+          <p:cNvSpPr/>
+          <p:nvPr/>
+        </p:nvSpPr>
+        <p:spPr>
+          <a:xfrm>
+            <a:off x="6278728" y="1463040"/>
+            <a:ext cx="5364328" cy="1600200"/>
+          </a:xfrm>
+          <a:prstGeom prst="roundRect">
+            <a:avLst>
+              <a:gd name="adj" fmla="val 5143"/>
+            </a:avLst>
+          </a:prstGeom>
+          <a:solidFill>
+            <a:srgbClr val="F3F6FC"/>
+          </a:solidFill>
+          <a:ln/>
+          <a:effectLst>
+            <a:outerShdw sx="100000" sy="100000" kx="0" ky="0" algn="bl" rotWithShape="0" blurRad="101600" dist="25400" dir="5400000">
+              <a:srgbClr val="1B2A55">
+                <a:alpha val="12000"/>
+              </a:srgbClr>
+            </a:outerShdw>
+          </a:effectLst>
+        </p:spPr>
+      </p:sp>
+      <p:sp>
+        <p:nvSpPr>
+          <p:cNvPr id="10" name="Shape 7"/>
+          <p:cNvSpPr/>
+          <p:nvPr/>
+        </p:nvSpPr>
+        <p:spPr>
+          <a:xfrm>
+            <a:off x="6534760" y="1700784"/>
+            <a:ext cx="457200" cy="457200"/>
+          </a:xfrm>
+          <a:prstGeom prst="ellipse">
+            <a:avLst/>
+          </a:prstGeom>
+          <a:solidFill>
+            <a:srgbClr val="00D68F"/>
+          </a:solidFill>
+          <a:ln/>
+        </p:spPr>
+      </p:sp>
+      <p:pic>
+        <p:nvPicPr>
+          <p:cNvPr id="11" name="Image 1" descr="C:\Users\PC ANTONIO\AppData\Roaming\Claude\scratch-workspaces\f0f5d1bc-bf72-4611-a8ea-e50e459a0a45\08c0c592-3fff-44bf-a144-086c85aaeea0\scratch-2026-09-22-98642c\icons\list.png">    </p:cNvPr>
+          <p:cNvPicPr>
+            <a:picLocks noChangeAspect="1"/>
+          </p:cNvPicPr>
+          <p:nvPr/>
+        </p:nvPicPr>
+        <p:blipFill>
+          <a:blip r:embed="rId2"/>
+          <a:stretch>
+            <a:fillRect/>
+          </a:stretch>
+        </p:blipFill>
+        <p:spPr>
+          <a:xfrm>
+            <a:off x="6653632" y="1819656"/>
+            <a:ext cx="219456" cy="219456"/>
+          </a:xfrm>
+          <a:prstGeom prst="rect">
+            <a:avLst/>
+          </a:prstGeom>
+        </p:spPr>
+      </p:pic>
+      <p:sp>
+        <p:nvSpPr>
+          <p:cNvPr id="12" name="Text 8"/>
+          <p:cNvSpPr/>
+          <p:nvPr/>
+        </p:nvSpPr>
+        <p:spPr>
+          <a:xfrm>
+            <a:off x="7156552" y="1645920"/>
+            <a:ext cx="4257904" cy="365760"/>
+          </a:xfrm>
+          <a:prstGeom prst="rect">
+            <a:avLst/>
+          </a:prstGeom>
+          <a:noFill/>
+          <a:ln/>
+        </p:spPr>
+        <p:txBody>
+          <a:bodyPr wrap="square" lIns="0" tIns="0" rIns="0" bIns="0" rtlCol="0" anchor="ctr"/>
+          <a:lstStyle/>
+          <a:p>
+            <a:pPr indent="0" marL="0">
+              <a:buNone/>
+            </a:pPr>
+            <a:r>
+              <a:rPr lang="en-US" sz="1400" b="1" dirty="0">
+                <a:solidFill>
+                  <a:srgbClr val="0D1B3E"/>
+                </a:solidFill>
+                <a:latin typeface="Calibri" pitchFamily="34" charset="0"/>
+                <a:ea typeface="Calibri" pitchFamily="34" charset="-122"/>
+                <a:cs typeface="Calibri" pitchFamily="34" charset="-120"/>
+              </a:rPr>
+              <a:t>Grid em Detalhes de Cotações</a:t>
+            </a:r>
+            <a:endParaRPr lang="en-US" sz="1400" dirty="0"/>
+          </a:p>
+        </p:txBody>
+      </p:sp>
+      <p:sp>
+        <p:nvSpPr>
+          <p:cNvPr id="13" name="Text 9"/>
+          <p:cNvSpPr/>
+          <p:nvPr/>
+        </p:nvSpPr>
+        <p:spPr>
+          <a:xfrm>
+            <a:off x="6534760" y="2286000"/>
+            <a:ext cx="4852264" cy="612648"/>
+          </a:xfrm>
+          <a:prstGeom prst="rect">
+            <a:avLst/>
+          </a:prstGeom>
+          <a:noFill/>
+          <a:ln/>
+        </p:spPr>
+        <p:txBody>
+          <a:bodyPr wrap="square" lIns="0" tIns="0" rIns="0" bIns="0" rtlCol="0" anchor="t"/>
+          <a:lstStyle/>
+          <a:p>
+            <a:pPr indent="0" marL="0">
+              <a:lnSpc>
+                <a:spcPct val="112000"/>
+              </a:lnSpc>
+              <a:buNone/>
+            </a:pPr>
+            <a:r>
+              <a:rPr lang="en-US" sz="1050" dirty="0">
+                <a:solidFill>
+                  <a:srgbClr val="40496B"/>
+                </a:solidFill>
+                <a:latin typeface="Calibri" pitchFamily="34" charset="0"/>
+                <a:ea typeface="Calibri" pitchFamily="34" charset="-122"/>
+                <a:cs typeface="Calibri" pitchFamily="34" charset="-120"/>
+              </a:rPr>
+              <a:t>Botão "Registros de cotações", ao lado de "Pesquisar cotação": registros do ticker digitado ou de todos os ativos, do mais recente ao mais antigo.</a:t>
+            </a:r>
+            <a:endParaRPr lang="en-US" sz="1050" dirty="0"/>
+          </a:p>
+        </p:txBody>
+      </p:sp>
+      <p:sp>
+        <p:nvSpPr>
+          <p:cNvPr id="14" name="Shape 10"/>
+          <p:cNvSpPr/>
+          <p:nvPr/>
+        </p:nvSpPr>
+        <p:spPr>
+          <a:xfrm>
+            <a:off x="548640" y="3246120"/>
+            <a:ext cx="5364328" cy="1280160"/>
+          </a:xfrm>
+          <a:prstGeom prst="roundRect">
+            <a:avLst>
+              <a:gd name="adj" fmla="val 6429"/>
+            </a:avLst>
+          </a:prstGeom>
+          <a:solidFill>
+            <a:srgbClr val="F3F6FC"/>
+          </a:solidFill>
+          <a:ln/>
+          <a:effectLst>
+            <a:outerShdw sx="100000" sy="100000" kx="0" ky="0" algn="bl" rotWithShape="0" blurRad="101600" dist="25400" dir="5400000">
+              <a:srgbClr val="1B2A55">
+                <a:alpha val="12000"/>
+              </a:srgbClr>
+            </a:outerShdw>
+          </a:effectLst>
+        </p:spPr>
+      </p:sp>
+      <p:sp>
+        <p:nvSpPr>
+          <p:cNvPr id="15" name="Shape 11"/>
+          <p:cNvSpPr/>
+          <p:nvPr/>
+        </p:nvSpPr>
+        <p:spPr>
+          <a:xfrm>
+            <a:off x="804672" y="3483864"/>
+            <a:ext cx="310896" cy="310896"/>
+          </a:xfrm>
+          <a:prstGeom prst="ellipse">
+            <a:avLst/>
+          </a:prstGeom>
+          <a:solidFill>
+            <a:srgbClr val="0D1B3E"/>
+          </a:solidFill>
+          <a:ln/>
+        </p:spPr>
+      </p:sp>
+      <p:pic>
+        <p:nvPicPr>
+          <p:cNvPr id="16" name="Image 2" descr="C:\Users\PC ANTONIO\AppData\Roaming\Claude\scratch-workspaces\f0f5d1bc-bf72-4611-a8ea-e50e459a0a45\08c0c592-3fff-44bf-a144-086c85aaeea0\scratch-2026-09-22-98642c\icons\search.png">    </p:cNvPr>
+          <p:cNvPicPr>
+            <a:picLocks noChangeAspect="1"/>
+          </p:cNvPicPr>
+          <p:nvPr/>
+        </p:nvPicPr>
+        <p:blipFill>
+          <a:blip r:embed="rId3"/>
+          <a:stretch>
+            <a:fillRect/>
+          </a:stretch>
+        </p:blipFill>
+        <p:spPr>
+          <a:xfrm>
+            <a:off x="885505" y="3564697"/>
+            <a:ext cx="149230" cy="149230"/>
+          </a:xfrm>
+          <a:prstGeom prst="rect">
+            <a:avLst/>
+          </a:prstGeom>
+        </p:spPr>
+      </p:pic>
+      <p:sp>
+        <p:nvSpPr>
+          <p:cNvPr id="17" name="Text 12"/>
+          <p:cNvSpPr/>
+          <p:nvPr/>
+        </p:nvSpPr>
+        <p:spPr>
+          <a:xfrm>
+            <a:off x="1280160" y="3429000"/>
+            <a:ext cx="4404208" cy="365760"/>
+          </a:xfrm>
+          <a:prstGeom prst="rect">
+            <a:avLst/>
+          </a:prstGeom>
+          <a:noFill/>
+          <a:ln/>
+        </p:spPr>
+        <p:txBody>
+          <a:bodyPr wrap="square" lIns="0" tIns="0" rIns="0" bIns="0" rtlCol="0" anchor="ctr"/>
+          <a:lstStyle/>
+          <a:p>
+            <a:pPr indent="0" marL="0">
+              <a:buNone/>
+            </a:pPr>
+            <a:r>
+              <a:rPr lang="en-US" sz="1350" b="1" dirty="0">
+                <a:solidFill>
+                  <a:srgbClr val="0D1B3E"/>
+                </a:solidFill>
+                <a:latin typeface="Calibri" pitchFamily="34" charset="0"/>
+                <a:ea typeface="Calibri" pitchFamily="34" charset="-122"/>
+                <a:cs typeface="Calibri" pitchFamily="34" charset="-120"/>
+              </a:rPr>
+              <a:t>Gráfico compra x alvo em popup</a:t>
+            </a:r>
+            <a:endParaRPr lang="en-US" sz="1350" dirty="0"/>
+          </a:p>
+        </p:txBody>
+      </p:sp>
+      <p:sp>
+        <p:nvSpPr>
+          <p:cNvPr id="18" name="Text 13"/>
+          <p:cNvSpPr/>
+          <p:nvPr/>
+        </p:nvSpPr>
+        <p:spPr>
+          <a:xfrm>
+            <a:off x="804672" y="3922776"/>
+            <a:ext cx="4852264" cy="438912"/>
+          </a:xfrm>
+          <a:prstGeom prst="rect">
+            <a:avLst/>
+          </a:prstGeom>
+          <a:noFill/>
+          <a:ln/>
+        </p:spPr>
+        <p:txBody>
+          <a:bodyPr wrap="square" lIns="0" tIns="0" rIns="0" bIns="0" rtlCol="0" anchor="t"/>
+          <a:lstStyle/>
+          <a:p>
+            <a:pPr indent="0" marL="0">
+              <a:lnSpc>
+                <a:spcPct val="112000"/>
+              </a:lnSpc>
+              <a:buNone/>
+            </a:pPr>
+            <a:r>
+              <a:rPr lang="en-US" sz="1050" dirty="0">
+                <a:solidFill>
+                  <a:srgbClr val="40496B"/>
+                </a:solidFill>
+                <a:latin typeface="Calibri" pitchFamily="34" charset="0"/>
+                <a:ea typeface="Calibri" pitchFamily="34" charset="-122"/>
+                <a:cs typeface="Calibri" pitchFamily="34" charset="-120"/>
+              </a:rPr>
+              <a:t>Botão de gráfico ao lado do ticker: linha das cotações registradas com o preço de compra (azul) e o alvo (laranja) como referências.</a:t>
+            </a:r>
+            <a:endParaRPr lang="en-US" sz="1050" dirty="0"/>
+          </a:p>
+        </p:txBody>
+      </p:sp>
+      <p:sp>
+        <p:nvSpPr>
+          <p:cNvPr id="19" name="Shape 14"/>
+          <p:cNvSpPr/>
+          <p:nvPr/>
+        </p:nvSpPr>
+        <p:spPr>
+          <a:xfrm>
+            <a:off x="6278728" y="3246120"/>
+            <a:ext cx="5364328" cy="1280160"/>
+          </a:xfrm>
+          <a:prstGeom prst="roundRect">
+            <a:avLst>
+              <a:gd name="adj" fmla="val 6429"/>
+            </a:avLst>
+          </a:prstGeom>
+          <a:solidFill>
+            <a:srgbClr val="F3F6FC"/>
+          </a:solidFill>
+          <a:ln/>
+          <a:effectLst>
+            <a:outerShdw sx="100000" sy="100000" kx="0" ky="0" algn="bl" rotWithShape="0" blurRad="101600" dist="25400" dir="5400000">
+              <a:srgbClr val="1B2A55">
+                <a:alpha val="12000"/>
+              </a:srgbClr>
+            </a:outerShdw>
+          </a:effectLst>
+        </p:spPr>
+      </p:sp>
+      <p:sp>
+        <p:nvSpPr>
+          <p:cNvPr id="20" name="Shape 15"/>
+          <p:cNvSpPr/>
+          <p:nvPr/>
+        </p:nvSpPr>
+        <p:spPr>
+          <a:xfrm>
+            <a:off x="6534760" y="3483864"/>
+            <a:ext cx="310896" cy="310896"/>
+          </a:xfrm>
+          <a:prstGeom prst="ellipse">
+            <a:avLst/>
+          </a:prstGeom>
+          <a:solidFill>
+            <a:srgbClr val="00D68F"/>
+          </a:solidFill>
+          <a:ln/>
+        </p:spPr>
+      </p:sp>
+      <p:pic>
+        <p:nvPicPr>
+          <p:cNvPr id="21" name="Image 3" descr="C:\Users\PC ANTONIO\AppData\Roaming\Claude\scratch-workspaces\f0f5d1bc-bf72-4611-a8ea-e50e459a0a45\08c0c592-3fff-44bf-a144-086c85aaeea0\scratch-2026-09-22-98642c\icons\activity.png">    </p:cNvPr>
+          <p:cNvPicPr>
+            <a:picLocks noChangeAspect="1"/>
+          </p:cNvPicPr>
+          <p:nvPr/>
+        </p:nvPicPr>
+        <p:blipFill>
+          <a:blip r:embed="rId4"/>
+          <a:stretch>
+            <a:fillRect/>
+          </a:stretch>
+        </p:blipFill>
+        <p:spPr>
+          <a:xfrm>
+            <a:off x="6615593" y="3564697"/>
+            <a:ext cx="149230" cy="149230"/>
+          </a:xfrm>
+          <a:prstGeom prst="rect">
+            <a:avLst/>
+          </a:prstGeom>
+        </p:spPr>
+      </p:pic>
+      <p:sp>
+        <p:nvSpPr>
+          <p:cNvPr id="22" name="Text 16"/>
+          <p:cNvSpPr/>
+          <p:nvPr/>
+        </p:nvSpPr>
+        <p:spPr>
+          <a:xfrm>
+            <a:off x="7010248" y="3429000"/>
+            <a:ext cx="4404208" cy="365760"/>
+          </a:xfrm>
+          <a:prstGeom prst="rect">
+            <a:avLst/>
+          </a:prstGeom>
+          <a:noFill/>
+          <a:ln/>
+        </p:spPr>
+        <p:txBody>
+          <a:bodyPr wrap="square" lIns="0" tIns="0" rIns="0" bIns="0" rtlCol="0" anchor="ctr"/>
+          <a:lstStyle/>
+          <a:p>
+            <a:pPr indent="0" marL="0">
+              <a:buNone/>
+            </a:pPr>
+            <a:r>
+              <a:rPr lang="en-US" sz="1350" b="1" dirty="0">
+                <a:solidFill>
+                  <a:srgbClr val="0D1B3E"/>
+                </a:solidFill>
+                <a:latin typeface="Calibri" pitchFamily="34" charset="0"/>
+                <a:ea typeface="Calibri" pitchFamily="34" charset="-122"/>
+                <a:cs typeface="Calibri" pitchFamily="34" charset="-120"/>
+              </a:rPr>
+              <a:t>Exclusão após a venda</a:t>
+            </a:r>
+            <a:endParaRPr lang="en-US" sz="1350" dirty="0"/>
+          </a:p>
+        </p:txBody>
+      </p:sp>
+      <p:sp>
+        <p:nvSpPr>
+          <p:cNvPr id="23" name="Text 17"/>
+          <p:cNvSpPr/>
+          <p:nvPr/>
+        </p:nvSpPr>
+        <p:spPr>
+          <a:xfrm>
+            <a:off x="6534760" y="3922776"/>
+            <a:ext cx="4852264" cy="438912"/>
+          </a:xfrm>
+          <a:prstGeom prst="rect">
+            <a:avLst/>
+          </a:prstGeom>
+          <a:noFill/>
+          <a:ln/>
+        </p:spPr>
+        <p:txBody>
+          <a:bodyPr wrap="square" lIns="0" tIns="0" rIns="0" bIns="0" rtlCol="0" anchor="t"/>
+          <a:lstStyle/>
+          <a:p>
+            <a:pPr indent="0" marL="0">
+              <a:lnSpc>
+                <a:spcPct val="112000"/>
+              </a:lnSpc>
+              <a:buNone/>
+            </a:pPr>
+            <a:r>
+              <a:rPr lang="en-US" sz="1050" dirty="0">
+                <a:solidFill>
+                  <a:srgbClr val="40496B"/>
+                </a:solidFill>
+                <a:latin typeface="Calibri" pitchFamily="34" charset="0"/>
+                <a:ea typeface="Calibri" pitchFamily="34" charset="-122"/>
+                <a:cs typeface="Calibri" pitchFamily="34" charset="-120"/>
+              </a:rPr>
+              <a:t>Depois de vender, o sistema pergunta se exclui os registros do ativo: Sim apaga todos, Não mantém.</a:t>
+            </a:r>
+            <a:endParaRPr lang="en-US" sz="1050" dirty="0"/>
+          </a:p>
+        </p:txBody>
+      </p:sp>
+      <p:sp>
+        <p:nvSpPr>
+          <p:cNvPr id="24" name="Text 18"/>
+          <p:cNvSpPr/>
+          <p:nvPr/>
+        </p:nvSpPr>
+        <p:spPr>
+          <a:xfrm>
+            <a:off x="548640" y="4709160"/>
+            <a:ext cx="7315200" cy="274320"/>
+          </a:xfrm>
+          <a:prstGeom prst="rect">
+            <a:avLst/>
+          </a:prstGeom>
+          <a:noFill/>
+          <a:ln/>
+        </p:spPr>
+        <p:txBody>
+          <a:bodyPr wrap="square" lIns="0" tIns="0" rIns="0" bIns="0" rtlCol="0" anchor="ctr"/>
+          <a:lstStyle/>
+          <a:p>
+            <a:pPr indent="0" marL="0">
+              <a:buNone/>
+            </a:pPr>
+            <a:r>
+              <a:rPr lang="en-US" sz="1350" b="1" dirty="0">
+                <a:solidFill>
+                  <a:srgbClr val="0D1B3E"/>
+                </a:solidFill>
+                <a:latin typeface="Calibri" pitchFamily="34" charset="0"/>
+                <a:ea typeface="Calibri" pitchFamily="34" charset="-122"/>
+                <a:cs typeface="Calibri" pitchFamily="34" charset="-120"/>
+              </a:rPr>
+              <a:t>Onde fica o botão de gráfico</a:t>
+            </a:r>
+            <a:endParaRPr lang="en-US" sz="1350" dirty="0"/>
+          </a:p>
+        </p:txBody>
+      </p:sp>
+      <p:sp>
+        <p:nvSpPr>
+          <p:cNvPr id="25" name="Shape 19"/>
+          <p:cNvSpPr/>
+          <p:nvPr/>
+        </p:nvSpPr>
+        <p:spPr>
+          <a:xfrm>
+            <a:off x="548640" y="5074920"/>
+            <a:ext cx="384048" cy="384048"/>
+          </a:xfrm>
+          <a:prstGeom prst="ellipse">
+            <a:avLst/>
+          </a:prstGeom>
+          <a:solidFill>
+            <a:srgbClr val="00D68F"/>
+          </a:solidFill>
+          <a:ln/>
+        </p:spPr>
+      </p:sp>
+      <p:pic>
+        <p:nvPicPr>
+          <p:cNvPr id="26" name="Image 4" descr="C:\Users\PC ANTONIO\AppData\Roaming\Claude\scratch-workspaces\f0f5d1bc-bf72-4611-a8ea-e50e459a0a45\08c0c592-3fff-44bf-a144-086c85aaeea0\scratch-2026-09-22-98642c\icons\trendUp.png">    </p:cNvPr>
+          <p:cNvPicPr>
+            <a:picLocks noChangeAspect="1"/>
+          </p:cNvPicPr>
+          <p:nvPr/>
+        </p:nvPicPr>
+        <p:blipFill>
+          <a:blip r:embed="rId5"/>
+          <a:stretch>
+            <a:fillRect/>
+          </a:stretch>
+        </p:blipFill>
+        <p:spPr>
+          <a:xfrm>
+            <a:off x="640812" y="5167092"/>
+            <a:ext cx="199705" cy="199705"/>
+          </a:xfrm>
+          <a:prstGeom prst="rect">
+            <a:avLst/>
+          </a:prstGeom>
+        </p:spPr>
+      </p:pic>
+      <p:sp>
+        <p:nvSpPr>
+          <p:cNvPr id="27" name="Text 20"/>
+          <p:cNvSpPr/>
+          <p:nvPr/>
+        </p:nvSpPr>
+        <p:spPr>
+          <a:xfrm>
+            <a:off x="1078992" y="5038344"/>
+            <a:ext cx="4833976" cy="256032"/>
+          </a:xfrm>
+          <a:prstGeom prst="rect">
+            <a:avLst/>
+          </a:prstGeom>
+          <a:noFill/>
+          <a:ln/>
+        </p:spPr>
+        <p:txBody>
+          <a:bodyPr wrap="square" lIns="0" tIns="0" rIns="0" bIns="0" rtlCol="0" anchor="ctr"/>
+          <a:lstStyle/>
+          <a:p>
+            <a:pPr indent="0" marL="0">
+              <a:buNone/>
+            </a:pPr>
+            <a:r>
+              <a:rPr lang="en-US" sz="1250" b="1" dirty="0">
+                <a:solidFill>
+                  <a:srgbClr val="0D1B3E"/>
+                </a:solidFill>
+                <a:latin typeface="Calibri" pitchFamily="34" charset="0"/>
+                <a:ea typeface="Calibri" pitchFamily="34" charset="-122"/>
+                <a:cs typeface="Calibri" pitchFamily="34" charset="-120"/>
+              </a:rPr>
+              <a:t>Posições em Carteira e Painel</a:t>
+            </a:r>
+            <a:endParaRPr lang="en-US" sz="1250" dirty="0"/>
+          </a:p>
+        </p:txBody>
+      </p:sp>
+      <p:sp>
+        <p:nvSpPr>
+          <p:cNvPr id="28" name="Text 21"/>
+          <p:cNvSpPr/>
+          <p:nvPr/>
+        </p:nvSpPr>
+        <p:spPr>
+          <a:xfrm>
+            <a:off x="1078992" y="5294376"/>
+            <a:ext cx="4833976" cy="640080"/>
+          </a:xfrm>
+          <a:prstGeom prst="rect">
+            <a:avLst/>
+          </a:prstGeom>
+          <a:noFill/>
+          <a:ln/>
+        </p:spPr>
+        <p:txBody>
+          <a:bodyPr wrap="square" lIns="0" tIns="0" rIns="0" bIns="0" rtlCol="0" anchor="ctr"/>
+          <a:lstStyle/>
+          <a:p>
+            <a:pPr indent="0" marL="0">
+              <a:lnSpc>
+                <a:spcPct val="110000"/>
+              </a:lnSpc>
+              <a:buNone/>
+            </a:pPr>
+            <a:r>
+              <a:rPr lang="en-US" sz="1000" dirty="0">
+                <a:solidFill>
+                  <a:srgbClr val="40496B"/>
+                </a:solidFill>
+                <a:latin typeface="Calibri" pitchFamily="34" charset="0"/>
+                <a:ea typeface="Calibri" pitchFamily="34" charset="-122"/>
+                <a:cs typeface="Calibri" pitchFamily="34" charset="-120"/>
+              </a:rPr>
+              <a:t>Ao lado do ticker na tabela de compradas; compra = preço médio da posição, alvo = meta de lucro.</a:t>
+            </a:r>
+            <a:endParaRPr lang="en-US" sz="1000" dirty="0"/>
+          </a:p>
+        </p:txBody>
+      </p:sp>
+      <p:sp>
+        <p:nvSpPr>
+          <p:cNvPr id="29" name="Shape 22"/>
+          <p:cNvSpPr/>
+          <p:nvPr/>
+        </p:nvSpPr>
+        <p:spPr>
+          <a:xfrm>
+            <a:off x="6278728" y="5074920"/>
+            <a:ext cx="384048" cy="384048"/>
+          </a:xfrm>
+          <a:prstGeom prst="ellipse">
+            <a:avLst/>
+          </a:prstGeom>
+          <a:solidFill>
+            <a:srgbClr val="E1495A"/>
+          </a:solidFill>
+          <a:ln/>
+        </p:spPr>
+      </p:sp>
+      <p:pic>
+        <p:nvPicPr>
+          <p:cNvPr id="30" name="Image 5" descr="C:\Users\PC ANTONIO\AppData\Roaming\Claude\scratch-workspaces\f0f5d1bc-bf72-4611-a8ea-e50e459a0a45\08c0c592-3fff-44bf-a144-086c85aaeea0\scratch-2026-09-22-98642c\icons\trendDown.png">    </p:cNvPr>
+          <p:cNvPicPr>
+            <a:picLocks noChangeAspect="1"/>
+          </p:cNvPicPr>
+          <p:nvPr/>
+        </p:nvPicPr>
+        <p:blipFill>
+          <a:blip r:embed="rId6"/>
+          <a:stretch>
+            <a:fillRect/>
+          </a:stretch>
+        </p:blipFill>
+        <p:spPr>
+          <a:xfrm>
+            <a:off x="6370899" y="5167092"/>
+            <a:ext cx="199705" cy="199705"/>
+          </a:xfrm>
+          <a:prstGeom prst="rect">
+            <a:avLst/>
+          </a:prstGeom>
+        </p:spPr>
+      </p:pic>
+      <p:sp>
+        <p:nvSpPr>
+          <p:cNvPr id="31" name="Text 23"/>
+          <p:cNvSpPr/>
+          <p:nvPr/>
+        </p:nvSpPr>
+        <p:spPr>
+          <a:xfrm>
+            <a:off x="6809080" y="5038344"/>
+            <a:ext cx="4833976" cy="256032"/>
+          </a:xfrm>
+          <a:prstGeom prst="rect">
+            <a:avLst/>
+          </a:prstGeom>
+          <a:noFill/>
+          <a:ln/>
+        </p:spPr>
+        <p:txBody>
+          <a:bodyPr wrap="square" lIns="0" tIns="0" rIns="0" bIns="0" rtlCol="0" anchor="ctr"/>
+          <a:lstStyle/>
+          <a:p>
+            <a:pPr indent="0" marL="0">
+              <a:buNone/>
+            </a:pPr>
+            <a:r>
+              <a:rPr lang="en-US" sz="1250" b="1" dirty="0">
+                <a:solidFill>
+                  <a:srgbClr val="0D1B3E"/>
+                </a:solidFill>
+                <a:latin typeface="Calibri" pitchFamily="34" charset="0"/>
+                <a:ea typeface="Calibri" pitchFamily="34" charset="-122"/>
+                <a:cs typeface="Calibri" pitchFamily="34" charset="-120"/>
+              </a:rPr>
+              <a:t>Minhas Operações › Em carteira</a:t>
+            </a:r>
+            <a:endParaRPr lang="en-US" sz="1250" dirty="0"/>
+          </a:p>
+        </p:txBody>
+      </p:sp>
+      <p:sp>
+        <p:nvSpPr>
+          <p:cNvPr id="32" name="Text 24"/>
+          <p:cNvSpPr/>
+          <p:nvPr/>
+        </p:nvSpPr>
+        <p:spPr>
+          <a:xfrm>
+            <a:off x="6809080" y="5294376"/>
+            <a:ext cx="4833976" cy="640080"/>
+          </a:xfrm>
+          <a:prstGeom prst="rect">
+            <a:avLst/>
+          </a:prstGeom>
+          <a:noFill/>
+          <a:ln/>
+        </p:spPr>
+        <p:txBody>
+          <a:bodyPr wrap="square" lIns="0" tIns="0" rIns="0" bIns="0" rtlCol="0" anchor="ctr"/>
+          <a:lstStyle/>
+          <a:p>
+            <a:pPr indent="0" marL="0">
+              <a:lnSpc>
+                <a:spcPct val="110000"/>
+              </a:lnSpc>
+              <a:buNone/>
+            </a:pPr>
+            <a:r>
+              <a:rPr lang="en-US" sz="1000" dirty="0">
+                <a:solidFill>
+                  <a:srgbClr val="40496B"/>
+                </a:solidFill>
+                <a:latin typeface="Calibri" pitchFamily="34" charset="0"/>
+                <a:ea typeface="Calibri" pitchFamily="34" charset="-122"/>
+                <a:cs typeface="Calibri" pitchFamily="34" charset="-120"/>
+              </a:rPr>
+              <a:t>Ao lado do ticker de cada lote com saldo; usa o preço de compra e o alvo (meta de lucro) daquele lote, e não o preço médio da posição.</a:t>
+            </a:r>
+            <a:endParaRPr lang="en-US" sz="1000" dirty="0"/>
+          </a:p>
+        </p:txBody>
+      </p:sp>
+      <p:sp>
+        <p:nvSpPr>
+          <p:cNvPr id="33" name="Text 25"/>
+          <p:cNvSpPr/>
+          <p:nvPr/>
+        </p:nvSpPr>
+        <p:spPr>
+          <a:xfrm>
+            <a:off x="548640" y="6473952"/>
+            <a:ext cx="7315200" cy="274320"/>
+          </a:xfrm>
+          <a:prstGeom prst="rect">
+            <a:avLst/>
+          </a:prstGeom>
+          <a:noFill/>
+          <a:ln/>
+        </p:spPr>
+        <p:txBody>
+          <a:bodyPr wrap="square" lIns="0" tIns="0" rIns="0" bIns="0" rtlCol="0" anchor="ctr"/>
+          <a:lstStyle/>
+          <a:p>
+            <a:pPr algn="l" indent="0" marL="0">
+              <a:buNone/>
+            </a:pPr>
+            <a:r>
+              <a:rPr lang="en-US" sz="900" dirty="0">
+                <a:solidFill>
+                  <a:srgbClr val="7C89A8"/>
+                </a:solidFill>
+                <a:latin typeface="Calibri" pitchFamily="34" charset="0"/>
+                <a:ea typeface="Calibri" pitchFamily="34" charset="-122"/>
+                <a:cs typeface="Calibri" pitchFamily="34" charset="-120"/>
+              </a:rPr>
+              <a:t>BolsaTrader  ·  Manual Operacional do Sistema</a:t>
+            </a:r>
+            <a:endParaRPr lang="en-US" sz="900" dirty="0"/>
+          </a:p>
+        </p:txBody>
+      </p:sp>
+      <p:sp>
+        <p:nvSpPr>
+          <p:cNvPr id="34" name="Text 26"/>
+          <p:cNvSpPr/>
+          <p:nvPr/>
+        </p:nvSpPr>
+        <p:spPr>
+          <a:xfrm>
+            <a:off x="10728655" y="6473952"/>
+            <a:ext cx="914400" cy="274320"/>
+          </a:xfrm>
+          <a:prstGeom prst="rect">
+            <a:avLst/>
+          </a:prstGeom>
+          <a:noFill/>
+          <a:ln/>
+        </p:spPr>
+        <p:txBody>
+          <a:bodyPr wrap="square" lIns="0" tIns="0" rIns="0" bIns="0" rtlCol="0" anchor="ctr"/>
+          <a:lstStyle/>
+          <a:p>
+            <a:pPr algn="r" indent="0" marL="0">
+              <a:buNone/>
+            </a:pPr>
+            <a:r>
+              <a:rPr lang="en-US" sz="900" dirty="0">
+                <a:solidFill>
+                  <a:srgbClr val="7C89A8"/>
+                </a:solidFill>
+                <a:latin typeface="Calibri" pitchFamily="34" charset="0"/>
+                <a:ea typeface="Calibri" pitchFamily="34" charset="-122"/>
+                <a:cs typeface="Calibri" pitchFamily="34" charset="-120"/>
+              </a:rPr>
+              <a:t>18</a:t>
+            </a:r>
+            <a:endParaRPr lang="en-US" sz="900" dirty="0"/>
+          </a:p>
+        </p:txBody>
+      </p:sp>
+    </p:spTree>
+  </p:cSld>
+  <p:clrMapOvr>
+    <a:masterClrMapping/>
+  </p:clrMapOvr>
+</p:sld>
+</file>
+
+<file path=ppt/slides/slide19.xml><?xml version="1.0" encoding="utf-8"?>
+<p:sld xmlns:a="http://schemas.openxmlformats.org/drawingml/2006/main" xmlns:r="http://schemas.openxmlformats.org/officeDocument/2006/relationships" xmlns:p="http://schemas.openxmlformats.org/presentationml/2006/main">
   <p:cSld name="Slide 18">
     <p:bg>
       <p:bgPr>
@@ -12747,912 +13879,6 @@
                 <a:ea typeface="Calibri" pitchFamily="34" charset="-122"/>
                 <a:cs typeface="Calibri" pitchFamily="34" charset="-120"/>
               </a:rPr>
-              <a:t>18</a:t>
-            </a:r>
-            <a:endParaRPr lang="en-US" sz="900" dirty="0"/>
-          </a:p>
-        </p:txBody>
-      </p:sp>
-    </p:spTree>
-  </p:cSld>
-  <p:clrMapOvr>
-    <a:masterClrMapping/>
-  </p:clrMapOvr>
-</p:sld>
-</file>
-
-<file path=ppt/slides/slide19.xml><?xml version="1.0" encoding="utf-8"?>
-<p:sld xmlns:a="http://schemas.openxmlformats.org/drawingml/2006/main" xmlns:r="http://schemas.openxmlformats.org/officeDocument/2006/relationships" xmlns:p="http://schemas.openxmlformats.org/presentationml/2006/main">
-  <p:cSld name="Slide 19">
-    <p:bg>
-      <p:bgPr>
-        <a:solidFill>
-          <a:srgbClr val="FFFFFF"/>
-        </a:solidFill>
-      </p:bgPr>
-    </p:bg>
-    <p:spTree>
-      <p:nvGrpSpPr>
-        <p:cNvPr id="1" name=""/>
-        <p:cNvGrpSpPr/>
-        <p:nvPr/>
-      </p:nvGrpSpPr>
-      <p:grpSpPr>
-        <a:xfrm>
-          <a:off x="0" y="0"/>
-          <a:ext cx="0" cy="0"/>
-          <a:chOff x="0" y="0"/>
-          <a:chExt cx="0" cy="0"/>
-        </a:xfrm>
-      </p:grpSpPr>
-      <p:sp>
-        <p:nvSpPr>
-          <p:cNvPr id="2" name="Text 0"/>
-          <p:cNvSpPr/>
-          <p:nvPr/>
-        </p:nvSpPr>
-        <p:spPr>
-          <a:xfrm>
-            <a:off x="548640" y="457200"/>
-            <a:ext cx="9144000" cy="292608"/>
-          </a:xfrm>
-          <a:prstGeom prst="rect">
-            <a:avLst/>
-          </a:prstGeom>
-          <a:noFill/>
-          <a:ln/>
-        </p:spPr>
-        <p:txBody>
-          <a:bodyPr wrap="square" lIns="0" tIns="0" rIns="0" bIns="0" rtlCol="0" anchor="ctr"/>
-          <a:lstStyle/>
-          <a:p>
-            <a:pPr indent="0" marL="0">
-              <a:buNone/>
-            </a:pPr>
-            <a:r>
-              <a:rPr lang="en-US" sz="1250" b="1" dirty="0">
-                <a:solidFill>
-                  <a:srgbClr val="00D68F"/>
-                </a:solidFill>
-                <a:latin typeface="Calibri" pitchFamily="34" charset="0"/>
-                <a:ea typeface="Calibri" pitchFamily="34" charset="-122"/>
-                <a:cs typeface="Calibri" pitchFamily="34" charset="-120"/>
-              </a:rPr>
-              <a:t>17  </a:t>
-            </a:r>
-            <a:pPr indent="0" marL="0">
-              <a:buNone/>
-            </a:pPr>
-            <a:r>
-              <a:rPr lang="en-US" sz="1250" b="1" spc="200" kern="0" dirty="0">
-                <a:solidFill>
-                  <a:srgbClr val="00D68F"/>
-                </a:solidFill>
-                <a:latin typeface="Calibri" pitchFamily="34" charset="0"/>
-                <a:ea typeface="Calibri" pitchFamily="34" charset="-122"/>
-                <a:cs typeface="Calibri" pitchFamily="34" charset="-120"/>
-              </a:rPr>
-              <a:t>CONTA CORRENTE</a:t>
-            </a:r>
-            <a:endParaRPr lang="en-US" sz="1250" dirty="0"/>
-          </a:p>
-        </p:txBody>
-      </p:sp>
-      <p:sp>
-        <p:nvSpPr>
-          <p:cNvPr id="3" name="Text 1"/>
-          <p:cNvSpPr/>
-          <p:nvPr/>
-        </p:nvSpPr>
-        <p:spPr>
-          <a:xfrm>
-            <a:off x="548640" y="749808"/>
-            <a:ext cx="11094415" cy="640080"/>
-          </a:xfrm>
-          <a:prstGeom prst="rect">
-            <a:avLst/>
-          </a:prstGeom>
-          <a:noFill/>
-          <a:ln/>
-        </p:spPr>
-        <p:txBody>
-          <a:bodyPr wrap="square" lIns="0" tIns="0" rIns="0" bIns="0" rtlCol="0" anchor="ctr"/>
-          <a:lstStyle/>
-          <a:p>
-            <a:pPr indent="0" marL="0">
-              <a:buNone/>
-            </a:pPr>
-            <a:r>
-              <a:rPr lang="en-US" sz="3000" b="1" dirty="0">
-                <a:solidFill>
-                  <a:srgbClr val="0D1B3E"/>
-                </a:solidFill>
-                <a:latin typeface="Calibri" pitchFamily="34" charset="0"/>
-                <a:ea typeface="Calibri" pitchFamily="34" charset="-122"/>
-                <a:cs typeface="Calibri" pitchFamily="34" charset="-120"/>
-              </a:rPr>
-              <a:t>Conta corrente — o caixa das operações</a:t>
-            </a:r>
-            <a:endParaRPr lang="en-US" sz="3000" dirty="0"/>
-          </a:p>
-        </p:txBody>
-      </p:sp>
-      <p:sp>
-        <p:nvSpPr>
-          <p:cNvPr id="4" name="Text 2"/>
-          <p:cNvSpPr/>
-          <p:nvPr/>
-        </p:nvSpPr>
-        <p:spPr>
-          <a:xfrm>
-            <a:off x="548640" y="1371600"/>
-            <a:ext cx="11094415" cy="502920"/>
-          </a:xfrm>
-          <a:prstGeom prst="rect">
-            <a:avLst/>
-          </a:prstGeom>
-          <a:noFill/>
-          <a:ln/>
-        </p:spPr>
-        <p:txBody>
-          <a:bodyPr wrap="square" lIns="0" tIns="0" rIns="0" bIns="0" rtlCol="0" anchor="ctr"/>
-          <a:lstStyle/>
-          <a:p>
-            <a:pPr indent="0" marL="0">
-              <a:lnSpc>
-                <a:spcPct val="120000"/>
-              </a:lnSpc>
-              <a:buNone/>
-            </a:pPr>
-            <a:r>
-              <a:rPr lang="en-US" sz="1150" dirty="0">
-                <a:solidFill>
-                  <a:srgbClr val="40496B"/>
-                </a:solidFill>
-                <a:latin typeface="Calibri" pitchFamily="34" charset="0"/>
-                <a:ea typeface="Calibri" pitchFamily="34" charset="-122"/>
-                <a:cs typeface="Calibri" pitchFamily="34" charset="-120"/>
-              </a:rPr>
-              <a:t>Registra o saldo inicial informado manualmente, debita automaticamente a cada compra e credita automaticamente a cada venda, além de aceitar transferências manuais de e para outras contas (ex.: Nubank, a própria corretora).</a:t>
-            </a:r>
-            <a:endParaRPr lang="en-US" sz="1150" dirty="0"/>
-          </a:p>
-        </p:txBody>
-      </p:sp>
-      <p:sp>
-        <p:nvSpPr>
-          <p:cNvPr id="5" name="Shape 3"/>
-          <p:cNvSpPr/>
-          <p:nvPr/>
-        </p:nvSpPr>
-        <p:spPr>
-          <a:xfrm>
-            <a:off x="548640" y="2011680"/>
-            <a:ext cx="5364328" cy="914400"/>
-          </a:xfrm>
-          <a:prstGeom prst="roundRect">
-            <a:avLst>
-              <a:gd name="adj" fmla="val 8000"/>
-            </a:avLst>
-          </a:prstGeom>
-          <a:solidFill>
-            <a:srgbClr val="F3F6FC"/>
-          </a:solidFill>
-          <a:ln/>
-        </p:spPr>
-      </p:sp>
-      <p:sp>
-        <p:nvSpPr>
-          <p:cNvPr id="6" name="Text 4"/>
-          <p:cNvSpPr/>
-          <p:nvPr/>
-        </p:nvSpPr>
-        <p:spPr>
-          <a:xfrm>
-            <a:off x="731520" y="2084832"/>
-            <a:ext cx="4998568" cy="365760"/>
-          </a:xfrm>
-          <a:prstGeom prst="rect">
-            <a:avLst/>
-          </a:prstGeom>
-          <a:noFill/>
-          <a:ln/>
-        </p:spPr>
-        <p:txBody>
-          <a:bodyPr wrap="square" lIns="0" tIns="0" rIns="0" bIns="0" rtlCol="0" anchor="ctr"/>
-          <a:lstStyle/>
-          <a:p>
-            <a:pPr indent="0" marL="0">
-              <a:buNone/>
-            </a:pPr>
-            <a:r>
-              <a:rPr lang="en-US" sz="1500" b="1" dirty="0">
-                <a:solidFill>
-                  <a:srgbClr val="0D1B3E"/>
-                </a:solidFill>
-                <a:latin typeface="Calibri" pitchFamily="34" charset="0"/>
-                <a:ea typeface="Calibri" pitchFamily="34" charset="-122"/>
-                <a:cs typeface="Calibri" pitchFamily="34" charset="-120"/>
-              </a:rPr>
-              <a:t>Saldo inicial</a:t>
-            </a:r>
-            <a:endParaRPr lang="en-US" sz="1500" dirty="0"/>
-          </a:p>
-        </p:txBody>
-      </p:sp>
-      <p:sp>
-        <p:nvSpPr>
-          <p:cNvPr id="7" name="Text 5"/>
-          <p:cNvSpPr/>
-          <p:nvPr/>
-        </p:nvSpPr>
-        <p:spPr>
-          <a:xfrm>
-            <a:off x="731520" y="2450592"/>
-            <a:ext cx="4998568" cy="384048"/>
-          </a:xfrm>
-          <a:prstGeom prst="rect">
-            <a:avLst/>
-          </a:prstGeom>
-          <a:noFill/>
-          <a:ln/>
-        </p:spPr>
-        <p:txBody>
-          <a:bodyPr wrap="square" lIns="0" tIns="0" rIns="0" bIns="0" rtlCol="0" anchor="ctr"/>
-          <a:lstStyle/>
-          <a:p>
-            <a:pPr indent="0" marL="0">
-              <a:buNone/>
-            </a:pPr>
-            <a:r>
-              <a:rPr lang="en-US" sz="1000" dirty="0">
-                <a:solidFill>
-                  <a:srgbClr val="7C89A8"/>
-                </a:solidFill>
-                <a:latin typeface="Calibri" pitchFamily="34" charset="0"/>
-                <a:ea typeface="Calibri" pitchFamily="34" charset="-122"/>
-                <a:cs typeface="Calibri" pitchFamily="34" charset="-120"/>
-              </a:rPr>
-              <a:t>Definido no formulário, editável a qualquer momento</a:t>
-            </a:r>
-            <a:endParaRPr lang="en-US" sz="1000" dirty="0"/>
-          </a:p>
-        </p:txBody>
-      </p:sp>
-      <p:sp>
-        <p:nvSpPr>
-          <p:cNvPr id="8" name="Shape 6"/>
-          <p:cNvSpPr/>
-          <p:nvPr/>
-        </p:nvSpPr>
-        <p:spPr>
-          <a:xfrm>
-            <a:off x="6278728" y="2011680"/>
-            <a:ext cx="5364328" cy="914400"/>
-          </a:xfrm>
-          <a:prstGeom prst="roundRect">
-            <a:avLst>
-              <a:gd name="adj" fmla="val 8000"/>
-            </a:avLst>
-          </a:prstGeom>
-          <a:solidFill>
-            <a:srgbClr val="F3F6FC"/>
-          </a:solidFill>
-          <a:ln/>
-        </p:spPr>
-      </p:sp>
-      <p:sp>
-        <p:nvSpPr>
-          <p:cNvPr id="9" name="Text 7"/>
-          <p:cNvSpPr/>
-          <p:nvPr/>
-        </p:nvSpPr>
-        <p:spPr>
-          <a:xfrm>
-            <a:off x="6461608" y="2084832"/>
-            <a:ext cx="4998568" cy="365760"/>
-          </a:xfrm>
-          <a:prstGeom prst="rect">
-            <a:avLst/>
-          </a:prstGeom>
-          <a:noFill/>
-          <a:ln/>
-        </p:spPr>
-        <p:txBody>
-          <a:bodyPr wrap="square" lIns="0" tIns="0" rIns="0" bIns="0" rtlCol="0" anchor="ctr"/>
-          <a:lstStyle/>
-          <a:p>
-            <a:pPr indent="0" marL="0">
-              <a:buNone/>
-            </a:pPr>
-            <a:r>
-              <a:rPr lang="en-US" sz="1500" b="1" dirty="0">
-                <a:solidFill>
-                  <a:srgbClr val="00D68F"/>
-                </a:solidFill>
-                <a:latin typeface="Calibri" pitchFamily="34" charset="0"/>
-                <a:ea typeface="Calibri" pitchFamily="34" charset="-122"/>
-                <a:cs typeface="Calibri" pitchFamily="34" charset="-120"/>
-              </a:rPr>
-              <a:t>Saldo atual</a:t>
-            </a:r>
-            <a:endParaRPr lang="en-US" sz="1500" dirty="0"/>
-          </a:p>
-        </p:txBody>
-      </p:sp>
-      <p:sp>
-        <p:nvSpPr>
-          <p:cNvPr id="10" name="Text 8"/>
-          <p:cNvSpPr/>
-          <p:nvPr/>
-        </p:nvSpPr>
-        <p:spPr>
-          <a:xfrm>
-            <a:off x="6461608" y="2450592"/>
-            <a:ext cx="4998568" cy="384048"/>
-          </a:xfrm>
-          <a:prstGeom prst="rect">
-            <a:avLst/>
-          </a:prstGeom>
-          <a:noFill/>
-          <a:ln/>
-        </p:spPr>
-        <p:txBody>
-          <a:bodyPr wrap="square" lIns="0" tIns="0" rIns="0" bIns="0" rtlCol="0" anchor="ctr"/>
-          <a:lstStyle/>
-          <a:p>
-            <a:pPr indent="0" marL="0">
-              <a:buNone/>
-            </a:pPr>
-            <a:r>
-              <a:rPr lang="en-US" sz="1000" dirty="0">
-                <a:solidFill>
-                  <a:srgbClr val="7C89A8"/>
-                </a:solidFill>
-                <a:latin typeface="Calibri" pitchFamily="34" charset="0"/>
-                <a:ea typeface="Calibri" pitchFamily="34" charset="-122"/>
-                <a:cs typeface="Calibri" pitchFamily="34" charset="-120"/>
-              </a:rPr>
-              <a:t>Inicial + créditos − débitos, incl. transferências</a:t>
-            </a:r>
-            <a:endParaRPr lang="en-US" sz="1000" dirty="0"/>
-          </a:p>
-        </p:txBody>
-      </p:sp>
-      <p:sp>
-        <p:nvSpPr>
-          <p:cNvPr id="11" name="Shape 9"/>
-          <p:cNvSpPr/>
-          <p:nvPr/>
-        </p:nvSpPr>
-        <p:spPr>
-          <a:xfrm>
-            <a:off x="548640" y="3154680"/>
-            <a:ext cx="11094415" cy="1234440"/>
-          </a:xfrm>
-          <a:prstGeom prst="roundRect">
-            <a:avLst>
-              <a:gd name="adj" fmla="val 6667"/>
-            </a:avLst>
-          </a:prstGeom>
-          <a:solidFill>
-            <a:srgbClr val="F3F6FC"/>
-          </a:solidFill>
-          <a:ln/>
-          <a:effectLst>
-            <a:outerShdw sx="100000" sy="100000" kx="0" ky="0" algn="bl" rotWithShape="0" blurRad="101600" dist="25400" dir="5400000">
-              <a:srgbClr val="1B2A55">
-                <a:alpha val="12000"/>
-              </a:srgbClr>
-            </a:outerShdw>
-          </a:effectLst>
-        </p:spPr>
-      </p:sp>
-      <p:sp>
-        <p:nvSpPr>
-          <p:cNvPr id="12" name="Shape 10"/>
-          <p:cNvSpPr/>
-          <p:nvPr/>
-        </p:nvSpPr>
-        <p:spPr>
-          <a:xfrm>
-            <a:off x="804672" y="3392424"/>
-            <a:ext cx="310896" cy="310896"/>
-          </a:xfrm>
-          <a:prstGeom prst="ellipse">
-            <a:avLst/>
-          </a:prstGeom>
-          <a:solidFill>
-            <a:srgbClr val="0D1B3E"/>
-          </a:solidFill>
-          <a:ln/>
-        </p:spPr>
-      </p:sp>
-      <p:pic>
-        <p:nvPicPr>
-          <p:cNvPr id="13" name="Image 0" descr="C:\Users\PC ANTONIO\AppData\Roaming\Claude\scratch-workspaces\f0f5d1bc-bf72-4611-a8ea-e50e459a0a45\08c0c592-3fff-44bf-a144-086c85aaeea0\scratch-2026-09-22-98642c\icons\refresh.png">    </p:cNvPr>
-          <p:cNvPicPr>
-            <a:picLocks noChangeAspect="1"/>
-          </p:cNvPicPr>
-          <p:nvPr/>
-        </p:nvPicPr>
-        <p:blipFill>
-          <a:blip r:embed="rId1"/>
-          <a:stretch>
-            <a:fillRect/>
-          </a:stretch>
-        </p:blipFill>
-        <p:spPr>
-          <a:xfrm>
-            <a:off x="885505" y="3473257"/>
-            <a:ext cx="149230" cy="149230"/>
-          </a:xfrm>
-          <a:prstGeom prst="rect">
-            <a:avLst/>
-          </a:prstGeom>
-        </p:spPr>
-      </p:pic>
-      <p:sp>
-        <p:nvSpPr>
-          <p:cNvPr id="14" name="Text 11"/>
-          <p:cNvSpPr/>
-          <p:nvPr/>
-        </p:nvSpPr>
-        <p:spPr>
-          <a:xfrm>
-            <a:off x="1280160" y="3337560"/>
-            <a:ext cx="10134295" cy="365760"/>
-          </a:xfrm>
-          <a:prstGeom prst="rect">
-            <a:avLst/>
-          </a:prstGeom>
-          <a:noFill/>
-          <a:ln/>
-        </p:spPr>
-        <p:txBody>
-          <a:bodyPr wrap="square" lIns="0" tIns="0" rIns="0" bIns="0" rtlCol="0" anchor="ctr"/>
-          <a:lstStyle/>
-          <a:p>
-            <a:pPr indent="0" marL="0">
-              <a:buNone/>
-            </a:pPr>
-            <a:r>
-              <a:rPr lang="en-US" sz="1400" b="1" dirty="0">
-                <a:solidFill>
-                  <a:srgbClr val="0D1B3E"/>
-                </a:solidFill>
-                <a:latin typeface="Calibri" pitchFamily="34" charset="0"/>
-                <a:ea typeface="Calibri" pitchFamily="34" charset="-122"/>
-                <a:cs typeface="Calibri" pitchFamily="34" charset="-120"/>
-              </a:rPr>
-              <a:t>Débito e crédito automáticos</a:t>
-            </a:r>
-            <a:endParaRPr lang="en-US" sz="1400" dirty="0"/>
-          </a:p>
-        </p:txBody>
-      </p:sp>
-      <p:sp>
-        <p:nvSpPr>
-          <p:cNvPr id="15" name="Text 12"/>
-          <p:cNvSpPr/>
-          <p:nvPr/>
-        </p:nvSpPr>
-        <p:spPr>
-          <a:xfrm>
-            <a:off x="804672" y="3831336"/>
-            <a:ext cx="10582351" cy="393192"/>
-          </a:xfrm>
-          <a:prstGeom prst="rect">
-            <a:avLst/>
-          </a:prstGeom>
-          <a:noFill/>
-          <a:ln/>
-        </p:spPr>
-        <p:txBody>
-          <a:bodyPr wrap="square" lIns="0" tIns="0" rIns="0" bIns="0" rtlCol="0" anchor="t"/>
-          <a:lstStyle/>
-          <a:p>
-            <a:pPr indent="0" marL="0">
-              <a:lnSpc>
-                <a:spcPct val="112000"/>
-              </a:lnSpc>
-              <a:buNone/>
-            </a:pPr>
-            <a:r>
-              <a:rPr lang="en-US" sz="1050" dirty="0">
-                <a:solidFill>
-                  <a:srgbClr val="40496B"/>
-                </a:solidFill>
-                <a:latin typeface="Calibri" pitchFamily="34" charset="0"/>
-                <a:ea typeface="Calibri" pitchFamily="34" charset="-122"/>
-                <a:cs typeface="Calibri" pitchFamily="34" charset="-120"/>
-              </a:rPr>
-              <a:t>Toda compra gera um débito automático ("Compra de Nx TICKER"); toda venda gera um crédito automático líquido ("Venda de Nx TICKER"). Editar uma operação atualiza o lançamento; excluir a operação de origem exclui o lançamento junto.</a:t>
-            </a:r>
-            <a:endParaRPr lang="en-US" sz="1050" dirty="0"/>
-          </a:p>
-        </p:txBody>
-      </p:sp>
-      <p:sp>
-        <p:nvSpPr>
-          <p:cNvPr id="16" name="Shape 13"/>
-          <p:cNvSpPr/>
-          <p:nvPr/>
-        </p:nvSpPr>
-        <p:spPr>
-          <a:xfrm>
-            <a:off x="548640" y="4526280"/>
-            <a:ext cx="5364328" cy="1280160"/>
-          </a:xfrm>
-          <a:prstGeom prst="roundRect">
-            <a:avLst>
-              <a:gd name="adj" fmla="val 6429"/>
-            </a:avLst>
-          </a:prstGeom>
-          <a:solidFill>
-            <a:srgbClr val="F3F6FC"/>
-          </a:solidFill>
-          <a:ln/>
-          <a:effectLst>
-            <a:outerShdw sx="100000" sy="100000" kx="0" ky="0" algn="bl" rotWithShape="0" blurRad="101600" dist="25400" dir="5400000">
-              <a:srgbClr val="1B2A55">
-                <a:alpha val="12000"/>
-              </a:srgbClr>
-            </a:outerShdw>
-          </a:effectLst>
-        </p:spPr>
-      </p:sp>
-      <p:sp>
-        <p:nvSpPr>
-          <p:cNvPr id="17" name="Shape 14"/>
-          <p:cNvSpPr/>
-          <p:nvPr/>
-        </p:nvSpPr>
-        <p:spPr>
-          <a:xfrm>
-            <a:off x="804672" y="4764024"/>
-            <a:ext cx="310896" cy="310896"/>
-          </a:xfrm>
-          <a:prstGeom prst="ellipse">
-            <a:avLst/>
-          </a:prstGeom>
-          <a:solidFill>
-            <a:srgbClr val="00D68F"/>
-          </a:solidFill>
-          <a:ln/>
-        </p:spPr>
-      </p:sp>
-      <p:pic>
-        <p:nvPicPr>
-          <p:cNvPr id="18" name="Image 1" descr="C:\Users\PC ANTONIO\AppData\Roaming\Claude\scratch-workspaces\f0f5d1bc-bf72-4611-a8ea-e50e459a0a45\08c0c592-3fff-44bf-a144-086c85aaeea0\scratch-2026-09-22-98642c\icons\plus.png">    </p:cNvPr>
-          <p:cNvPicPr>
-            <a:picLocks noChangeAspect="1"/>
-          </p:cNvPicPr>
-          <p:nvPr/>
-        </p:nvPicPr>
-        <p:blipFill>
-          <a:blip r:embed="rId2"/>
-          <a:stretch>
-            <a:fillRect/>
-          </a:stretch>
-        </p:blipFill>
-        <p:spPr>
-          <a:xfrm>
-            <a:off x="885505" y="4844857"/>
-            <a:ext cx="149230" cy="149230"/>
-          </a:xfrm>
-          <a:prstGeom prst="rect">
-            <a:avLst/>
-          </a:prstGeom>
-        </p:spPr>
-      </p:pic>
-      <p:sp>
-        <p:nvSpPr>
-          <p:cNvPr id="19" name="Text 15"/>
-          <p:cNvSpPr/>
-          <p:nvPr/>
-        </p:nvSpPr>
-        <p:spPr>
-          <a:xfrm>
-            <a:off x="1280160" y="4709160"/>
-            <a:ext cx="4404208" cy="365760"/>
-          </a:xfrm>
-          <a:prstGeom prst="rect">
-            <a:avLst/>
-          </a:prstGeom>
-          <a:noFill/>
-          <a:ln/>
-        </p:spPr>
-        <p:txBody>
-          <a:bodyPr wrap="square" lIns="0" tIns="0" rIns="0" bIns="0" rtlCol="0" anchor="ctr"/>
-          <a:lstStyle/>
-          <a:p>
-            <a:pPr indent="0" marL="0">
-              <a:buNone/>
-            </a:pPr>
-            <a:r>
-              <a:rPr lang="en-US" sz="1350" b="1" dirty="0">
-                <a:solidFill>
-                  <a:srgbClr val="0D1B3E"/>
-                </a:solidFill>
-                <a:latin typeface="Calibri" pitchFamily="34" charset="0"/>
-                <a:ea typeface="Calibri" pitchFamily="34" charset="-122"/>
-                <a:cs typeface="Calibri" pitchFamily="34" charset="-120"/>
-              </a:rPr>
-              <a:t>Transferências manuais</a:t>
-            </a:r>
-            <a:endParaRPr lang="en-US" sz="1350" dirty="0"/>
-          </a:p>
-        </p:txBody>
-      </p:sp>
-      <p:sp>
-        <p:nvSpPr>
-          <p:cNvPr id="20" name="Text 16"/>
-          <p:cNvSpPr/>
-          <p:nvPr/>
-        </p:nvSpPr>
-        <p:spPr>
-          <a:xfrm>
-            <a:off x="804672" y="5202936"/>
-            <a:ext cx="4852264" cy="438912"/>
-          </a:xfrm>
-          <a:prstGeom prst="rect">
-            <a:avLst/>
-          </a:prstGeom>
-          <a:noFill/>
-          <a:ln/>
-        </p:spPr>
-        <p:txBody>
-          <a:bodyPr wrap="square" lIns="0" tIns="0" rIns="0" bIns="0" rtlCol="0" anchor="t"/>
-          <a:lstStyle/>
-          <a:p>
-            <a:pPr indent="0" marL="0">
-              <a:lnSpc>
-                <a:spcPct val="112000"/>
-              </a:lnSpc>
-              <a:buNone/>
-            </a:pPr>
-            <a:r>
-              <a:rPr lang="en-US" sz="1000" dirty="0">
-                <a:solidFill>
-                  <a:srgbClr val="40496B"/>
-                </a:solidFill>
-                <a:latin typeface="Calibri" pitchFamily="34" charset="0"/>
-                <a:ea typeface="Calibri" pitchFamily="34" charset="-122"/>
-                <a:cs typeface="Calibri" pitchFamily="34" charset="-120"/>
-              </a:rPr>
-              <a:t>Registra Crédito (entrada) ou Débito (saída) não ligado a compra/venda — ex.: depósito de outro banco ou saque para outra conta.</a:t>
-            </a:r>
-            <a:endParaRPr lang="en-US" sz="1000" dirty="0"/>
-          </a:p>
-        </p:txBody>
-      </p:sp>
-      <p:sp>
-        <p:nvSpPr>
-          <p:cNvPr id="21" name="Shape 17"/>
-          <p:cNvSpPr/>
-          <p:nvPr/>
-        </p:nvSpPr>
-        <p:spPr>
-          <a:xfrm>
-            <a:off x="6278728" y="4526280"/>
-            <a:ext cx="5364328" cy="1280160"/>
-          </a:xfrm>
-          <a:prstGeom prst="roundRect">
-            <a:avLst>
-              <a:gd name="adj" fmla="val 6429"/>
-            </a:avLst>
-          </a:prstGeom>
-          <a:solidFill>
-            <a:srgbClr val="F3F6FC"/>
-          </a:solidFill>
-          <a:ln/>
-          <a:effectLst>
-            <a:outerShdw sx="100000" sy="100000" kx="0" ky="0" algn="bl" rotWithShape="0" blurRad="101600" dist="25400" dir="5400000">
-              <a:srgbClr val="1B2A55">
-                <a:alpha val="12000"/>
-              </a:srgbClr>
-            </a:outerShdw>
-          </a:effectLst>
-        </p:spPr>
-      </p:sp>
-      <p:sp>
-        <p:nvSpPr>
-          <p:cNvPr id="22" name="Shape 18"/>
-          <p:cNvSpPr/>
-          <p:nvPr/>
-        </p:nvSpPr>
-        <p:spPr>
-          <a:xfrm>
-            <a:off x="6534760" y="4764024"/>
-            <a:ext cx="310896" cy="310896"/>
-          </a:xfrm>
-          <a:prstGeom prst="ellipse">
-            <a:avLst/>
-          </a:prstGeom>
-          <a:solidFill>
-            <a:srgbClr val="0D1B3E"/>
-          </a:solidFill>
-          <a:ln/>
-        </p:spPr>
-      </p:sp>
-      <p:pic>
-        <p:nvPicPr>
-          <p:cNvPr id="23" name="Image 2" descr="C:\Users\PC ANTONIO\AppData\Roaming\Claude\scratch-workspaces\f0f5d1bc-bf72-4611-a8ea-e50e459a0a45\08c0c592-3fff-44bf-a144-086c85aaeea0\scratch-2026-09-22-98642c\icons\download.png">    </p:cNvPr>
-          <p:cNvPicPr>
-            <a:picLocks noChangeAspect="1"/>
-          </p:cNvPicPr>
-          <p:nvPr/>
-        </p:nvPicPr>
-        <p:blipFill>
-          <a:blip r:embed="rId3"/>
-          <a:stretch>
-            <a:fillRect/>
-          </a:stretch>
-        </p:blipFill>
-        <p:spPr>
-          <a:xfrm>
-            <a:off x="6615593" y="4844857"/>
-            <a:ext cx="149230" cy="149230"/>
-          </a:xfrm>
-          <a:prstGeom prst="rect">
-            <a:avLst/>
-          </a:prstGeom>
-        </p:spPr>
-      </p:pic>
-      <p:sp>
-        <p:nvSpPr>
-          <p:cNvPr id="24" name="Text 19"/>
-          <p:cNvSpPr/>
-          <p:nvPr/>
-        </p:nvSpPr>
-        <p:spPr>
-          <a:xfrm>
-            <a:off x="7010248" y="4709160"/>
-            <a:ext cx="4404208" cy="365760"/>
-          </a:xfrm>
-          <a:prstGeom prst="rect">
-            <a:avLst/>
-          </a:prstGeom>
-          <a:noFill/>
-          <a:ln/>
-        </p:spPr>
-        <p:txBody>
-          <a:bodyPr wrap="square" lIns="0" tIns="0" rIns="0" bIns="0" rtlCol="0" anchor="ctr"/>
-          <a:lstStyle/>
-          <a:p>
-            <a:pPr indent="0" marL="0">
-              <a:buNone/>
-            </a:pPr>
-            <a:r>
-              <a:rPr lang="en-US" sz="1350" b="1" dirty="0">
-                <a:solidFill>
-                  <a:srgbClr val="0D1B3E"/>
-                </a:solidFill>
-                <a:latin typeface="Calibri" pitchFamily="34" charset="0"/>
-                <a:ea typeface="Calibri" pitchFamily="34" charset="-122"/>
-                <a:cs typeface="Calibri" pitchFamily="34" charset="-120"/>
-              </a:rPr>
-              <a:t>Extrato e exportação</a:t>
-            </a:r>
-            <a:endParaRPr lang="en-US" sz="1350" dirty="0"/>
-          </a:p>
-        </p:txBody>
-      </p:sp>
-      <p:sp>
-        <p:nvSpPr>
-          <p:cNvPr id="25" name="Text 20"/>
-          <p:cNvSpPr/>
-          <p:nvPr/>
-        </p:nvSpPr>
-        <p:spPr>
-          <a:xfrm>
-            <a:off x="6534760" y="5202936"/>
-            <a:ext cx="4852264" cy="438912"/>
-          </a:xfrm>
-          <a:prstGeom prst="rect">
-            <a:avLst/>
-          </a:prstGeom>
-          <a:noFill/>
-          <a:ln/>
-        </p:spPr>
-        <p:txBody>
-          <a:bodyPr wrap="square" lIns="0" tIns="0" rIns="0" bIns="0" rtlCol="0" anchor="t"/>
-          <a:lstStyle/>
-          <a:p>
-            <a:pPr indent="0" marL="0">
-              <a:lnSpc>
-                <a:spcPct val="112000"/>
-              </a:lnSpc>
-              <a:buNone/>
-            </a:pPr>
-            <a:r>
-              <a:rPr lang="en-US" sz="1000" dirty="0">
-                <a:solidFill>
-                  <a:srgbClr val="40496B"/>
-                </a:solidFill>
-                <a:latin typeface="Calibri" pitchFamily="34" charset="0"/>
-                <a:ea typeface="Calibri" pitchFamily="34" charset="-122"/>
-                <a:cs typeface="Calibri" pitchFamily="34" charset="-120"/>
-              </a:rPr>
-              <a:t>Lista todos os lançamentos com saldo acumulado por linha. Filtro por período (padrão: mês corrente) e exportação em Excel/PDF.</a:t>
-            </a:r>
-            <a:endParaRPr lang="en-US" sz="1000" dirty="0"/>
-          </a:p>
-        </p:txBody>
-      </p:sp>
-      <p:sp>
-        <p:nvSpPr>
-          <p:cNvPr id="26" name="Text 21"/>
-          <p:cNvSpPr/>
-          <p:nvPr/>
-        </p:nvSpPr>
-        <p:spPr>
-          <a:xfrm>
-            <a:off x="548640" y="6473952"/>
-            <a:ext cx="7315200" cy="274320"/>
-          </a:xfrm>
-          <a:prstGeom prst="rect">
-            <a:avLst/>
-          </a:prstGeom>
-          <a:noFill/>
-          <a:ln/>
-        </p:spPr>
-        <p:txBody>
-          <a:bodyPr wrap="square" lIns="0" tIns="0" rIns="0" bIns="0" rtlCol="0" anchor="ctr"/>
-          <a:lstStyle/>
-          <a:p>
-            <a:pPr algn="l" indent="0" marL="0">
-              <a:buNone/>
-            </a:pPr>
-            <a:r>
-              <a:rPr lang="en-US" sz="900" dirty="0">
-                <a:solidFill>
-                  <a:srgbClr val="7C89A8"/>
-                </a:solidFill>
-                <a:latin typeface="Calibri" pitchFamily="34" charset="0"/>
-                <a:ea typeface="Calibri" pitchFamily="34" charset="-122"/>
-                <a:cs typeface="Calibri" pitchFamily="34" charset="-120"/>
-              </a:rPr>
-              <a:t>BolsaTrader  ·  Manual Operacional do Sistema</a:t>
-            </a:r>
-            <a:endParaRPr lang="en-US" sz="900" dirty="0"/>
-          </a:p>
-        </p:txBody>
-      </p:sp>
-      <p:sp>
-        <p:nvSpPr>
-          <p:cNvPr id="27" name="Text 22"/>
-          <p:cNvSpPr/>
-          <p:nvPr/>
-        </p:nvSpPr>
-        <p:spPr>
-          <a:xfrm>
-            <a:off x="10728655" y="6473952"/>
-            <a:ext cx="914400" cy="274320"/>
-          </a:xfrm>
-          <a:prstGeom prst="rect">
-            <a:avLst/>
-          </a:prstGeom>
-          <a:noFill/>
-          <a:ln/>
-        </p:spPr>
-        <p:txBody>
-          <a:bodyPr wrap="square" lIns="0" tIns="0" rIns="0" bIns="0" rtlCol="0" anchor="ctr"/>
-          <a:lstStyle/>
-          <a:p>
-            <a:pPr algn="r" indent="0" marL="0">
-              <a:buNone/>
-            </a:pPr>
-            <a:r>
-              <a:rPr lang="en-US" sz="900" dirty="0">
-                <a:solidFill>
-                  <a:srgbClr val="7C89A8"/>
-                </a:solidFill>
-                <a:latin typeface="Calibri" pitchFamily="34" charset="0"/>
-                <a:ea typeface="Calibri" pitchFamily="34" charset="-122"/>
-                <a:cs typeface="Calibri" pitchFamily="34" charset="-120"/>
-              </a:rPr>
               <a:t>19</a:t>
             </a:r>
             <a:endParaRPr lang="en-US" sz="900" dirty="0"/>
@@ -14557,7 +14783,7 @@
                 <a:ea typeface="Calibri" pitchFamily="34" charset="-122"/>
                 <a:cs typeface="Calibri" pitchFamily="34" charset="-120"/>
               </a:rPr>
-              <a:t>Histórico, cotações e IFR</a:t>
+              <a:t>Histórico, cotações, IFR e registros</a:t>
             </a:r>
             <a:endParaRPr lang="en-US" sz="1350" dirty="0"/>
           </a:p>
@@ -14806,6 +15032,1818 @@
 </file>
 
 <file path=ppt/slides/slide20.xml><?xml version="1.0" encoding="utf-8"?>
+<p:sld xmlns:a="http://schemas.openxmlformats.org/drawingml/2006/main" xmlns:r="http://schemas.openxmlformats.org/officeDocument/2006/relationships" xmlns:p="http://schemas.openxmlformats.org/presentationml/2006/main">
+  <p:cSld name="Slide 19">
+    <p:bg>
+      <p:bgPr>
+        <a:solidFill>
+          <a:srgbClr val="FFFFFF"/>
+        </a:solidFill>
+      </p:bgPr>
+    </p:bg>
+    <p:spTree>
+      <p:nvGrpSpPr>
+        <p:cNvPr id="1" name=""/>
+        <p:cNvGrpSpPr/>
+        <p:nvPr/>
+      </p:nvGrpSpPr>
+      <p:grpSpPr>
+        <a:xfrm>
+          <a:off x="0" y="0"/>
+          <a:ext cx="0" cy="0"/>
+          <a:chOff x="0" y="0"/>
+          <a:chExt cx="0" cy="0"/>
+        </a:xfrm>
+      </p:grpSpPr>
+      <p:sp>
+        <p:nvSpPr>
+          <p:cNvPr id="2" name="Text 0"/>
+          <p:cNvSpPr/>
+          <p:nvPr/>
+        </p:nvSpPr>
+        <p:spPr>
+          <a:xfrm>
+            <a:off x="548640" y="457200"/>
+            <a:ext cx="9144000" cy="292608"/>
+          </a:xfrm>
+          <a:prstGeom prst="rect">
+            <a:avLst/>
+          </a:prstGeom>
+          <a:noFill/>
+          <a:ln/>
+        </p:spPr>
+        <p:txBody>
+          <a:bodyPr wrap="square" lIns="0" tIns="0" rIns="0" bIns="0" rtlCol="0" anchor="ctr"/>
+          <a:lstStyle/>
+          <a:p>
+            <a:pPr indent="0" marL="0">
+              <a:buNone/>
+            </a:pPr>
+            <a:r>
+              <a:rPr lang="en-US" sz="1250" b="1" dirty="0">
+                <a:solidFill>
+                  <a:srgbClr val="00D68F"/>
+                </a:solidFill>
+                <a:latin typeface="Calibri" pitchFamily="34" charset="0"/>
+                <a:ea typeface="Calibri" pitchFamily="34" charset="-122"/>
+                <a:cs typeface="Calibri" pitchFamily="34" charset="-120"/>
+              </a:rPr>
+              <a:t>17  </a:t>
+            </a:r>
+            <a:pPr indent="0" marL="0">
+              <a:buNone/>
+            </a:pPr>
+            <a:r>
+              <a:rPr lang="en-US" sz="1250" b="1" spc="200" kern="0" dirty="0">
+                <a:solidFill>
+                  <a:srgbClr val="00D68F"/>
+                </a:solidFill>
+                <a:latin typeface="Calibri" pitchFamily="34" charset="0"/>
+                <a:ea typeface="Calibri" pitchFamily="34" charset="-122"/>
+                <a:cs typeface="Calibri" pitchFamily="34" charset="-120"/>
+              </a:rPr>
+              <a:t>CONTA CORRENTE</a:t>
+            </a:r>
+            <a:endParaRPr lang="en-US" sz="1250" dirty="0"/>
+          </a:p>
+        </p:txBody>
+      </p:sp>
+      <p:sp>
+        <p:nvSpPr>
+          <p:cNvPr id="3" name="Text 1"/>
+          <p:cNvSpPr/>
+          <p:nvPr/>
+        </p:nvSpPr>
+        <p:spPr>
+          <a:xfrm>
+            <a:off x="548640" y="749808"/>
+            <a:ext cx="11094415" cy="640080"/>
+          </a:xfrm>
+          <a:prstGeom prst="rect">
+            <a:avLst/>
+          </a:prstGeom>
+          <a:noFill/>
+          <a:ln/>
+        </p:spPr>
+        <p:txBody>
+          <a:bodyPr wrap="square" lIns="0" tIns="0" rIns="0" bIns="0" rtlCol="0" anchor="ctr"/>
+          <a:lstStyle/>
+          <a:p>
+            <a:pPr indent="0" marL="0">
+              <a:buNone/>
+            </a:pPr>
+            <a:r>
+              <a:rPr lang="en-US" sz="3000" b="1" dirty="0">
+                <a:solidFill>
+                  <a:srgbClr val="0D1B3E"/>
+                </a:solidFill>
+                <a:latin typeface="Calibri" pitchFamily="34" charset="0"/>
+                <a:ea typeface="Calibri" pitchFamily="34" charset="-122"/>
+                <a:cs typeface="Calibri" pitchFamily="34" charset="-120"/>
+              </a:rPr>
+              <a:t>Conta corrente — o caixa das operações</a:t>
+            </a:r>
+            <a:endParaRPr lang="en-US" sz="3000" dirty="0"/>
+          </a:p>
+        </p:txBody>
+      </p:sp>
+      <p:sp>
+        <p:nvSpPr>
+          <p:cNvPr id="4" name="Text 2"/>
+          <p:cNvSpPr/>
+          <p:nvPr/>
+        </p:nvSpPr>
+        <p:spPr>
+          <a:xfrm>
+            <a:off x="548640" y="1371600"/>
+            <a:ext cx="11094415" cy="502920"/>
+          </a:xfrm>
+          <a:prstGeom prst="rect">
+            <a:avLst/>
+          </a:prstGeom>
+          <a:noFill/>
+          <a:ln/>
+        </p:spPr>
+        <p:txBody>
+          <a:bodyPr wrap="square" lIns="0" tIns="0" rIns="0" bIns="0" rtlCol="0" anchor="ctr"/>
+          <a:lstStyle/>
+          <a:p>
+            <a:pPr indent="0" marL="0">
+              <a:lnSpc>
+                <a:spcPct val="120000"/>
+              </a:lnSpc>
+              <a:buNone/>
+            </a:pPr>
+            <a:r>
+              <a:rPr lang="en-US" sz="1150" dirty="0">
+                <a:solidFill>
+                  <a:srgbClr val="40496B"/>
+                </a:solidFill>
+                <a:latin typeface="Calibri" pitchFamily="34" charset="0"/>
+                <a:ea typeface="Calibri" pitchFamily="34" charset="-122"/>
+                <a:cs typeface="Calibri" pitchFamily="34" charset="-120"/>
+              </a:rPr>
+              <a:t>Registra o saldo inicial informado manualmente, debita automaticamente a cada compra e credita automaticamente a cada venda, além de aceitar transferências manuais de e para outras contas (ex.: Nubank, a própria corretora).</a:t>
+            </a:r>
+            <a:endParaRPr lang="en-US" sz="1150" dirty="0"/>
+          </a:p>
+        </p:txBody>
+      </p:sp>
+      <p:sp>
+        <p:nvSpPr>
+          <p:cNvPr id="5" name="Shape 3"/>
+          <p:cNvSpPr/>
+          <p:nvPr/>
+        </p:nvSpPr>
+        <p:spPr>
+          <a:xfrm>
+            <a:off x="548640" y="2011680"/>
+            <a:ext cx="5364328" cy="914400"/>
+          </a:xfrm>
+          <a:prstGeom prst="roundRect">
+            <a:avLst>
+              <a:gd name="adj" fmla="val 8000"/>
+            </a:avLst>
+          </a:prstGeom>
+          <a:solidFill>
+            <a:srgbClr val="F3F6FC"/>
+          </a:solidFill>
+          <a:ln/>
+        </p:spPr>
+      </p:sp>
+      <p:sp>
+        <p:nvSpPr>
+          <p:cNvPr id="6" name="Text 4"/>
+          <p:cNvSpPr/>
+          <p:nvPr/>
+        </p:nvSpPr>
+        <p:spPr>
+          <a:xfrm>
+            <a:off x="731520" y="2084832"/>
+            <a:ext cx="4998568" cy="365760"/>
+          </a:xfrm>
+          <a:prstGeom prst="rect">
+            <a:avLst/>
+          </a:prstGeom>
+          <a:noFill/>
+          <a:ln/>
+        </p:spPr>
+        <p:txBody>
+          <a:bodyPr wrap="square" lIns="0" tIns="0" rIns="0" bIns="0" rtlCol="0" anchor="ctr"/>
+          <a:lstStyle/>
+          <a:p>
+            <a:pPr indent="0" marL="0">
+              <a:buNone/>
+            </a:pPr>
+            <a:r>
+              <a:rPr lang="en-US" sz="1500" b="1" dirty="0">
+                <a:solidFill>
+                  <a:srgbClr val="0D1B3E"/>
+                </a:solidFill>
+                <a:latin typeface="Calibri" pitchFamily="34" charset="0"/>
+                <a:ea typeface="Calibri" pitchFamily="34" charset="-122"/>
+                <a:cs typeface="Calibri" pitchFamily="34" charset="-120"/>
+              </a:rPr>
+              <a:t>Saldo inicial</a:t>
+            </a:r>
+            <a:endParaRPr lang="en-US" sz="1500" dirty="0"/>
+          </a:p>
+        </p:txBody>
+      </p:sp>
+      <p:sp>
+        <p:nvSpPr>
+          <p:cNvPr id="7" name="Text 5"/>
+          <p:cNvSpPr/>
+          <p:nvPr/>
+        </p:nvSpPr>
+        <p:spPr>
+          <a:xfrm>
+            <a:off x="731520" y="2450592"/>
+            <a:ext cx="4998568" cy="384048"/>
+          </a:xfrm>
+          <a:prstGeom prst="rect">
+            <a:avLst/>
+          </a:prstGeom>
+          <a:noFill/>
+          <a:ln/>
+        </p:spPr>
+        <p:txBody>
+          <a:bodyPr wrap="square" lIns="0" tIns="0" rIns="0" bIns="0" rtlCol="0" anchor="ctr"/>
+          <a:lstStyle/>
+          <a:p>
+            <a:pPr indent="0" marL="0">
+              <a:buNone/>
+            </a:pPr>
+            <a:r>
+              <a:rPr lang="en-US" sz="1000" dirty="0">
+                <a:solidFill>
+                  <a:srgbClr val="7C89A8"/>
+                </a:solidFill>
+                <a:latin typeface="Calibri" pitchFamily="34" charset="0"/>
+                <a:ea typeface="Calibri" pitchFamily="34" charset="-122"/>
+                <a:cs typeface="Calibri" pitchFamily="34" charset="-120"/>
+              </a:rPr>
+              <a:t>Definido no formulário, editável a qualquer momento</a:t>
+            </a:r>
+            <a:endParaRPr lang="en-US" sz="1000" dirty="0"/>
+          </a:p>
+        </p:txBody>
+      </p:sp>
+      <p:sp>
+        <p:nvSpPr>
+          <p:cNvPr id="8" name="Shape 6"/>
+          <p:cNvSpPr/>
+          <p:nvPr/>
+        </p:nvSpPr>
+        <p:spPr>
+          <a:xfrm>
+            <a:off x="6278728" y="2011680"/>
+            <a:ext cx="5364328" cy="914400"/>
+          </a:xfrm>
+          <a:prstGeom prst="roundRect">
+            <a:avLst>
+              <a:gd name="adj" fmla="val 8000"/>
+            </a:avLst>
+          </a:prstGeom>
+          <a:solidFill>
+            <a:srgbClr val="F3F6FC"/>
+          </a:solidFill>
+          <a:ln/>
+        </p:spPr>
+      </p:sp>
+      <p:sp>
+        <p:nvSpPr>
+          <p:cNvPr id="9" name="Text 7"/>
+          <p:cNvSpPr/>
+          <p:nvPr/>
+        </p:nvSpPr>
+        <p:spPr>
+          <a:xfrm>
+            <a:off x="6461608" y="2084832"/>
+            <a:ext cx="4998568" cy="365760"/>
+          </a:xfrm>
+          <a:prstGeom prst="rect">
+            <a:avLst/>
+          </a:prstGeom>
+          <a:noFill/>
+          <a:ln/>
+        </p:spPr>
+        <p:txBody>
+          <a:bodyPr wrap="square" lIns="0" tIns="0" rIns="0" bIns="0" rtlCol="0" anchor="ctr"/>
+          <a:lstStyle/>
+          <a:p>
+            <a:pPr indent="0" marL="0">
+              <a:buNone/>
+            </a:pPr>
+            <a:r>
+              <a:rPr lang="en-US" sz="1500" b="1" dirty="0">
+                <a:solidFill>
+                  <a:srgbClr val="00D68F"/>
+                </a:solidFill>
+                <a:latin typeface="Calibri" pitchFamily="34" charset="0"/>
+                <a:ea typeface="Calibri" pitchFamily="34" charset="-122"/>
+                <a:cs typeface="Calibri" pitchFamily="34" charset="-120"/>
+              </a:rPr>
+              <a:t>Saldo atual</a:t>
+            </a:r>
+            <a:endParaRPr lang="en-US" sz="1500" dirty="0"/>
+          </a:p>
+        </p:txBody>
+      </p:sp>
+      <p:sp>
+        <p:nvSpPr>
+          <p:cNvPr id="10" name="Text 8"/>
+          <p:cNvSpPr/>
+          <p:nvPr/>
+        </p:nvSpPr>
+        <p:spPr>
+          <a:xfrm>
+            <a:off x="6461608" y="2450592"/>
+            <a:ext cx="4998568" cy="384048"/>
+          </a:xfrm>
+          <a:prstGeom prst="rect">
+            <a:avLst/>
+          </a:prstGeom>
+          <a:noFill/>
+          <a:ln/>
+        </p:spPr>
+        <p:txBody>
+          <a:bodyPr wrap="square" lIns="0" tIns="0" rIns="0" bIns="0" rtlCol="0" anchor="ctr"/>
+          <a:lstStyle/>
+          <a:p>
+            <a:pPr indent="0" marL="0">
+              <a:buNone/>
+            </a:pPr>
+            <a:r>
+              <a:rPr lang="en-US" sz="1000" dirty="0">
+                <a:solidFill>
+                  <a:srgbClr val="7C89A8"/>
+                </a:solidFill>
+                <a:latin typeface="Calibri" pitchFamily="34" charset="0"/>
+                <a:ea typeface="Calibri" pitchFamily="34" charset="-122"/>
+                <a:cs typeface="Calibri" pitchFamily="34" charset="-120"/>
+              </a:rPr>
+              <a:t>Inicial + créditos − débitos, incl. transferências</a:t>
+            </a:r>
+            <a:endParaRPr lang="en-US" sz="1000" dirty="0"/>
+          </a:p>
+        </p:txBody>
+      </p:sp>
+      <p:sp>
+        <p:nvSpPr>
+          <p:cNvPr id="11" name="Shape 9"/>
+          <p:cNvSpPr/>
+          <p:nvPr/>
+        </p:nvSpPr>
+        <p:spPr>
+          <a:xfrm>
+            <a:off x="548640" y="3154680"/>
+            <a:ext cx="11094415" cy="1234440"/>
+          </a:xfrm>
+          <a:prstGeom prst="roundRect">
+            <a:avLst>
+              <a:gd name="adj" fmla="val 6667"/>
+            </a:avLst>
+          </a:prstGeom>
+          <a:solidFill>
+            <a:srgbClr val="F3F6FC"/>
+          </a:solidFill>
+          <a:ln/>
+          <a:effectLst>
+            <a:outerShdw sx="100000" sy="100000" kx="0" ky="0" algn="bl" rotWithShape="0" blurRad="101600" dist="25400" dir="5400000">
+              <a:srgbClr val="1B2A55">
+                <a:alpha val="12000"/>
+              </a:srgbClr>
+            </a:outerShdw>
+          </a:effectLst>
+        </p:spPr>
+      </p:sp>
+      <p:sp>
+        <p:nvSpPr>
+          <p:cNvPr id="12" name="Shape 10"/>
+          <p:cNvSpPr/>
+          <p:nvPr/>
+        </p:nvSpPr>
+        <p:spPr>
+          <a:xfrm>
+            <a:off x="804672" y="3392424"/>
+            <a:ext cx="310896" cy="310896"/>
+          </a:xfrm>
+          <a:prstGeom prst="ellipse">
+            <a:avLst/>
+          </a:prstGeom>
+          <a:solidFill>
+            <a:srgbClr val="0D1B3E"/>
+          </a:solidFill>
+          <a:ln/>
+        </p:spPr>
+      </p:sp>
+      <p:pic>
+        <p:nvPicPr>
+          <p:cNvPr id="13" name="Image 0" descr="C:\Users\PC ANTONIO\AppData\Roaming\Claude\scratch-workspaces\f0f5d1bc-bf72-4611-a8ea-e50e459a0a45\08c0c592-3fff-44bf-a144-086c85aaeea0\scratch-2026-09-22-98642c\icons\refresh.png">    </p:cNvPr>
+          <p:cNvPicPr>
+            <a:picLocks noChangeAspect="1"/>
+          </p:cNvPicPr>
+          <p:nvPr/>
+        </p:nvPicPr>
+        <p:blipFill>
+          <a:blip r:embed="rId1"/>
+          <a:stretch>
+            <a:fillRect/>
+          </a:stretch>
+        </p:blipFill>
+        <p:spPr>
+          <a:xfrm>
+            <a:off x="885505" y="3473257"/>
+            <a:ext cx="149230" cy="149230"/>
+          </a:xfrm>
+          <a:prstGeom prst="rect">
+            <a:avLst/>
+          </a:prstGeom>
+        </p:spPr>
+      </p:pic>
+      <p:sp>
+        <p:nvSpPr>
+          <p:cNvPr id="14" name="Text 11"/>
+          <p:cNvSpPr/>
+          <p:nvPr/>
+        </p:nvSpPr>
+        <p:spPr>
+          <a:xfrm>
+            <a:off x="1280160" y="3337560"/>
+            <a:ext cx="10134295" cy="365760"/>
+          </a:xfrm>
+          <a:prstGeom prst="rect">
+            <a:avLst/>
+          </a:prstGeom>
+          <a:noFill/>
+          <a:ln/>
+        </p:spPr>
+        <p:txBody>
+          <a:bodyPr wrap="square" lIns="0" tIns="0" rIns="0" bIns="0" rtlCol="0" anchor="ctr"/>
+          <a:lstStyle/>
+          <a:p>
+            <a:pPr indent="0" marL="0">
+              <a:buNone/>
+            </a:pPr>
+            <a:r>
+              <a:rPr lang="en-US" sz="1400" b="1" dirty="0">
+                <a:solidFill>
+                  <a:srgbClr val="0D1B3E"/>
+                </a:solidFill>
+                <a:latin typeface="Calibri" pitchFamily="34" charset="0"/>
+                <a:ea typeface="Calibri" pitchFamily="34" charset="-122"/>
+                <a:cs typeface="Calibri" pitchFamily="34" charset="-120"/>
+              </a:rPr>
+              <a:t>Débito e crédito automáticos</a:t>
+            </a:r>
+            <a:endParaRPr lang="en-US" sz="1400" dirty="0"/>
+          </a:p>
+        </p:txBody>
+      </p:sp>
+      <p:sp>
+        <p:nvSpPr>
+          <p:cNvPr id="15" name="Text 12"/>
+          <p:cNvSpPr/>
+          <p:nvPr/>
+        </p:nvSpPr>
+        <p:spPr>
+          <a:xfrm>
+            <a:off x="804672" y="3831336"/>
+            <a:ext cx="10582351" cy="393192"/>
+          </a:xfrm>
+          <a:prstGeom prst="rect">
+            <a:avLst/>
+          </a:prstGeom>
+          <a:noFill/>
+          <a:ln/>
+        </p:spPr>
+        <p:txBody>
+          <a:bodyPr wrap="square" lIns="0" tIns="0" rIns="0" bIns="0" rtlCol="0" anchor="t"/>
+          <a:lstStyle/>
+          <a:p>
+            <a:pPr indent="0" marL="0">
+              <a:lnSpc>
+                <a:spcPct val="112000"/>
+              </a:lnSpc>
+              <a:buNone/>
+            </a:pPr>
+            <a:r>
+              <a:rPr lang="en-US" sz="1050" dirty="0">
+                <a:solidFill>
+                  <a:srgbClr val="40496B"/>
+                </a:solidFill>
+                <a:latin typeface="Calibri" pitchFamily="34" charset="0"/>
+                <a:ea typeface="Calibri" pitchFamily="34" charset="-122"/>
+                <a:cs typeface="Calibri" pitchFamily="34" charset="-120"/>
+              </a:rPr>
+              <a:t>Toda compra gera um débito automático ("Compra de Nx TICKER"); toda venda gera um crédito automático líquido ("Venda de Nx TICKER"). Editar uma operação atualiza o lançamento; excluir a operação de origem exclui o lançamento junto.</a:t>
+            </a:r>
+            <a:endParaRPr lang="en-US" sz="1050" dirty="0"/>
+          </a:p>
+        </p:txBody>
+      </p:sp>
+      <p:sp>
+        <p:nvSpPr>
+          <p:cNvPr id="16" name="Shape 13"/>
+          <p:cNvSpPr/>
+          <p:nvPr/>
+        </p:nvSpPr>
+        <p:spPr>
+          <a:xfrm>
+            <a:off x="548640" y="4526280"/>
+            <a:ext cx="5364328" cy="1280160"/>
+          </a:xfrm>
+          <a:prstGeom prst="roundRect">
+            <a:avLst>
+              <a:gd name="adj" fmla="val 6429"/>
+            </a:avLst>
+          </a:prstGeom>
+          <a:solidFill>
+            <a:srgbClr val="F3F6FC"/>
+          </a:solidFill>
+          <a:ln/>
+          <a:effectLst>
+            <a:outerShdw sx="100000" sy="100000" kx="0" ky="0" algn="bl" rotWithShape="0" blurRad="101600" dist="25400" dir="5400000">
+              <a:srgbClr val="1B2A55">
+                <a:alpha val="12000"/>
+              </a:srgbClr>
+            </a:outerShdw>
+          </a:effectLst>
+        </p:spPr>
+      </p:sp>
+      <p:sp>
+        <p:nvSpPr>
+          <p:cNvPr id="17" name="Shape 14"/>
+          <p:cNvSpPr/>
+          <p:nvPr/>
+        </p:nvSpPr>
+        <p:spPr>
+          <a:xfrm>
+            <a:off x="804672" y="4764024"/>
+            <a:ext cx="310896" cy="310896"/>
+          </a:xfrm>
+          <a:prstGeom prst="ellipse">
+            <a:avLst/>
+          </a:prstGeom>
+          <a:solidFill>
+            <a:srgbClr val="00D68F"/>
+          </a:solidFill>
+          <a:ln/>
+        </p:spPr>
+      </p:sp>
+      <p:pic>
+        <p:nvPicPr>
+          <p:cNvPr id="18" name="Image 1" descr="C:\Users\PC ANTONIO\AppData\Roaming\Claude\scratch-workspaces\f0f5d1bc-bf72-4611-a8ea-e50e459a0a45\08c0c592-3fff-44bf-a144-086c85aaeea0\scratch-2026-09-22-98642c\icons\plus.png">    </p:cNvPr>
+          <p:cNvPicPr>
+            <a:picLocks noChangeAspect="1"/>
+          </p:cNvPicPr>
+          <p:nvPr/>
+        </p:nvPicPr>
+        <p:blipFill>
+          <a:blip r:embed="rId2"/>
+          <a:stretch>
+            <a:fillRect/>
+          </a:stretch>
+        </p:blipFill>
+        <p:spPr>
+          <a:xfrm>
+            <a:off x="885505" y="4844857"/>
+            <a:ext cx="149230" cy="149230"/>
+          </a:xfrm>
+          <a:prstGeom prst="rect">
+            <a:avLst/>
+          </a:prstGeom>
+        </p:spPr>
+      </p:pic>
+      <p:sp>
+        <p:nvSpPr>
+          <p:cNvPr id="19" name="Text 15"/>
+          <p:cNvSpPr/>
+          <p:nvPr/>
+        </p:nvSpPr>
+        <p:spPr>
+          <a:xfrm>
+            <a:off x="1280160" y="4709160"/>
+            <a:ext cx="4404208" cy="365760"/>
+          </a:xfrm>
+          <a:prstGeom prst="rect">
+            <a:avLst/>
+          </a:prstGeom>
+          <a:noFill/>
+          <a:ln/>
+        </p:spPr>
+        <p:txBody>
+          <a:bodyPr wrap="square" lIns="0" tIns="0" rIns="0" bIns="0" rtlCol="0" anchor="ctr"/>
+          <a:lstStyle/>
+          <a:p>
+            <a:pPr indent="0" marL="0">
+              <a:buNone/>
+            </a:pPr>
+            <a:r>
+              <a:rPr lang="en-US" sz="1350" b="1" dirty="0">
+                <a:solidFill>
+                  <a:srgbClr val="0D1B3E"/>
+                </a:solidFill>
+                <a:latin typeface="Calibri" pitchFamily="34" charset="0"/>
+                <a:ea typeface="Calibri" pitchFamily="34" charset="-122"/>
+                <a:cs typeface="Calibri" pitchFamily="34" charset="-120"/>
+              </a:rPr>
+              <a:t>Transferências manuais</a:t>
+            </a:r>
+            <a:endParaRPr lang="en-US" sz="1350" dirty="0"/>
+          </a:p>
+        </p:txBody>
+      </p:sp>
+      <p:sp>
+        <p:nvSpPr>
+          <p:cNvPr id="20" name="Text 16"/>
+          <p:cNvSpPr/>
+          <p:nvPr/>
+        </p:nvSpPr>
+        <p:spPr>
+          <a:xfrm>
+            <a:off x="804672" y="5202936"/>
+            <a:ext cx="4852264" cy="438912"/>
+          </a:xfrm>
+          <a:prstGeom prst="rect">
+            <a:avLst/>
+          </a:prstGeom>
+          <a:noFill/>
+          <a:ln/>
+        </p:spPr>
+        <p:txBody>
+          <a:bodyPr wrap="square" lIns="0" tIns="0" rIns="0" bIns="0" rtlCol="0" anchor="t"/>
+          <a:lstStyle/>
+          <a:p>
+            <a:pPr indent="0" marL="0">
+              <a:lnSpc>
+                <a:spcPct val="112000"/>
+              </a:lnSpc>
+              <a:buNone/>
+            </a:pPr>
+            <a:r>
+              <a:rPr lang="en-US" sz="1000" dirty="0">
+                <a:solidFill>
+                  <a:srgbClr val="40496B"/>
+                </a:solidFill>
+                <a:latin typeface="Calibri" pitchFamily="34" charset="0"/>
+                <a:ea typeface="Calibri" pitchFamily="34" charset="-122"/>
+                <a:cs typeface="Calibri" pitchFamily="34" charset="-120"/>
+              </a:rPr>
+              <a:t>Registra Crédito (entrada) ou Débito (saída) não ligado a compra/venda — ex.: depósito de outro banco ou saque para outra conta.</a:t>
+            </a:r>
+            <a:endParaRPr lang="en-US" sz="1000" dirty="0"/>
+          </a:p>
+        </p:txBody>
+      </p:sp>
+      <p:sp>
+        <p:nvSpPr>
+          <p:cNvPr id="21" name="Shape 17"/>
+          <p:cNvSpPr/>
+          <p:nvPr/>
+        </p:nvSpPr>
+        <p:spPr>
+          <a:xfrm>
+            <a:off x="6278728" y="4526280"/>
+            <a:ext cx="5364328" cy="1280160"/>
+          </a:xfrm>
+          <a:prstGeom prst="roundRect">
+            <a:avLst>
+              <a:gd name="adj" fmla="val 6429"/>
+            </a:avLst>
+          </a:prstGeom>
+          <a:solidFill>
+            <a:srgbClr val="F3F6FC"/>
+          </a:solidFill>
+          <a:ln/>
+          <a:effectLst>
+            <a:outerShdw sx="100000" sy="100000" kx="0" ky="0" algn="bl" rotWithShape="0" blurRad="101600" dist="25400" dir="5400000">
+              <a:srgbClr val="1B2A55">
+                <a:alpha val="12000"/>
+              </a:srgbClr>
+            </a:outerShdw>
+          </a:effectLst>
+        </p:spPr>
+      </p:sp>
+      <p:sp>
+        <p:nvSpPr>
+          <p:cNvPr id="22" name="Shape 18"/>
+          <p:cNvSpPr/>
+          <p:nvPr/>
+        </p:nvSpPr>
+        <p:spPr>
+          <a:xfrm>
+            <a:off x="6534760" y="4764024"/>
+            <a:ext cx="310896" cy="310896"/>
+          </a:xfrm>
+          <a:prstGeom prst="ellipse">
+            <a:avLst/>
+          </a:prstGeom>
+          <a:solidFill>
+            <a:srgbClr val="0D1B3E"/>
+          </a:solidFill>
+          <a:ln/>
+        </p:spPr>
+      </p:sp>
+      <p:pic>
+        <p:nvPicPr>
+          <p:cNvPr id="23" name="Image 2" descr="C:\Users\PC ANTONIO\AppData\Roaming\Claude\scratch-workspaces\f0f5d1bc-bf72-4611-a8ea-e50e459a0a45\08c0c592-3fff-44bf-a144-086c85aaeea0\scratch-2026-09-22-98642c\icons\download.png">    </p:cNvPr>
+          <p:cNvPicPr>
+            <a:picLocks noChangeAspect="1"/>
+          </p:cNvPicPr>
+          <p:nvPr/>
+        </p:nvPicPr>
+        <p:blipFill>
+          <a:blip r:embed="rId3"/>
+          <a:stretch>
+            <a:fillRect/>
+          </a:stretch>
+        </p:blipFill>
+        <p:spPr>
+          <a:xfrm>
+            <a:off x="6615593" y="4844857"/>
+            <a:ext cx="149230" cy="149230"/>
+          </a:xfrm>
+          <a:prstGeom prst="rect">
+            <a:avLst/>
+          </a:prstGeom>
+        </p:spPr>
+      </p:pic>
+      <p:sp>
+        <p:nvSpPr>
+          <p:cNvPr id="24" name="Text 19"/>
+          <p:cNvSpPr/>
+          <p:nvPr/>
+        </p:nvSpPr>
+        <p:spPr>
+          <a:xfrm>
+            <a:off x="7010248" y="4709160"/>
+            <a:ext cx="4404208" cy="365760"/>
+          </a:xfrm>
+          <a:prstGeom prst="rect">
+            <a:avLst/>
+          </a:prstGeom>
+          <a:noFill/>
+          <a:ln/>
+        </p:spPr>
+        <p:txBody>
+          <a:bodyPr wrap="square" lIns="0" tIns="0" rIns="0" bIns="0" rtlCol="0" anchor="ctr"/>
+          <a:lstStyle/>
+          <a:p>
+            <a:pPr indent="0" marL="0">
+              <a:buNone/>
+            </a:pPr>
+            <a:r>
+              <a:rPr lang="en-US" sz="1350" b="1" dirty="0">
+                <a:solidFill>
+                  <a:srgbClr val="0D1B3E"/>
+                </a:solidFill>
+                <a:latin typeface="Calibri" pitchFamily="34" charset="0"/>
+                <a:ea typeface="Calibri" pitchFamily="34" charset="-122"/>
+                <a:cs typeface="Calibri" pitchFamily="34" charset="-120"/>
+              </a:rPr>
+              <a:t>Extrato e exportação</a:t>
+            </a:r>
+            <a:endParaRPr lang="en-US" sz="1350" dirty="0"/>
+          </a:p>
+        </p:txBody>
+      </p:sp>
+      <p:sp>
+        <p:nvSpPr>
+          <p:cNvPr id="25" name="Text 20"/>
+          <p:cNvSpPr/>
+          <p:nvPr/>
+        </p:nvSpPr>
+        <p:spPr>
+          <a:xfrm>
+            <a:off x="6534760" y="5202936"/>
+            <a:ext cx="4852264" cy="438912"/>
+          </a:xfrm>
+          <a:prstGeom prst="rect">
+            <a:avLst/>
+          </a:prstGeom>
+          <a:noFill/>
+          <a:ln/>
+        </p:spPr>
+        <p:txBody>
+          <a:bodyPr wrap="square" lIns="0" tIns="0" rIns="0" bIns="0" rtlCol="0" anchor="t"/>
+          <a:lstStyle/>
+          <a:p>
+            <a:pPr indent="0" marL="0">
+              <a:lnSpc>
+                <a:spcPct val="112000"/>
+              </a:lnSpc>
+              <a:buNone/>
+            </a:pPr>
+            <a:r>
+              <a:rPr lang="en-US" sz="1000" dirty="0">
+                <a:solidFill>
+                  <a:srgbClr val="40496B"/>
+                </a:solidFill>
+                <a:latin typeface="Calibri" pitchFamily="34" charset="0"/>
+                <a:ea typeface="Calibri" pitchFamily="34" charset="-122"/>
+                <a:cs typeface="Calibri" pitchFamily="34" charset="-120"/>
+              </a:rPr>
+              <a:t>Lista todos os lançamentos com saldo acumulado por linha. Filtro por período (padrão: mês corrente) e exportação em Excel/PDF.</a:t>
+            </a:r>
+            <a:endParaRPr lang="en-US" sz="1000" dirty="0"/>
+          </a:p>
+        </p:txBody>
+      </p:sp>
+      <p:sp>
+        <p:nvSpPr>
+          <p:cNvPr id="26" name="Text 21"/>
+          <p:cNvSpPr/>
+          <p:nvPr/>
+        </p:nvSpPr>
+        <p:spPr>
+          <a:xfrm>
+            <a:off x="548640" y="6473952"/>
+            <a:ext cx="7315200" cy="274320"/>
+          </a:xfrm>
+          <a:prstGeom prst="rect">
+            <a:avLst/>
+          </a:prstGeom>
+          <a:noFill/>
+          <a:ln/>
+        </p:spPr>
+        <p:txBody>
+          <a:bodyPr wrap="square" lIns="0" tIns="0" rIns="0" bIns="0" rtlCol="0" anchor="ctr"/>
+          <a:lstStyle/>
+          <a:p>
+            <a:pPr algn="l" indent="0" marL="0">
+              <a:buNone/>
+            </a:pPr>
+            <a:r>
+              <a:rPr lang="en-US" sz="900" dirty="0">
+                <a:solidFill>
+                  <a:srgbClr val="7C89A8"/>
+                </a:solidFill>
+                <a:latin typeface="Calibri" pitchFamily="34" charset="0"/>
+                <a:ea typeface="Calibri" pitchFamily="34" charset="-122"/>
+                <a:cs typeface="Calibri" pitchFamily="34" charset="-120"/>
+              </a:rPr>
+              <a:t>BolsaTrader  ·  Manual Operacional do Sistema</a:t>
+            </a:r>
+            <a:endParaRPr lang="en-US" sz="900" dirty="0"/>
+          </a:p>
+        </p:txBody>
+      </p:sp>
+      <p:sp>
+        <p:nvSpPr>
+          <p:cNvPr id="27" name="Text 22"/>
+          <p:cNvSpPr/>
+          <p:nvPr/>
+        </p:nvSpPr>
+        <p:spPr>
+          <a:xfrm>
+            <a:off x="10728655" y="6473952"/>
+            <a:ext cx="914400" cy="274320"/>
+          </a:xfrm>
+          <a:prstGeom prst="rect">
+            <a:avLst/>
+          </a:prstGeom>
+          <a:noFill/>
+          <a:ln/>
+        </p:spPr>
+        <p:txBody>
+          <a:bodyPr wrap="square" lIns="0" tIns="0" rIns="0" bIns="0" rtlCol="0" anchor="ctr"/>
+          <a:lstStyle/>
+          <a:p>
+            <a:pPr algn="r" indent="0" marL="0">
+              <a:buNone/>
+            </a:pPr>
+            <a:r>
+              <a:rPr lang="en-US" sz="900" dirty="0">
+                <a:solidFill>
+                  <a:srgbClr val="7C89A8"/>
+                </a:solidFill>
+                <a:latin typeface="Calibri" pitchFamily="34" charset="0"/>
+                <a:ea typeface="Calibri" pitchFamily="34" charset="-122"/>
+                <a:cs typeface="Calibri" pitchFamily="34" charset="-120"/>
+              </a:rPr>
+              <a:t>20</a:t>
+            </a:r>
+            <a:endParaRPr lang="en-US" sz="900" dirty="0"/>
+          </a:p>
+        </p:txBody>
+      </p:sp>
+    </p:spTree>
+  </p:cSld>
+  <p:clrMapOvr>
+    <a:masterClrMapping/>
+  </p:clrMapOvr>
+</p:sld>
+</file>
+
+<file path=ppt/slides/slide21.xml><?xml version="1.0" encoding="utf-8"?>
+<p:sld xmlns:a="http://schemas.openxmlformats.org/drawingml/2006/main" xmlns:r="http://schemas.openxmlformats.org/officeDocument/2006/relationships" xmlns:p="http://schemas.openxmlformats.org/presentationml/2006/main">
+  <p:cSld name="Slide 19">
+    <p:bg>
+      <p:bgPr>
+        <a:solidFill>
+          <a:srgbClr val="FFFFFF"/>
+        </a:solidFill>
+      </p:bgPr>
+    </p:bg>
+    <p:spTree>
+      <p:nvGrpSpPr>
+        <p:cNvPr id="1" name=""/>
+        <p:cNvGrpSpPr/>
+        <p:nvPr/>
+      </p:nvGrpSpPr>
+      <p:grpSpPr>
+        <a:xfrm>
+          <a:off x="0" y="0"/>
+          <a:ext cx="0" cy="0"/>
+          <a:chOff x="0" y="0"/>
+          <a:chExt cx="0" cy="0"/>
+        </a:xfrm>
+      </p:grpSpPr>
+      <p:sp>
+        <p:nvSpPr>
+          <p:cNvPr id="2" name="Text 0"/>
+          <p:cNvSpPr/>
+          <p:nvPr/>
+        </p:nvSpPr>
+        <p:spPr>
+          <a:xfrm>
+            <a:off x="548640" y="457200"/>
+            <a:ext cx="9144000" cy="292608"/>
+          </a:xfrm>
+          <a:prstGeom prst="rect">
+            <a:avLst/>
+          </a:prstGeom>
+          <a:noFill/>
+          <a:ln/>
+        </p:spPr>
+        <p:txBody>
+          <a:bodyPr wrap="square" lIns="0" tIns="0" rIns="0" bIns="0" rtlCol="0" anchor="ctr"/>
+          <a:lstStyle/>
+          <a:p>
+            <a:pPr indent="0" marL="0">
+              <a:buNone/>
+            </a:pPr>
+            <a:r>
+              <a:rPr lang="en-US" sz="1250" b="1" dirty="0">
+                <a:solidFill>
+                  <a:srgbClr val="00D68F"/>
+                </a:solidFill>
+                <a:latin typeface="Calibri" pitchFamily="34" charset="0"/>
+                <a:ea typeface="Calibri" pitchFamily="34" charset="-122"/>
+                <a:cs typeface="Calibri" pitchFamily="34" charset="-120"/>
+              </a:rPr>
+              <a:t>21  </a:t>
+            </a:r>
+            <a:pPr indent="0" marL="0">
+              <a:buNone/>
+            </a:pPr>
+            <a:r>
+              <a:rPr lang="en-US" sz="1250" b="1" spc="200" kern="0" dirty="0">
+                <a:solidFill>
+                  <a:srgbClr val="00D68F"/>
+                </a:solidFill>
+                <a:latin typeface="Calibri" pitchFamily="34" charset="0"/>
+                <a:ea typeface="Calibri" pitchFamily="34" charset="-122"/>
+                <a:cs typeface="Calibri" pitchFamily="34" charset="-120"/>
+              </a:rPr>
+              <a:t>MÓDULO DE CRIPTOMOEDAS</a:t>
+            </a:r>
+            <a:endParaRPr lang="en-US" sz="1250" dirty="0"/>
+          </a:p>
+        </p:txBody>
+      </p:sp>
+      <p:sp>
+        <p:nvSpPr>
+          <p:cNvPr id="3" name="Text 1"/>
+          <p:cNvSpPr/>
+          <p:nvPr/>
+        </p:nvSpPr>
+        <p:spPr>
+          <a:xfrm>
+            <a:off x="548640" y="749808"/>
+            <a:ext cx="11094415" cy="640080"/>
+          </a:xfrm>
+          <a:prstGeom prst="rect">
+            <a:avLst/>
+          </a:prstGeom>
+          <a:noFill/>
+          <a:ln/>
+        </p:spPr>
+        <p:txBody>
+          <a:bodyPr wrap="square" lIns="0" tIns="0" rIns="0" bIns="0" rtlCol="0" anchor="ctr"/>
+          <a:lstStyle/>
+          <a:p>
+            <a:pPr indent="0" marL="0">
+              <a:buNone/>
+            </a:pPr>
+            <a:r>
+              <a:rPr lang="en-US" sz="3000" b="1" dirty="0">
+                <a:solidFill>
+                  <a:srgbClr val="0D1B3E"/>
+                </a:solidFill>
+                <a:latin typeface="Calibri" pitchFamily="34" charset="0"/>
+                <a:ea typeface="Calibri" pitchFamily="34" charset="-122"/>
+                <a:cs typeface="Calibri" pitchFamily="34" charset="-120"/>
+              </a:rPr>
+              <a:t>Criptomoedas — carteira própria, 24 horas por dia</a:t>
+            </a:r>
+            <a:endParaRPr lang="en-US" sz="3000" dirty="0"/>
+          </a:p>
+        </p:txBody>
+      </p:sp>
+      <p:sp>
+        <p:nvSpPr>
+          <p:cNvPr id="4" name="Text 2"/>
+          <p:cNvSpPr/>
+          <p:nvPr/>
+        </p:nvSpPr>
+        <p:spPr>
+          <a:xfrm>
+            <a:off x="548640" y="1371600"/>
+            <a:ext cx="11094415" cy="502920"/>
+          </a:xfrm>
+          <a:prstGeom prst="rect">
+            <a:avLst/>
+          </a:prstGeom>
+          <a:noFill/>
+          <a:ln/>
+        </p:spPr>
+        <p:txBody>
+          <a:bodyPr wrap="square" lIns="0" tIns="0" rIns="0" bIns="0" rtlCol="0" anchor="ctr"/>
+          <a:lstStyle/>
+          <a:p>
+            <a:pPr indent="0" marL="0">
+              <a:lnSpc>
+                <a:spcPct val="120000"/>
+              </a:lnSpc>
+              <a:buNone/>
+            </a:pPr>
+            <a:r>
+              <a:rPr lang="en-US" sz="1150" dirty="0">
+                <a:solidFill>
+                  <a:srgbClr val="40496B"/>
+                </a:solidFill>
+                <a:latin typeface="Calibri" pitchFamily="34" charset="0"/>
+                <a:ea typeface="Calibri" pitchFamily="34" charset="-122"/>
+                <a:cs typeface="Calibri" pitchFamily="34" charset="-120"/>
+              </a:rPr>
+              <a:t>Módulo completamente separado das ações da B3: não entra em Posições em Carteira, no robô consultor, no Scanner Técnico nem na comparação com Ibovespa/CDI. Como cripto negocia todos os dias, sem horário de pregão, cada carteira mantém sua própria lógica e seus próprios números.</a:t>
+            </a:r>
+            <a:endParaRPr lang="en-US" sz="1150" dirty="0"/>
+          </a:p>
+        </p:txBody>
+      </p:sp>
+      <p:sp>
+        <p:nvSpPr>
+          <p:cNvPr id="5" name="Shape 3"/>
+          <p:cNvSpPr/>
+          <p:nvPr/>
+        </p:nvSpPr>
+        <p:spPr>
+          <a:xfrm>
+            <a:off x="548640" y="2011680"/>
+            <a:ext cx="5364328" cy="914400"/>
+          </a:xfrm>
+          <a:prstGeom prst="roundRect">
+            <a:avLst>
+              <a:gd name="adj" fmla="val 8000"/>
+            </a:avLst>
+          </a:prstGeom>
+          <a:solidFill>
+            <a:srgbClr val="F3F6FC"/>
+          </a:solidFill>
+          <a:ln/>
+        </p:spPr>
+      </p:sp>
+      <p:sp>
+        <p:nvSpPr>
+          <p:cNvPr id="6" name="Text 4"/>
+          <p:cNvSpPr/>
+          <p:nvPr/>
+        </p:nvSpPr>
+        <p:spPr>
+          <a:xfrm>
+            <a:off x="731520" y="2084832"/>
+            <a:ext cx="4998568" cy="365760"/>
+          </a:xfrm>
+          <a:prstGeom prst="rect">
+            <a:avLst/>
+          </a:prstGeom>
+          <a:noFill/>
+          <a:ln/>
+        </p:spPr>
+        <p:txBody>
+          <a:bodyPr wrap="square" lIns="0" tIns="0" rIns="0" bIns="0" rtlCol="0" anchor="ctr"/>
+          <a:lstStyle/>
+          <a:p>
+            <a:pPr indent="0" marL="0">
+              <a:buNone/>
+            </a:pPr>
+            <a:r>
+              <a:rPr lang="en-US" sz="1500" b="1" dirty="0">
+                <a:solidFill>
+                  <a:srgbClr val="0D1B3E"/>
+                </a:solidFill>
+                <a:latin typeface="Calibri" pitchFamily="34" charset="0"/>
+                <a:ea typeface="Calibri" pitchFamily="34" charset="-122"/>
+                <a:cs typeface="Calibri" pitchFamily="34" charset="-120"/>
+              </a:rPr>
+              <a:t>Tela Criptomoedas</a:t>
+            </a:r>
+            <a:endParaRPr lang="en-US" sz="1500" dirty="0"/>
+          </a:p>
+        </p:txBody>
+      </p:sp>
+      <p:sp>
+        <p:nvSpPr>
+          <p:cNvPr id="7" name="Text 5"/>
+          <p:cNvSpPr/>
+          <p:nvPr/>
+        </p:nvSpPr>
+        <p:spPr>
+          <a:xfrm>
+            <a:off x="731520" y="2450592"/>
+            <a:ext cx="4998568" cy="384048"/>
+          </a:xfrm>
+          <a:prstGeom prst="rect">
+            <a:avLst/>
+          </a:prstGeom>
+          <a:noFill/>
+          <a:ln/>
+        </p:spPr>
+        <p:txBody>
+          <a:bodyPr wrap="square" lIns="0" tIns="0" rIns="0" bIns="0" rtlCol="0" anchor="ctr"/>
+          <a:lstStyle/>
+          <a:p>
+            <a:pPr indent="0" marL="0">
+              <a:buNone/>
+            </a:pPr>
+            <a:r>
+              <a:rPr lang="en-US" sz="1000" dirty="0">
+                <a:solidFill>
+                  <a:srgbClr val="7C89A8"/>
+                </a:solidFill>
+                <a:latin typeface="Calibri" pitchFamily="34" charset="0"/>
+                <a:ea typeface="Calibri" pitchFamily="34" charset="-122"/>
+                <a:cs typeface="Calibri" pitchFamily="34" charset="-120"/>
+              </a:rPr>
+              <a:t>Cotações, carteira e reservas em uma tela própria, acessível pelo Menu</a:t>
+            </a:r>
+            <a:endParaRPr lang="en-US" sz="1000" dirty="0"/>
+          </a:p>
+        </p:txBody>
+      </p:sp>
+      <p:sp>
+        <p:nvSpPr>
+          <p:cNvPr id="8" name="Shape 6"/>
+          <p:cNvSpPr/>
+          <p:nvPr/>
+        </p:nvSpPr>
+        <p:spPr>
+          <a:xfrm>
+            <a:off x="6278728" y="2011680"/>
+            <a:ext cx="5364328" cy="914400"/>
+          </a:xfrm>
+          <a:prstGeom prst="roundRect">
+            <a:avLst>
+              <a:gd name="adj" fmla="val 8000"/>
+            </a:avLst>
+          </a:prstGeom>
+          <a:solidFill>
+            <a:srgbClr val="F3F6FC"/>
+          </a:solidFill>
+          <a:ln/>
+        </p:spPr>
+      </p:sp>
+      <p:sp>
+        <p:nvSpPr>
+          <p:cNvPr id="9" name="Text 7"/>
+          <p:cNvSpPr/>
+          <p:nvPr/>
+        </p:nvSpPr>
+        <p:spPr>
+          <a:xfrm>
+            <a:off x="6461608" y="2084832"/>
+            <a:ext cx="4998568" cy="365760"/>
+          </a:xfrm>
+          <a:prstGeom prst="rect">
+            <a:avLst/>
+          </a:prstGeom>
+          <a:noFill/>
+          <a:ln/>
+        </p:spPr>
+        <p:txBody>
+          <a:bodyPr wrap="square" lIns="0" tIns="0" rIns="0" bIns="0" rtlCol="0" anchor="ctr"/>
+          <a:lstStyle/>
+          <a:p>
+            <a:pPr indent="0" marL="0">
+              <a:buNone/>
+            </a:pPr>
+            <a:r>
+              <a:rPr lang="en-US" sz="1500" b="1" dirty="0">
+                <a:solidFill>
+                  <a:srgbClr val="00D68F"/>
+                </a:solidFill>
+                <a:latin typeface="Calibri" pitchFamily="34" charset="0"/>
+                <a:ea typeface="Calibri" pitchFamily="34" charset="-122"/>
+                <a:cs typeface="Calibri" pitchFamily="34" charset="-120"/>
+              </a:rPr>
+              <a:t>Atualizar Cripto agora</a:t>
+            </a:r>
+            <a:endParaRPr lang="en-US" sz="1500" dirty="0"/>
+          </a:p>
+        </p:txBody>
+      </p:sp>
+      <p:sp>
+        <p:nvSpPr>
+          <p:cNvPr id="10" name="Text 8"/>
+          <p:cNvSpPr/>
+          <p:nvPr/>
+        </p:nvSpPr>
+        <p:spPr>
+          <a:xfrm>
+            <a:off x="6461608" y="2450592"/>
+            <a:ext cx="4998568" cy="384048"/>
+          </a:xfrm>
+          <a:prstGeom prst="rect">
+            <a:avLst/>
+          </a:prstGeom>
+          <a:noFill/>
+          <a:ln/>
+        </p:spPr>
+        <p:txBody>
+          <a:bodyPr wrap="square" lIns="0" tIns="0" rIns="0" bIns="0" rtlCol="0" anchor="ctr"/>
+          <a:lstStyle/>
+          <a:p>
+            <a:pPr indent="0" marL="0">
+              <a:buNone/>
+            </a:pPr>
+            <a:r>
+              <a:rPr lang="en-US" sz="1000" dirty="0">
+                <a:solidFill>
+                  <a:srgbClr val="7C89A8"/>
+                </a:solidFill>
+                <a:latin typeface="Calibri" pitchFamily="34" charset="0"/>
+                <a:ea typeface="Calibri" pitchFamily="34" charset="-122"/>
+                <a:cs typeface="Calibri" pitchFamily="34" charset="-120"/>
+              </a:rPr>
+              <a:t>Busca as cotações mais recentes e grava um novo registro, sem depender do horário de pregão da B3</a:t>
+            </a:r>
+            <a:endParaRPr lang="en-US" sz="1000" dirty="0"/>
+          </a:p>
+        </p:txBody>
+      </p:sp>
+      <p:sp>
+        <p:nvSpPr>
+          <p:cNvPr id="11" name="Shape 9"/>
+          <p:cNvSpPr/>
+          <p:nvPr/>
+        </p:nvSpPr>
+        <p:spPr>
+          <a:xfrm>
+            <a:off x="548640" y="3154680"/>
+            <a:ext cx="11094415" cy="1234440"/>
+          </a:xfrm>
+          <a:prstGeom prst="roundRect">
+            <a:avLst>
+              <a:gd name="adj" fmla="val 6667"/>
+            </a:avLst>
+          </a:prstGeom>
+          <a:solidFill>
+            <a:srgbClr val="F3F6FC"/>
+          </a:solidFill>
+          <a:ln/>
+          <a:effectLst>
+            <a:outerShdw sx="100000" sy="100000" kx="0" ky="0" algn="bl" rotWithShape="0" blurRad="101600" dist="25400" dir="5400000">
+              <a:srgbClr val="1B2A55">
+                <a:alpha val="12000"/>
+              </a:srgbClr>
+            </a:outerShdw>
+          </a:effectLst>
+        </p:spPr>
+      </p:sp>
+      <p:sp>
+        <p:nvSpPr>
+          <p:cNvPr id="12" name="Shape 10"/>
+          <p:cNvSpPr/>
+          <p:nvPr/>
+        </p:nvSpPr>
+        <p:spPr>
+          <a:xfrm>
+            <a:off x="804672" y="3392424"/>
+            <a:ext cx="310896" cy="310896"/>
+          </a:xfrm>
+          <a:prstGeom prst="ellipse">
+            <a:avLst/>
+          </a:prstGeom>
+          <a:solidFill>
+            <a:srgbClr val="0D1B3E"/>
+          </a:solidFill>
+          <a:ln/>
+        </p:spPr>
+      </p:sp>
+      <p:pic>
+        <p:nvPicPr>
+          <p:cNvPr id="13" name="Image 0" descr="C:\Users\PC ANTONIO\AppData\Roaming\Claude\scratch-workspaces\f0f5d1bc-bf72-4611-a8ea-e50e459a0a45\08c0c592-3fff-44bf-a144-086c85aaeea0\scratch-2026-09-22-98642c\icons\refresh.png">    </p:cNvPr>
+          <p:cNvPicPr>
+            <a:picLocks noChangeAspect="1"/>
+          </p:cNvPicPr>
+          <p:nvPr/>
+        </p:nvPicPr>
+        <p:blipFill>
+          <a:blip r:embed="rId1"/>
+          <a:stretch>
+            <a:fillRect/>
+          </a:stretch>
+        </p:blipFill>
+        <p:spPr>
+          <a:xfrm>
+            <a:off x="885505" y="3473257"/>
+            <a:ext cx="149230" cy="149230"/>
+          </a:xfrm>
+          <a:prstGeom prst="rect">
+            <a:avLst/>
+          </a:prstGeom>
+        </p:spPr>
+      </p:pic>
+      <p:sp>
+        <p:nvSpPr>
+          <p:cNvPr id="14" name="Text 11"/>
+          <p:cNvSpPr/>
+          <p:nvPr/>
+        </p:nvSpPr>
+        <p:spPr>
+          <a:xfrm>
+            <a:off x="1280160" y="3337560"/>
+            <a:ext cx="10134295" cy="365760"/>
+          </a:xfrm>
+          <a:prstGeom prst="rect">
+            <a:avLst/>
+          </a:prstGeom>
+          <a:noFill/>
+          <a:ln/>
+        </p:spPr>
+        <p:txBody>
+          <a:bodyPr wrap="square" lIns="0" tIns="0" rIns="0" bIns="0" rtlCol="0" anchor="ctr"/>
+          <a:lstStyle/>
+          <a:p>
+            <a:pPr indent="0" marL="0">
+              <a:buNone/>
+            </a:pPr>
+            <a:r>
+              <a:rPr lang="en-US" sz="1400" b="1" dirty="0">
+                <a:solidFill>
+                  <a:srgbClr val="0D1B3E"/>
+                </a:solidFill>
+                <a:latin typeface="Calibri" pitchFamily="34" charset="0"/>
+                <a:ea typeface="Calibri" pitchFamily="34" charset="-122"/>
+                <a:cs typeface="Calibri" pitchFamily="34" charset="-120"/>
+              </a:rPr>
+              <a:t>Registrar operações de cripto</a:t>
+            </a:r>
+            <a:endParaRPr lang="en-US" sz="1400" dirty="0"/>
+          </a:p>
+        </p:txBody>
+      </p:sp>
+      <p:sp>
+        <p:nvSpPr>
+          <p:cNvPr id="15" name="Text 12"/>
+          <p:cNvSpPr/>
+          <p:nvPr/>
+        </p:nvSpPr>
+        <p:spPr>
+          <a:xfrm>
+            <a:off x="804672" y="3831336"/>
+            <a:ext cx="10582351" cy="393192"/>
+          </a:xfrm>
+          <a:prstGeom prst="rect">
+            <a:avLst/>
+          </a:prstGeom>
+          <a:noFill/>
+          <a:ln/>
+        </p:spPr>
+        <p:txBody>
+          <a:bodyPr wrap="square" lIns="0" tIns="0" rIns="0" bIns="0" rtlCol="0" anchor="t"/>
+          <a:lstStyle/>
+          <a:p>
+            <a:pPr indent="0" marL="0">
+              <a:lnSpc>
+                <a:spcPct val="112000"/>
+              </a:lnSpc>
+              <a:buNone/>
+            </a:pPr>
+            <a:r>
+              <a:rPr lang="en-US" sz="1050" dirty="0">
+                <a:solidFill>
+                  <a:srgbClr val="40496B"/>
+                </a:solidFill>
+                <a:latin typeface="Calibri" pitchFamily="34" charset="0"/>
+                <a:ea typeface="Calibri" pitchFamily="34" charset="-122"/>
+                <a:cs typeface="Calibri" pitchFamily="34" charset="-120"/>
+              </a:rPr>
+              <a:t>Compra, venda e reserva com até 8 casas decimais de precisão e metas de lucro e perda — os mesmos recursos de editar, excluir e vender um lote parcial das ações.</a:t>
+            </a:r>
+            <a:endParaRPr lang="en-US" sz="1050" dirty="0"/>
+          </a:p>
+        </p:txBody>
+      </p:sp>
+      <p:sp>
+        <p:nvSpPr>
+          <p:cNvPr id="16" name="Shape 13"/>
+          <p:cNvSpPr/>
+          <p:nvPr/>
+        </p:nvSpPr>
+        <p:spPr>
+          <a:xfrm>
+            <a:off x="548640" y="4526280"/>
+            <a:ext cx="5364328" cy="1280160"/>
+          </a:xfrm>
+          <a:prstGeom prst="roundRect">
+            <a:avLst>
+              <a:gd name="adj" fmla="val 6429"/>
+            </a:avLst>
+          </a:prstGeom>
+          <a:solidFill>
+            <a:srgbClr val="F3F6FC"/>
+          </a:solidFill>
+          <a:ln/>
+          <a:effectLst>
+            <a:outerShdw sx="100000" sy="100000" kx="0" ky="0" algn="bl" rotWithShape="0" blurRad="101600" dist="25400" dir="5400000">
+              <a:srgbClr val="1B2A55">
+                <a:alpha val="12000"/>
+              </a:srgbClr>
+            </a:outerShdw>
+          </a:effectLst>
+        </p:spPr>
+      </p:sp>
+      <p:sp>
+        <p:nvSpPr>
+          <p:cNvPr id="17" name="Shape 14"/>
+          <p:cNvSpPr/>
+          <p:nvPr/>
+        </p:nvSpPr>
+        <p:spPr>
+          <a:xfrm>
+            <a:off x="804672" y="4764024"/>
+            <a:ext cx="310896" cy="310896"/>
+          </a:xfrm>
+          <a:prstGeom prst="ellipse">
+            <a:avLst/>
+          </a:prstGeom>
+          <a:solidFill>
+            <a:srgbClr val="00D68F"/>
+          </a:solidFill>
+          <a:ln/>
+        </p:spPr>
+      </p:sp>
+      <p:pic>
+        <p:nvPicPr>
+          <p:cNvPr id="18" name="Image 1" descr="C:\Users\PC ANTONIO\AppData\Roaming\Claude\scratch-workspaces\f0f5d1bc-bf72-4611-a8ea-e50e459a0a45\08c0c592-3fff-44bf-a144-086c85aaeea0\scratch-2026-09-22-98642c\icons\plus.png">    </p:cNvPr>
+          <p:cNvPicPr>
+            <a:picLocks noChangeAspect="1"/>
+          </p:cNvPicPr>
+          <p:nvPr/>
+        </p:nvPicPr>
+        <p:blipFill>
+          <a:blip r:embed="rId2"/>
+          <a:stretch>
+            <a:fillRect/>
+          </a:stretch>
+        </p:blipFill>
+        <p:spPr>
+          <a:xfrm>
+            <a:off x="885505" y="4844857"/>
+            <a:ext cx="149230" cy="149230"/>
+          </a:xfrm>
+          <a:prstGeom prst="rect">
+            <a:avLst/>
+          </a:prstGeom>
+        </p:spPr>
+      </p:pic>
+      <p:sp>
+        <p:nvSpPr>
+          <p:cNvPr id="19" name="Text 15"/>
+          <p:cNvSpPr/>
+          <p:nvPr/>
+        </p:nvSpPr>
+        <p:spPr>
+          <a:xfrm>
+            <a:off x="1280160" y="4709160"/>
+            <a:ext cx="4404208" cy="365760"/>
+          </a:xfrm>
+          <a:prstGeom prst="rect">
+            <a:avLst/>
+          </a:prstGeom>
+          <a:noFill/>
+          <a:ln/>
+        </p:spPr>
+        <p:txBody>
+          <a:bodyPr wrap="square" lIns="0" tIns="0" rIns="0" bIns="0" rtlCol="0" anchor="ctr"/>
+          <a:lstStyle/>
+          <a:p>
+            <a:pPr indent="0" marL="0">
+              <a:buNone/>
+            </a:pPr>
+            <a:r>
+              <a:rPr lang="en-US" sz="1350" b="1" dirty="0">
+                <a:solidFill>
+                  <a:srgbClr val="0D1B3E"/>
+                </a:solidFill>
+                <a:latin typeface="Calibri" pitchFamily="34" charset="0"/>
+                <a:ea typeface="Calibri" pitchFamily="34" charset="-122"/>
+                <a:cs typeface="Calibri" pitchFamily="34" charset="-120"/>
+              </a:rPr>
+              <a:t>Variações de hoje</a:t>
+            </a:r>
+            <a:endParaRPr lang="en-US" sz="1350" dirty="0"/>
+          </a:p>
+        </p:txBody>
+      </p:sp>
+      <p:sp>
+        <p:nvSpPr>
+          <p:cNvPr id="20" name="Text 16"/>
+          <p:cNvSpPr/>
+          <p:nvPr/>
+        </p:nvSpPr>
+        <p:spPr>
+          <a:xfrm>
+            <a:off x="804672" y="5202936"/>
+            <a:ext cx="4852264" cy="438912"/>
+          </a:xfrm>
+          <a:prstGeom prst="rect">
+            <a:avLst/>
+          </a:prstGeom>
+          <a:noFill/>
+          <a:ln/>
+        </p:spPr>
+        <p:txBody>
+          <a:bodyPr wrap="square" lIns="0" tIns="0" rIns="0" bIns="0" rtlCol="0" anchor="t"/>
+          <a:lstStyle/>
+          <a:p>
+            <a:pPr indent="0" marL="0">
+              <a:lnSpc>
+                <a:spcPct val="112000"/>
+              </a:lnSpc>
+              <a:buNone/>
+            </a:pPr>
+            <a:r>
+              <a:rPr lang="en-US" sz="1000" dirty="0">
+                <a:solidFill>
+                  <a:srgbClr val="40496B"/>
+                </a:solidFill>
+                <a:latin typeface="Calibri" pitchFamily="34" charset="0"/>
+                <a:ea typeface="Calibri" pitchFamily="34" charset="-122"/>
+                <a:cs typeface="Calibri" pitchFamily="34" charset="-120"/>
+              </a:rPr>
+              <a:t>Gráfico com o lucro/perda consolidado da carteira de cripto a cada atualização registrada no dia.</a:t>
+            </a:r>
+            <a:endParaRPr lang="en-US" sz="1000" dirty="0"/>
+          </a:p>
+        </p:txBody>
+      </p:sp>
+      <p:sp>
+        <p:nvSpPr>
+          <p:cNvPr id="21" name="Shape 17"/>
+          <p:cNvSpPr/>
+          <p:nvPr/>
+        </p:nvSpPr>
+        <p:spPr>
+          <a:xfrm>
+            <a:off x="6278728" y="4526280"/>
+            <a:ext cx="5364328" cy="1280160"/>
+          </a:xfrm>
+          <a:prstGeom prst="roundRect">
+            <a:avLst>
+              <a:gd name="adj" fmla="val 6429"/>
+            </a:avLst>
+          </a:prstGeom>
+          <a:solidFill>
+            <a:srgbClr val="F3F6FC"/>
+          </a:solidFill>
+          <a:ln/>
+          <a:effectLst>
+            <a:outerShdw sx="100000" sy="100000" kx="0" ky="0" algn="bl" rotWithShape="0" blurRad="101600" dist="25400" dir="5400000">
+              <a:srgbClr val="1B2A55">
+                <a:alpha val="12000"/>
+              </a:srgbClr>
+            </a:outerShdw>
+          </a:effectLst>
+        </p:spPr>
+      </p:sp>
+      <p:sp>
+        <p:nvSpPr>
+          <p:cNvPr id="22" name="Shape 18"/>
+          <p:cNvSpPr/>
+          <p:nvPr/>
+        </p:nvSpPr>
+        <p:spPr>
+          <a:xfrm>
+            <a:off x="6534760" y="4764024"/>
+            <a:ext cx="310896" cy="310896"/>
+          </a:xfrm>
+          <a:prstGeom prst="ellipse">
+            <a:avLst/>
+          </a:prstGeom>
+          <a:solidFill>
+            <a:srgbClr val="0D1B3E"/>
+          </a:solidFill>
+          <a:ln/>
+        </p:spPr>
+      </p:sp>
+      <p:pic>
+        <p:nvPicPr>
+          <p:cNvPr id="23" name="Image 2" descr="C:\Users\PC ANTONIO\AppData\Roaming\Claude\scratch-workspaces\f0f5d1bc-bf72-4611-a8ea-e50e459a0a45\08c0c592-3fff-44bf-a144-086c85aaeea0\scratch-2026-09-22-98642c\icons\download.png">    </p:cNvPr>
+          <p:cNvPicPr>
+            <a:picLocks noChangeAspect="1"/>
+          </p:cNvPicPr>
+          <p:nvPr/>
+        </p:nvPicPr>
+        <p:blipFill>
+          <a:blip r:embed="rId3"/>
+          <a:stretch>
+            <a:fillRect/>
+          </a:stretch>
+        </p:blipFill>
+        <p:spPr>
+          <a:xfrm>
+            <a:off x="6615593" y="4844857"/>
+            <a:ext cx="149230" cy="149230"/>
+          </a:xfrm>
+          <a:prstGeom prst="rect">
+            <a:avLst/>
+          </a:prstGeom>
+        </p:spPr>
+      </p:pic>
+      <p:sp>
+        <p:nvSpPr>
+          <p:cNvPr id="24" name="Text 19"/>
+          <p:cNvSpPr/>
+          <p:nvPr/>
+        </p:nvSpPr>
+        <p:spPr>
+          <a:xfrm>
+            <a:off x="7010248" y="4709160"/>
+            <a:ext cx="4404208" cy="365760"/>
+          </a:xfrm>
+          <a:prstGeom prst="rect">
+            <a:avLst/>
+          </a:prstGeom>
+          <a:noFill/>
+          <a:ln/>
+        </p:spPr>
+        <p:txBody>
+          <a:bodyPr wrap="square" lIns="0" tIns="0" rIns="0" bIns="0" rtlCol="0" anchor="ctr"/>
+          <a:lstStyle/>
+          <a:p>
+            <a:pPr indent="0" marL="0">
+              <a:buNone/>
+            </a:pPr>
+            <a:r>
+              <a:rPr lang="en-US" sz="1350" b="1" dirty="0">
+                <a:solidFill>
+                  <a:srgbClr val="0D1B3E"/>
+                </a:solidFill>
+                <a:latin typeface="Calibri" pitchFamily="34" charset="0"/>
+                <a:ea typeface="Calibri" pitchFamily="34" charset="-122"/>
+                <a:cs typeface="Calibri" pitchFamily="34" charset="-120"/>
+              </a:rPr>
+              <a:t>Conta Corrente e relatórios</a:t>
+            </a:r>
+            <a:endParaRPr lang="en-US" sz="1350" dirty="0"/>
+          </a:p>
+        </p:txBody>
+      </p:sp>
+      <p:sp>
+        <p:nvSpPr>
+          <p:cNvPr id="25" name="Text 20"/>
+          <p:cNvSpPr/>
+          <p:nvPr/>
+        </p:nvSpPr>
+        <p:spPr>
+          <a:xfrm>
+            <a:off x="6534760" y="5202936"/>
+            <a:ext cx="4852264" cy="438912"/>
+          </a:xfrm>
+          <a:prstGeom prst="rect">
+            <a:avLst/>
+          </a:prstGeom>
+          <a:noFill/>
+          <a:ln/>
+        </p:spPr>
+        <p:txBody>
+          <a:bodyPr wrap="square" lIns="0" tIns="0" rIns="0" bIns="0" rtlCol="0" anchor="t"/>
+          <a:lstStyle/>
+          <a:p>
+            <a:pPr indent="0" marL="0">
+              <a:lnSpc>
+                <a:spcPct val="112000"/>
+              </a:lnSpc>
+              <a:buNone/>
+            </a:pPr>
+            <a:r>
+              <a:rPr lang="en-US" sz="1000" dirty="0">
+                <a:solidFill>
+                  <a:srgbClr val="40496B"/>
+                </a:solidFill>
+                <a:latin typeface="Calibri" pitchFamily="34" charset="0"/>
+                <a:ea typeface="Calibri" pitchFamily="34" charset="-122"/>
+                <a:cs typeface="Calibri" pitchFamily="34" charset="-120"/>
+              </a:rPr>
+              <a:t>Compras e vendas lançadas automaticamente no mesmo caixa das ações, com exportação em Excel e PDF.</a:t>
+            </a:r>
+            <a:endParaRPr lang="en-US" sz="1000" dirty="0"/>
+          </a:p>
+        </p:txBody>
+      </p:sp>
+      <p:sp>
+        <p:nvSpPr>
+          <p:cNvPr id="26" name="Text 21"/>
+          <p:cNvSpPr/>
+          <p:nvPr/>
+        </p:nvSpPr>
+        <p:spPr>
+          <a:xfrm>
+            <a:off x="548640" y="6473952"/>
+            <a:ext cx="7315200" cy="274320"/>
+          </a:xfrm>
+          <a:prstGeom prst="rect">
+            <a:avLst/>
+          </a:prstGeom>
+          <a:noFill/>
+          <a:ln/>
+        </p:spPr>
+        <p:txBody>
+          <a:bodyPr wrap="square" lIns="0" tIns="0" rIns="0" bIns="0" rtlCol="0" anchor="ctr"/>
+          <a:lstStyle/>
+          <a:p>
+            <a:pPr algn="l" indent="0" marL="0">
+              <a:buNone/>
+            </a:pPr>
+            <a:r>
+              <a:rPr lang="en-US" sz="900" dirty="0">
+                <a:solidFill>
+                  <a:srgbClr val="7C89A8"/>
+                </a:solidFill>
+                <a:latin typeface="Calibri" pitchFamily="34" charset="0"/>
+                <a:ea typeface="Calibri" pitchFamily="34" charset="-122"/>
+                <a:cs typeface="Calibri" pitchFamily="34" charset="-120"/>
+              </a:rPr>
+              <a:t>BolsaTrader  ·  Manual Operacional do Sistema</a:t>
+            </a:r>
+            <a:endParaRPr lang="en-US" sz="900" dirty="0"/>
+          </a:p>
+        </p:txBody>
+      </p:sp>
+      <p:sp>
+        <p:nvSpPr>
+          <p:cNvPr id="27" name="Text 22"/>
+          <p:cNvSpPr/>
+          <p:nvPr/>
+        </p:nvSpPr>
+        <p:spPr>
+          <a:xfrm>
+            <a:off x="10728655" y="6473952"/>
+            <a:ext cx="914400" cy="274320"/>
+          </a:xfrm>
+          <a:prstGeom prst="rect">
+            <a:avLst/>
+          </a:prstGeom>
+          <a:noFill/>
+          <a:ln/>
+        </p:spPr>
+        <p:txBody>
+          <a:bodyPr wrap="square" lIns="0" tIns="0" rIns="0" bIns="0" rtlCol="0" anchor="ctr"/>
+          <a:lstStyle/>
+          <a:p>
+            <a:pPr algn="r" indent="0" marL="0">
+              <a:buNone/>
+            </a:pPr>
+            <a:r>
+              <a:rPr lang="en-US" sz="900" dirty="0">
+                <a:solidFill>
+                  <a:srgbClr val="7C89A8"/>
+                </a:solidFill>
+                <a:latin typeface="Calibri" pitchFamily="34" charset="0"/>
+                <a:ea typeface="Calibri" pitchFamily="34" charset="-122"/>
+                <a:cs typeface="Calibri" pitchFamily="34" charset="-120"/>
+              </a:rPr>
+              <a:t>21</a:t>
+            </a:r>
+            <a:endParaRPr lang="en-US" sz="900" dirty="0"/>
+          </a:p>
+        </p:txBody>
+      </p:sp>
+    </p:spTree>
+  </p:cSld>
+  <p:clrMapOvr>
+    <a:masterClrMapping/>
+  </p:clrMapOvr>
+</p:sld>
+</file>
+
+<file path=ppt/slides/slide22.xml><?xml version="1.0" encoding="utf-8"?>
 <p:sld xmlns:a="http://schemas.openxmlformats.org/drawingml/2006/main" xmlns:r="http://schemas.openxmlformats.org/officeDocument/2006/relationships" xmlns:p="http://schemas.openxmlformats.org/presentationml/2006/main">
   <p:cSld name="Slide 20">
     <p:bg>
@@ -16100,7 +18138,7 @@
                 <a:ea typeface="Calibri" pitchFamily="34" charset="-122"/>
                 <a:cs typeface="Calibri" pitchFamily="34" charset="-120"/>
               </a:rPr>
-              <a:t>21</a:t>
+              <a:t>22</a:t>
             </a:r>
             <a:endParaRPr lang="en-US" sz="900" dirty="0"/>
           </a:p>
@@ -16114,7 +18152,7 @@
 </p:sld>
 </file>
 
-<file path=ppt/slides/slide21.xml><?xml version="1.0" encoding="utf-8"?>
+<file path=ppt/slides/slide23.xml><?xml version="1.0" encoding="utf-8"?>
 <p:sld xmlns:a="http://schemas.openxmlformats.org/drawingml/2006/main" xmlns:r="http://schemas.openxmlformats.org/officeDocument/2006/relationships" xmlns:p="http://schemas.openxmlformats.org/presentationml/2006/main">
   <p:cSld name="Slide 21">
     <p:bg>
@@ -16849,7 +18887,7 @@
                 <a:ea typeface="Calibri" pitchFamily="34" charset="-122"/>
                 <a:cs typeface="Calibri" pitchFamily="34" charset="-120"/>
               </a:rPr>
-              <a:t>22</a:t>
+              <a:t>23</a:t>
             </a:r>
             <a:endParaRPr lang="en-US" sz="900" dirty="0"/>
           </a:p>
@@ -16863,7 +18901,7 @@
 </p:sld>
 </file>
 
-<file path=ppt/slides/slide22.xml><?xml version="1.0" encoding="utf-8"?>
+<file path=ppt/slides/slide24.xml><?xml version="1.0" encoding="utf-8"?>
 <p:sld xmlns:a="http://schemas.openxmlformats.org/drawingml/2006/main" xmlns:r="http://schemas.openxmlformats.org/officeDocument/2006/relationships" xmlns:p="http://schemas.openxmlformats.org/presentationml/2006/main">
   <p:cSld name="Slide 22">
     <p:bg>
@@ -16906,6 +18944,10 @@
           </a:solidFill>
           <a:ln/>
         </p:spPr>
+        <p:txBody>
+          <a:bodyPr/>
+          <a:p/>
+        </p:txBody>
       </p:sp>
       <p:sp>
         <p:nvSpPr>
@@ -16926,6 +18968,10 @@
           </a:solidFill>
           <a:ln/>
         </p:spPr>
+        <p:txBody>
+          <a:bodyPr/>
+          <a:p/>
+        </p:txBody>
       </p:sp>
       <p:sp>
         <p:nvSpPr>
@@ -16946,6 +18992,10 @@
           </a:solidFill>
           <a:ln/>
         </p:spPr>
+        <p:txBody>
+          <a:bodyPr/>
+          <a:p/>
+        </p:txBody>
       </p:sp>
       <p:pic>
         <p:nvPicPr>
@@ -17085,7 +19135,7 @@
                 <a:ea typeface="Calibri" pitchFamily="34" charset="-122"/>
                 <a:cs typeface="Calibri" pitchFamily="34" charset="-120"/>
               </a:rPr>
-              <a:t>Manual_Operacional_BolsaTrader.docx  ·  Versão 09/2026 (rev. 22/09/2026)</a:t>
+              <a:t>Manual_Operacional_BolsaTrader.docx  ·  Versão 10/2026 (rev. 09/10/2026)</a:t>
             </a:r>
             <a:endParaRPr lang="en-US" sz="1050" dirty="0"/>
           </a:p>
@@ -17163,913 +19213,7 @@
                 <a:ea typeface="Calibri" pitchFamily="34" charset="-122"/>
                 <a:cs typeface="Calibri" pitchFamily="34" charset="-120"/>
               </a:rPr>
-              <a:t>23</a:t>
-            </a:r>
-            <a:endParaRPr lang="en-US" sz="900" dirty="0"/>
-          </a:p>
-        </p:txBody>
-      </p:sp>
-    </p:spTree>
-  </p:cSld>
-  <p:clrMapOvr>
-    <a:masterClrMapping/>
-  </p:clrMapOvr>
-</p:sld>
-</file>
-
-<file path=ppt/slides/slide23.xml><?xml version="1.0" encoding="utf-8"?>
-<p:sld xmlns:a="http://schemas.openxmlformats.org/drawingml/2006/main" xmlns:r="http://schemas.openxmlformats.org/officeDocument/2006/relationships" xmlns:p="http://schemas.openxmlformats.org/presentationml/2006/main">
-  <p:cSld name="Slide 19">
-    <p:bg>
-      <p:bgPr>
-        <a:solidFill>
-          <a:srgbClr val="FFFFFF"/>
-        </a:solidFill>
-      </p:bgPr>
-    </p:bg>
-    <p:spTree>
-      <p:nvGrpSpPr>
-        <p:cNvPr id="1" name=""/>
-        <p:cNvGrpSpPr/>
-        <p:nvPr/>
-      </p:nvGrpSpPr>
-      <p:grpSpPr>
-        <a:xfrm>
-          <a:off x="0" y="0"/>
-          <a:ext cx="0" cy="0"/>
-          <a:chOff x="0" y="0"/>
-          <a:chExt cx="0" cy="0"/>
-        </a:xfrm>
-      </p:grpSpPr>
-      <p:sp>
-        <p:nvSpPr>
-          <p:cNvPr id="2" name="Text 0"/>
-          <p:cNvSpPr/>
-          <p:nvPr/>
-        </p:nvSpPr>
-        <p:spPr>
-          <a:xfrm>
-            <a:off x="548640" y="457200"/>
-            <a:ext cx="9144000" cy="292608"/>
-          </a:xfrm>
-          <a:prstGeom prst="rect">
-            <a:avLst/>
-          </a:prstGeom>
-          <a:noFill/>
-          <a:ln/>
-        </p:spPr>
-        <p:txBody>
-          <a:bodyPr wrap="square" lIns="0" tIns="0" rIns="0" bIns="0" rtlCol="0" anchor="ctr"/>
-          <a:lstStyle/>
-          <a:p>
-            <a:pPr indent="0" marL="0">
-              <a:buNone/>
-            </a:pPr>
-            <a:r>
-              <a:rPr lang="en-US" sz="1250" b="1" dirty="0">
-                <a:solidFill>
-                  <a:srgbClr val="00D68F"/>
-                </a:solidFill>
-                <a:latin typeface="Calibri" pitchFamily="34" charset="0"/>
-                <a:ea typeface="Calibri" pitchFamily="34" charset="-122"/>
-                <a:cs typeface="Calibri" pitchFamily="34" charset="-120"/>
-              </a:rPr>
-              <a:t>21  </a:t>
-            </a:r>
-            <a:pPr indent="0" marL="0">
-              <a:buNone/>
-            </a:pPr>
-            <a:r>
-              <a:rPr lang="en-US" sz="1250" b="1" spc="200" kern="0" dirty="0">
-                <a:solidFill>
-                  <a:srgbClr val="00D68F"/>
-                </a:solidFill>
-                <a:latin typeface="Calibri" pitchFamily="34" charset="0"/>
-                <a:ea typeface="Calibri" pitchFamily="34" charset="-122"/>
-                <a:cs typeface="Calibri" pitchFamily="34" charset="-120"/>
-              </a:rPr>
-              <a:t>MÓDULO DE CRIPTOMOEDAS</a:t>
-            </a:r>
-            <a:endParaRPr lang="en-US" sz="1250" dirty="0"/>
-          </a:p>
-        </p:txBody>
-      </p:sp>
-      <p:sp>
-        <p:nvSpPr>
-          <p:cNvPr id="3" name="Text 1"/>
-          <p:cNvSpPr/>
-          <p:nvPr/>
-        </p:nvSpPr>
-        <p:spPr>
-          <a:xfrm>
-            <a:off x="548640" y="749808"/>
-            <a:ext cx="11094415" cy="640080"/>
-          </a:xfrm>
-          <a:prstGeom prst="rect">
-            <a:avLst/>
-          </a:prstGeom>
-          <a:noFill/>
-          <a:ln/>
-        </p:spPr>
-        <p:txBody>
-          <a:bodyPr wrap="square" lIns="0" tIns="0" rIns="0" bIns="0" rtlCol="0" anchor="ctr"/>
-          <a:lstStyle/>
-          <a:p>
-            <a:pPr indent="0" marL="0">
-              <a:buNone/>
-            </a:pPr>
-            <a:r>
-              <a:rPr lang="en-US" sz="3000" b="1" dirty="0">
-                <a:solidFill>
-                  <a:srgbClr val="0D1B3E"/>
-                </a:solidFill>
-                <a:latin typeface="Calibri" pitchFamily="34" charset="0"/>
-                <a:ea typeface="Calibri" pitchFamily="34" charset="-122"/>
-                <a:cs typeface="Calibri" pitchFamily="34" charset="-120"/>
-              </a:rPr>
-              <a:t>Criptomoedas — carteira própria, 24 horas por dia</a:t>
-            </a:r>
-            <a:endParaRPr lang="en-US" sz="3000" dirty="0"/>
-          </a:p>
-        </p:txBody>
-      </p:sp>
-      <p:sp>
-        <p:nvSpPr>
-          <p:cNvPr id="4" name="Text 2"/>
-          <p:cNvSpPr/>
-          <p:nvPr/>
-        </p:nvSpPr>
-        <p:spPr>
-          <a:xfrm>
-            <a:off x="548640" y="1371600"/>
-            <a:ext cx="11094415" cy="502920"/>
-          </a:xfrm>
-          <a:prstGeom prst="rect">
-            <a:avLst/>
-          </a:prstGeom>
-          <a:noFill/>
-          <a:ln/>
-        </p:spPr>
-        <p:txBody>
-          <a:bodyPr wrap="square" lIns="0" tIns="0" rIns="0" bIns="0" rtlCol="0" anchor="ctr"/>
-          <a:lstStyle/>
-          <a:p>
-            <a:pPr indent="0" marL="0">
-              <a:lnSpc>
-                <a:spcPct val="120000"/>
-              </a:lnSpc>
-              <a:buNone/>
-            </a:pPr>
-            <a:r>
-              <a:rPr lang="en-US" sz="1150" dirty="0">
-                <a:solidFill>
-                  <a:srgbClr val="40496B"/>
-                </a:solidFill>
-                <a:latin typeface="Calibri" pitchFamily="34" charset="0"/>
-                <a:ea typeface="Calibri" pitchFamily="34" charset="-122"/>
-                <a:cs typeface="Calibri" pitchFamily="34" charset="-120"/>
-              </a:rPr>
-              <a:t>Módulo completamente separado das ações da B3: não entra em Posições em Carteira, no robô consultor, no Scanner Técnico nem na comparação com Ibovespa/CDI. Como cripto negocia todos os dias, sem horário de pregão, cada carteira mantém sua própria lógica e seus próprios números.</a:t>
-            </a:r>
-            <a:endParaRPr lang="en-US" sz="1150" dirty="0"/>
-          </a:p>
-        </p:txBody>
-      </p:sp>
-      <p:sp>
-        <p:nvSpPr>
-          <p:cNvPr id="5" name="Shape 3"/>
-          <p:cNvSpPr/>
-          <p:nvPr/>
-        </p:nvSpPr>
-        <p:spPr>
-          <a:xfrm>
-            <a:off x="548640" y="2011680"/>
-            <a:ext cx="5364328" cy="914400"/>
-          </a:xfrm>
-          <a:prstGeom prst="roundRect">
-            <a:avLst>
-              <a:gd name="adj" fmla="val 8000"/>
-            </a:avLst>
-          </a:prstGeom>
-          <a:solidFill>
-            <a:srgbClr val="F3F6FC"/>
-          </a:solidFill>
-          <a:ln/>
-        </p:spPr>
-      </p:sp>
-      <p:sp>
-        <p:nvSpPr>
-          <p:cNvPr id="6" name="Text 4"/>
-          <p:cNvSpPr/>
-          <p:nvPr/>
-        </p:nvSpPr>
-        <p:spPr>
-          <a:xfrm>
-            <a:off x="731520" y="2084832"/>
-            <a:ext cx="4998568" cy="365760"/>
-          </a:xfrm>
-          <a:prstGeom prst="rect">
-            <a:avLst/>
-          </a:prstGeom>
-          <a:noFill/>
-          <a:ln/>
-        </p:spPr>
-        <p:txBody>
-          <a:bodyPr wrap="square" lIns="0" tIns="0" rIns="0" bIns="0" rtlCol="0" anchor="ctr"/>
-          <a:lstStyle/>
-          <a:p>
-            <a:pPr indent="0" marL="0">
-              <a:buNone/>
-            </a:pPr>
-            <a:r>
-              <a:rPr lang="en-US" sz="1500" b="1" dirty="0">
-                <a:solidFill>
-                  <a:srgbClr val="0D1B3E"/>
-                </a:solidFill>
-                <a:latin typeface="Calibri" pitchFamily="34" charset="0"/>
-                <a:ea typeface="Calibri" pitchFamily="34" charset="-122"/>
-                <a:cs typeface="Calibri" pitchFamily="34" charset="-120"/>
-              </a:rPr>
-              <a:t>Tela Criptomoedas</a:t>
-            </a:r>
-            <a:endParaRPr lang="en-US" sz="1500" dirty="0"/>
-          </a:p>
-        </p:txBody>
-      </p:sp>
-      <p:sp>
-        <p:nvSpPr>
-          <p:cNvPr id="7" name="Text 5"/>
-          <p:cNvSpPr/>
-          <p:nvPr/>
-        </p:nvSpPr>
-        <p:spPr>
-          <a:xfrm>
-            <a:off x="731520" y="2450592"/>
-            <a:ext cx="4998568" cy="384048"/>
-          </a:xfrm>
-          <a:prstGeom prst="rect">
-            <a:avLst/>
-          </a:prstGeom>
-          <a:noFill/>
-          <a:ln/>
-        </p:spPr>
-        <p:txBody>
-          <a:bodyPr wrap="square" lIns="0" tIns="0" rIns="0" bIns="0" rtlCol="0" anchor="ctr"/>
-          <a:lstStyle/>
-          <a:p>
-            <a:pPr indent="0" marL="0">
-              <a:buNone/>
-            </a:pPr>
-            <a:r>
-              <a:rPr lang="en-US" sz="1000" dirty="0">
-                <a:solidFill>
-                  <a:srgbClr val="7C89A8"/>
-                </a:solidFill>
-                <a:latin typeface="Calibri" pitchFamily="34" charset="0"/>
-                <a:ea typeface="Calibri" pitchFamily="34" charset="-122"/>
-                <a:cs typeface="Calibri" pitchFamily="34" charset="-120"/>
-              </a:rPr>
-              <a:t>Cotações, carteira e reservas em uma tela própria, acessível pelo Menu</a:t>
-            </a:r>
-            <a:endParaRPr lang="en-US" sz="1000" dirty="0"/>
-          </a:p>
-        </p:txBody>
-      </p:sp>
-      <p:sp>
-        <p:nvSpPr>
-          <p:cNvPr id="8" name="Shape 6"/>
-          <p:cNvSpPr/>
-          <p:nvPr/>
-        </p:nvSpPr>
-        <p:spPr>
-          <a:xfrm>
-            <a:off x="6278728" y="2011680"/>
-            <a:ext cx="5364328" cy="914400"/>
-          </a:xfrm>
-          <a:prstGeom prst="roundRect">
-            <a:avLst>
-              <a:gd name="adj" fmla="val 8000"/>
-            </a:avLst>
-          </a:prstGeom>
-          <a:solidFill>
-            <a:srgbClr val="F3F6FC"/>
-          </a:solidFill>
-          <a:ln/>
-        </p:spPr>
-      </p:sp>
-      <p:sp>
-        <p:nvSpPr>
-          <p:cNvPr id="9" name="Text 7"/>
-          <p:cNvSpPr/>
-          <p:nvPr/>
-        </p:nvSpPr>
-        <p:spPr>
-          <a:xfrm>
-            <a:off x="6461608" y="2084832"/>
-            <a:ext cx="4998568" cy="365760"/>
-          </a:xfrm>
-          <a:prstGeom prst="rect">
-            <a:avLst/>
-          </a:prstGeom>
-          <a:noFill/>
-          <a:ln/>
-        </p:spPr>
-        <p:txBody>
-          <a:bodyPr wrap="square" lIns="0" tIns="0" rIns="0" bIns="0" rtlCol="0" anchor="ctr"/>
-          <a:lstStyle/>
-          <a:p>
-            <a:pPr indent="0" marL="0">
-              <a:buNone/>
-            </a:pPr>
-            <a:r>
-              <a:rPr lang="en-US" sz="1500" b="1" dirty="0">
-                <a:solidFill>
-                  <a:srgbClr val="00D68F"/>
-                </a:solidFill>
-                <a:latin typeface="Calibri" pitchFamily="34" charset="0"/>
-                <a:ea typeface="Calibri" pitchFamily="34" charset="-122"/>
-                <a:cs typeface="Calibri" pitchFamily="34" charset="-120"/>
-              </a:rPr>
-              <a:t>Atualizar Cripto agora</a:t>
-            </a:r>
-            <a:endParaRPr lang="en-US" sz="1500" dirty="0"/>
-          </a:p>
-        </p:txBody>
-      </p:sp>
-      <p:sp>
-        <p:nvSpPr>
-          <p:cNvPr id="10" name="Text 8"/>
-          <p:cNvSpPr/>
-          <p:nvPr/>
-        </p:nvSpPr>
-        <p:spPr>
-          <a:xfrm>
-            <a:off x="6461608" y="2450592"/>
-            <a:ext cx="4998568" cy="384048"/>
-          </a:xfrm>
-          <a:prstGeom prst="rect">
-            <a:avLst/>
-          </a:prstGeom>
-          <a:noFill/>
-          <a:ln/>
-        </p:spPr>
-        <p:txBody>
-          <a:bodyPr wrap="square" lIns="0" tIns="0" rIns="0" bIns="0" rtlCol="0" anchor="ctr"/>
-          <a:lstStyle/>
-          <a:p>
-            <a:pPr indent="0" marL="0">
-              <a:buNone/>
-            </a:pPr>
-            <a:r>
-              <a:rPr lang="en-US" sz="1000" dirty="0">
-                <a:solidFill>
-                  <a:srgbClr val="7C89A8"/>
-                </a:solidFill>
-                <a:latin typeface="Calibri" pitchFamily="34" charset="0"/>
-                <a:ea typeface="Calibri" pitchFamily="34" charset="-122"/>
-                <a:cs typeface="Calibri" pitchFamily="34" charset="-120"/>
-              </a:rPr>
-              <a:t>Busca as cotações mais recentes e grava um novo registro, sem depender do horário de pregão da B3</a:t>
-            </a:r>
-            <a:endParaRPr lang="en-US" sz="1000" dirty="0"/>
-          </a:p>
-        </p:txBody>
-      </p:sp>
-      <p:sp>
-        <p:nvSpPr>
-          <p:cNvPr id="11" name="Shape 9"/>
-          <p:cNvSpPr/>
-          <p:nvPr/>
-        </p:nvSpPr>
-        <p:spPr>
-          <a:xfrm>
-            <a:off x="548640" y="3154680"/>
-            <a:ext cx="11094415" cy="1234440"/>
-          </a:xfrm>
-          <a:prstGeom prst="roundRect">
-            <a:avLst>
-              <a:gd name="adj" fmla="val 6667"/>
-            </a:avLst>
-          </a:prstGeom>
-          <a:solidFill>
-            <a:srgbClr val="F3F6FC"/>
-          </a:solidFill>
-          <a:ln/>
-          <a:effectLst>
-            <a:outerShdw sx="100000" sy="100000" kx="0" ky="0" algn="bl" rotWithShape="0" blurRad="101600" dist="25400" dir="5400000">
-              <a:srgbClr val="1B2A55">
-                <a:alpha val="12000"/>
-              </a:srgbClr>
-            </a:outerShdw>
-          </a:effectLst>
-        </p:spPr>
-      </p:sp>
-      <p:sp>
-        <p:nvSpPr>
-          <p:cNvPr id="12" name="Shape 10"/>
-          <p:cNvSpPr/>
-          <p:nvPr/>
-        </p:nvSpPr>
-        <p:spPr>
-          <a:xfrm>
-            <a:off x="804672" y="3392424"/>
-            <a:ext cx="310896" cy="310896"/>
-          </a:xfrm>
-          <a:prstGeom prst="ellipse">
-            <a:avLst/>
-          </a:prstGeom>
-          <a:solidFill>
-            <a:srgbClr val="0D1B3E"/>
-          </a:solidFill>
-          <a:ln/>
-        </p:spPr>
-      </p:sp>
-      <p:pic>
-        <p:nvPicPr>
-          <p:cNvPr id="13" name="Image 0" descr="C:\Users\PC ANTONIO\AppData\Roaming\Claude\scratch-workspaces\f0f5d1bc-bf72-4611-a8ea-e50e459a0a45\08c0c592-3fff-44bf-a144-086c85aaeea0\scratch-2026-09-22-98642c\icons\refresh.png">    </p:cNvPr>
-          <p:cNvPicPr>
-            <a:picLocks noChangeAspect="1"/>
-          </p:cNvPicPr>
-          <p:nvPr/>
-        </p:nvPicPr>
-        <p:blipFill>
-          <a:blip r:embed="rId1"/>
-          <a:stretch>
-            <a:fillRect/>
-          </a:stretch>
-        </p:blipFill>
-        <p:spPr>
-          <a:xfrm>
-            <a:off x="885505" y="3473257"/>
-            <a:ext cx="149230" cy="149230"/>
-          </a:xfrm>
-          <a:prstGeom prst="rect">
-            <a:avLst/>
-          </a:prstGeom>
-        </p:spPr>
-      </p:pic>
-      <p:sp>
-        <p:nvSpPr>
-          <p:cNvPr id="14" name="Text 11"/>
-          <p:cNvSpPr/>
-          <p:nvPr/>
-        </p:nvSpPr>
-        <p:spPr>
-          <a:xfrm>
-            <a:off x="1280160" y="3337560"/>
-            <a:ext cx="10134295" cy="365760"/>
-          </a:xfrm>
-          <a:prstGeom prst="rect">
-            <a:avLst/>
-          </a:prstGeom>
-          <a:noFill/>
-          <a:ln/>
-        </p:spPr>
-        <p:txBody>
-          <a:bodyPr wrap="square" lIns="0" tIns="0" rIns="0" bIns="0" rtlCol="0" anchor="ctr"/>
-          <a:lstStyle/>
-          <a:p>
-            <a:pPr indent="0" marL="0">
-              <a:buNone/>
-            </a:pPr>
-            <a:r>
-              <a:rPr lang="en-US" sz="1400" b="1" dirty="0">
-                <a:solidFill>
-                  <a:srgbClr val="0D1B3E"/>
-                </a:solidFill>
-                <a:latin typeface="Calibri" pitchFamily="34" charset="0"/>
-                <a:ea typeface="Calibri" pitchFamily="34" charset="-122"/>
-                <a:cs typeface="Calibri" pitchFamily="34" charset="-120"/>
-              </a:rPr>
-              <a:t>Registrar operações de cripto</a:t>
-            </a:r>
-            <a:endParaRPr lang="en-US" sz="1400" dirty="0"/>
-          </a:p>
-        </p:txBody>
-      </p:sp>
-      <p:sp>
-        <p:nvSpPr>
-          <p:cNvPr id="15" name="Text 12"/>
-          <p:cNvSpPr/>
-          <p:nvPr/>
-        </p:nvSpPr>
-        <p:spPr>
-          <a:xfrm>
-            <a:off x="804672" y="3831336"/>
-            <a:ext cx="10582351" cy="393192"/>
-          </a:xfrm>
-          <a:prstGeom prst="rect">
-            <a:avLst/>
-          </a:prstGeom>
-          <a:noFill/>
-          <a:ln/>
-        </p:spPr>
-        <p:txBody>
-          <a:bodyPr wrap="square" lIns="0" tIns="0" rIns="0" bIns="0" rtlCol="0" anchor="t"/>
-          <a:lstStyle/>
-          <a:p>
-            <a:pPr indent="0" marL="0">
-              <a:lnSpc>
-                <a:spcPct val="112000"/>
-              </a:lnSpc>
-              <a:buNone/>
-            </a:pPr>
-            <a:r>
-              <a:rPr lang="en-US" sz="1050" dirty="0">
-                <a:solidFill>
-                  <a:srgbClr val="40496B"/>
-                </a:solidFill>
-                <a:latin typeface="Calibri" pitchFamily="34" charset="0"/>
-                <a:ea typeface="Calibri" pitchFamily="34" charset="-122"/>
-                <a:cs typeface="Calibri" pitchFamily="34" charset="-120"/>
-              </a:rPr>
-              <a:t>Compra, venda e reserva com até 8 casas decimais de precisão e metas de lucro e perda — os mesmos recursos de editar, excluir e vender um lote parcial das ações.</a:t>
-            </a:r>
-            <a:endParaRPr lang="en-US" sz="1050" dirty="0"/>
-          </a:p>
-        </p:txBody>
-      </p:sp>
-      <p:sp>
-        <p:nvSpPr>
-          <p:cNvPr id="16" name="Shape 13"/>
-          <p:cNvSpPr/>
-          <p:nvPr/>
-        </p:nvSpPr>
-        <p:spPr>
-          <a:xfrm>
-            <a:off x="548640" y="4526280"/>
-            <a:ext cx="5364328" cy="1280160"/>
-          </a:xfrm>
-          <a:prstGeom prst="roundRect">
-            <a:avLst>
-              <a:gd name="adj" fmla="val 6429"/>
-            </a:avLst>
-          </a:prstGeom>
-          <a:solidFill>
-            <a:srgbClr val="F3F6FC"/>
-          </a:solidFill>
-          <a:ln/>
-          <a:effectLst>
-            <a:outerShdw sx="100000" sy="100000" kx="0" ky="0" algn="bl" rotWithShape="0" blurRad="101600" dist="25400" dir="5400000">
-              <a:srgbClr val="1B2A55">
-                <a:alpha val="12000"/>
-              </a:srgbClr>
-            </a:outerShdw>
-          </a:effectLst>
-        </p:spPr>
-      </p:sp>
-      <p:sp>
-        <p:nvSpPr>
-          <p:cNvPr id="17" name="Shape 14"/>
-          <p:cNvSpPr/>
-          <p:nvPr/>
-        </p:nvSpPr>
-        <p:spPr>
-          <a:xfrm>
-            <a:off x="804672" y="4764024"/>
-            <a:ext cx="310896" cy="310896"/>
-          </a:xfrm>
-          <a:prstGeom prst="ellipse">
-            <a:avLst/>
-          </a:prstGeom>
-          <a:solidFill>
-            <a:srgbClr val="00D68F"/>
-          </a:solidFill>
-          <a:ln/>
-        </p:spPr>
-      </p:sp>
-      <p:pic>
-        <p:nvPicPr>
-          <p:cNvPr id="18" name="Image 1" descr="C:\Users\PC ANTONIO\AppData\Roaming\Claude\scratch-workspaces\f0f5d1bc-bf72-4611-a8ea-e50e459a0a45\08c0c592-3fff-44bf-a144-086c85aaeea0\scratch-2026-09-22-98642c\icons\plus.png">    </p:cNvPr>
-          <p:cNvPicPr>
-            <a:picLocks noChangeAspect="1"/>
-          </p:cNvPicPr>
-          <p:nvPr/>
-        </p:nvPicPr>
-        <p:blipFill>
-          <a:blip r:embed="rId2"/>
-          <a:stretch>
-            <a:fillRect/>
-          </a:stretch>
-        </p:blipFill>
-        <p:spPr>
-          <a:xfrm>
-            <a:off x="885505" y="4844857"/>
-            <a:ext cx="149230" cy="149230"/>
-          </a:xfrm>
-          <a:prstGeom prst="rect">
-            <a:avLst/>
-          </a:prstGeom>
-        </p:spPr>
-      </p:pic>
-      <p:sp>
-        <p:nvSpPr>
-          <p:cNvPr id="19" name="Text 15"/>
-          <p:cNvSpPr/>
-          <p:nvPr/>
-        </p:nvSpPr>
-        <p:spPr>
-          <a:xfrm>
-            <a:off x="1280160" y="4709160"/>
-            <a:ext cx="4404208" cy="365760"/>
-          </a:xfrm>
-          <a:prstGeom prst="rect">
-            <a:avLst/>
-          </a:prstGeom>
-          <a:noFill/>
-          <a:ln/>
-        </p:spPr>
-        <p:txBody>
-          <a:bodyPr wrap="square" lIns="0" tIns="0" rIns="0" bIns="0" rtlCol="0" anchor="ctr"/>
-          <a:lstStyle/>
-          <a:p>
-            <a:pPr indent="0" marL="0">
-              <a:buNone/>
-            </a:pPr>
-            <a:r>
-              <a:rPr lang="en-US" sz="1350" b="1" dirty="0">
-                <a:solidFill>
-                  <a:srgbClr val="0D1B3E"/>
-                </a:solidFill>
-                <a:latin typeface="Calibri" pitchFamily="34" charset="0"/>
-                <a:ea typeface="Calibri" pitchFamily="34" charset="-122"/>
-                <a:cs typeface="Calibri" pitchFamily="34" charset="-120"/>
-              </a:rPr>
-              <a:t>Variações de hoje</a:t>
-            </a:r>
-            <a:endParaRPr lang="en-US" sz="1350" dirty="0"/>
-          </a:p>
-        </p:txBody>
-      </p:sp>
-      <p:sp>
-        <p:nvSpPr>
-          <p:cNvPr id="20" name="Text 16"/>
-          <p:cNvSpPr/>
-          <p:nvPr/>
-        </p:nvSpPr>
-        <p:spPr>
-          <a:xfrm>
-            <a:off x="804672" y="5202936"/>
-            <a:ext cx="4852264" cy="438912"/>
-          </a:xfrm>
-          <a:prstGeom prst="rect">
-            <a:avLst/>
-          </a:prstGeom>
-          <a:noFill/>
-          <a:ln/>
-        </p:spPr>
-        <p:txBody>
-          <a:bodyPr wrap="square" lIns="0" tIns="0" rIns="0" bIns="0" rtlCol="0" anchor="t"/>
-          <a:lstStyle/>
-          <a:p>
-            <a:pPr indent="0" marL="0">
-              <a:lnSpc>
-                <a:spcPct val="112000"/>
-              </a:lnSpc>
-              <a:buNone/>
-            </a:pPr>
-            <a:r>
-              <a:rPr lang="en-US" sz="1000" dirty="0">
-                <a:solidFill>
-                  <a:srgbClr val="40496B"/>
-                </a:solidFill>
-                <a:latin typeface="Calibri" pitchFamily="34" charset="0"/>
-                <a:ea typeface="Calibri" pitchFamily="34" charset="-122"/>
-                <a:cs typeface="Calibri" pitchFamily="34" charset="-120"/>
-              </a:rPr>
-              <a:t>Gráfico com o lucro/perda consolidado da carteira de cripto a cada atualização registrada no dia.</a:t>
-            </a:r>
-            <a:endParaRPr lang="en-US" sz="1000" dirty="0"/>
-          </a:p>
-        </p:txBody>
-      </p:sp>
-      <p:sp>
-        <p:nvSpPr>
-          <p:cNvPr id="21" name="Shape 17"/>
-          <p:cNvSpPr/>
-          <p:nvPr/>
-        </p:nvSpPr>
-        <p:spPr>
-          <a:xfrm>
-            <a:off x="6278728" y="4526280"/>
-            <a:ext cx="5364328" cy="1280160"/>
-          </a:xfrm>
-          <a:prstGeom prst="roundRect">
-            <a:avLst>
-              <a:gd name="adj" fmla="val 6429"/>
-            </a:avLst>
-          </a:prstGeom>
-          <a:solidFill>
-            <a:srgbClr val="F3F6FC"/>
-          </a:solidFill>
-          <a:ln/>
-          <a:effectLst>
-            <a:outerShdw sx="100000" sy="100000" kx="0" ky="0" algn="bl" rotWithShape="0" blurRad="101600" dist="25400" dir="5400000">
-              <a:srgbClr val="1B2A55">
-                <a:alpha val="12000"/>
-              </a:srgbClr>
-            </a:outerShdw>
-          </a:effectLst>
-        </p:spPr>
-      </p:sp>
-      <p:sp>
-        <p:nvSpPr>
-          <p:cNvPr id="22" name="Shape 18"/>
-          <p:cNvSpPr/>
-          <p:nvPr/>
-        </p:nvSpPr>
-        <p:spPr>
-          <a:xfrm>
-            <a:off x="6534760" y="4764024"/>
-            <a:ext cx="310896" cy="310896"/>
-          </a:xfrm>
-          <a:prstGeom prst="ellipse">
-            <a:avLst/>
-          </a:prstGeom>
-          <a:solidFill>
-            <a:srgbClr val="0D1B3E"/>
-          </a:solidFill>
-          <a:ln/>
-        </p:spPr>
-      </p:sp>
-      <p:pic>
-        <p:nvPicPr>
-          <p:cNvPr id="23" name="Image 2" descr="C:\Users\PC ANTONIO\AppData\Roaming\Claude\scratch-workspaces\f0f5d1bc-bf72-4611-a8ea-e50e459a0a45\08c0c592-3fff-44bf-a144-086c85aaeea0\scratch-2026-09-22-98642c\icons\download.png">    </p:cNvPr>
-          <p:cNvPicPr>
-            <a:picLocks noChangeAspect="1"/>
-          </p:cNvPicPr>
-          <p:nvPr/>
-        </p:nvPicPr>
-        <p:blipFill>
-          <a:blip r:embed="rId3"/>
-          <a:stretch>
-            <a:fillRect/>
-          </a:stretch>
-        </p:blipFill>
-        <p:spPr>
-          <a:xfrm>
-            <a:off x="6615593" y="4844857"/>
-            <a:ext cx="149230" cy="149230"/>
-          </a:xfrm>
-          <a:prstGeom prst="rect">
-            <a:avLst/>
-          </a:prstGeom>
-        </p:spPr>
-      </p:pic>
-      <p:sp>
-        <p:nvSpPr>
-          <p:cNvPr id="24" name="Text 19"/>
-          <p:cNvSpPr/>
-          <p:nvPr/>
-        </p:nvSpPr>
-        <p:spPr>
-          <a:xfrm>
-            <a:off x="7010248" y="4709160"/>
-            <a:ext cx="4404208" cy="365760"/>
-          </a:xfrm>
-          <a:prstGeom prst="rect">
-            <a:avLst/>
-          </a:prstGeom>
-          <a:noFill/>
-          <a:ln/>
-        </p:spPr>
-        <p:txBody>
-          <a:bodyPr wrap="square" lIns="0" tIns="0" rIns="0" bIns="0" rtlCol="0" anchor="ctr"/>
-          <a:lstStyle/>
-          <a:p>
-            <a:pPr indent="0" marL="0">
-              <a:buNone/>
-            </a:pPr>
-            <a:r>
-              <a:rPr lang="en-US" sz="1350" b="1" dirty="0">
-                <a:solidFill>
-                  <a:srgbClr val="0D1B3E"/>
-                </a:solidFill>
-                <a:latin typeface="Calibri" pitchFamily="34" charset="0"/>
-                <a:ea typeface="Calibri" pitchFamily="34" charset="-122"/>
-                <a:cs typeface="Calibri" pitchFamily="34" charset="-120"/>
-              </a:rPr>
-              <a:t>Conta Corrente e relatórios</a:t>
-            </a:r>
-            <a:endParaRPr lang="en-US" sz="1350" dirty="0"/>
-          </a:p>
-        </p:txBody>
-      </p:sp>
-      <p:sp>
-        <p:nvSpPr>
-          <p:cNvPr id="25" name="Text 20"/>
-          <p:cNvSpPr/>
-          <p:nvPr/>
-        </p:nvSpPr>
-        <p:spPr>
-          <a:xfrm>
-            <a:off x="6534760" y="5202936"/>
-            <a:ext cx="4852264" cy="438912"/>
-          </a:xfrm>
-          <a:prstGeom prst="rect">
-            <a:avLst/>
-          </a:prstGeom>
-          <a:noFill/>
-          <a:ln/>
-        </p:spPr>
-        <p:txBody>
-          <a:bodyPr wrap="square" lIns="0" tIns="0" rIns="0" bIns="0" rtlCol="0" anchor="t"/>
-          <a:lstStyle/>
-          <a:p>
-            <a:pPr indent="0" marL="0">
-              <a:lnSpc>
-                <a:spcPct val="112000"/>
-              </a:lnSpc>
-              <a:buNone/>
-            </a:pPr>
-            <a:r>
-              <a:rPr lang="en-US" sz="1000" dirty="0">
-                <a:solidFill>
-                  <a:srgbClr val="40496B"/>
-                </a:solidFill>
-                <a:latin typeface="Calibri" pitchFamily="34" charset="0"/>
-                <a:ea typeface="Calibri" pitchFamily="34" charset="-122"/>
-                <a:cs typeface="Calibri" pitchFamily="34" charset="-120"/>
-              </a:rPr>
-              <a:t>Compras e vendas lançadas automaticamente no mesmo caixa das ações, com exportação em Excel e PDF.</a:t>
-            </a:r>
-            <a:endParaRPr lang="en-US" sz="1000" dirty="0"/>
-          </a:p>
-        </p:txBody>
-      </p:sp>
-      <p:sp>
-        <p:nvSpPr>
-          <p:cNvPr id="26" name="Text 21"/>
-          <p:cNvSpPr/>
-          <p:nvPr/>
-        </p:nvSpPr>
-        <p:spPr>
-          <a:xfrm>
-            <a:off x="548640" y="6473952"/>
-            <a:ext cx="7315200" cy="274320"/>
-          </a:xfrm>
-          <a:prstGeom prst="rect">
-            <a:avLst/>
-          </a:prstGeom>
-          <a:noFill/>
-          <a:ln/>
-        </p:spPr>
-        <p:txBody>
-          <a:bodyPr wrap="square" lIns="0" tIns="0" rIns="0" bIns="0" rtlCol="0" anchor="ctr"/>
-          <a:lstStyle/>
-          <a:p>
-            <a:pPr algn="l" indent="0" marL="0">
-              <a:buNone/>
-            </a:pPr>
-            <a:r>
-              <a:rPr lang="en-US" sz="900" dirty="0">
-                <a:solidFill>
-                  <a:srgbClr val="7C89A8"/>
-                </a:solidFill>
-                <a:latin typeface="Calibri" pitchFamily="34" charset="0"/>
-                <a:ea typeface="Calibri" pitchFamily="34" charset="-122"/>
-                <a:cs typeface="Calibri" pitchFamily="34" charset="-120"/>
-              </a:rPr>
-              <a:t>BolsaTrader  ·  Manual Operacional do Sistema</a:t>
-            </a:r>
-            <a:endParaRPr lang="en-US" sz="900" dirty="0"/>
-          </a:p>
-        </p:txBody>
-      </p:sp>
-      <p:sp>
-        <p:nvSpPr>
-          <p:cNvPr id="27" name="Text 22"/>
-          <p:cNvSpPr/>
-          <p:nvPr/>
-        </p:nvSpPr>
-        <p:spPr>
-          <a:xfrm>
-            <a:off x="10728655" y="6473952"/>
-            <a:ext cx="914400" cy="274320"/>
-          </a:xfrm>
-          <a:prstGeom prst="rect">
-            <a:avLst/>
-          </a:prstGeom>
-          <a:noFill/>
-          <a:ln/>
-        </p:spPr>
-        <p:txBody>
-          <a:bodyPr wrap="square" lIns="0" tIns="0" rIns="0" bIns="0" rtlCol="0" anchor="ctr"/>
-          <a:lstStyle/>
-          <a:p>
-            <a:pPr algn="r" indent="0" marL="0">
-              <a:buNone/>
-            </a:pPr>
-            <a:r>
-              <a:rPr lang="en-US" sz="900" dirty="0">
-                <a:solidFill>
-                  <a:srgbClr val="7C89A8"/>
-                </a:solidFill>
-                <a:latin typeface="Calibri" pitchFamily="34" charset="0"/>
-                <a:ea typeface="Calibri" pitchFamily="34" charset="-122"/>
-                <a:cs typeface="Calibri" pitchFamily="34" charset="-120"/>
-              </a:rPr>
-              <a:t>20</a:t>
+              <a:t>24</a:t>
             </a:r>
             <a:endParaRPr lang="en-US" sz="900" dirty="0"/>
           </a:p>

</xml_diff>

<commit_message>
Atualiza manuais e apresentacao com o comando de voz em portugues
Co-Authored-By: Claude Opus 5.5 <noreply@anthropic.com>
</commit_message>
<xml_diff>
--- a/docs/BolsaTrader_Manual_Operacional.pptx
+++ b/docs/BolsaTrader_Manual_Operacional.pptx
@@ -11,6 +11,7 @@
     <p:sldId id="259" r:id="rId5"/>
     <p:sldId id="260" r:id="rId6"/>
     <p:sldId id="261" r:id="rId7"/>
+    <p:sldId id="280" r:id="rId31"/>
     <p:sldId id="262" r:id="rId8"/>
     <p:sldId id="263" r:id="rId9"/>
     <p:sldId id="264" r:id="rId10"/>
@@ -3036,7 +3037,7 @@
                 <a:ea typeface="Calibri" pitchFamily="34" charset="-122"/>
                 <a:cs typeface="Calibri" pitchFamily="34" charset="-120"/>
               </a:rPr>
-              <a:t>10/2026 (revisão 09/10/2026)</a:t>
+              <a:t>10/2026 (revisão 10/10/2026)</a:t>
             </a:r>
             <a:endParaRPr lang="en-US" sz="1150" dirty="0"/>
           </a:p>
@@ -3432,6 +3433,10 @@
             </a:outerShdw>
           </a:effectLst>
         </p:spPr>
+        <p:txBody>
+          <a:bodyPr/>
+          <a:p/>
+        </p:txBody>
       </p:sp>
       <p:sp>
         <p:nvSpPr>
@@ -3452,6 +3457,10 @@
           </a:solidFill>
           <a:ln/>
         </p:spPr>
+        <p:txBody>
+          <a:bodyPr/>
+          <a:p/>
+        </p:txBody>
       </p:sp>
       <p:pic>
         <p:nvPicPr>
@@ -3586,6 +3595,10 @@
             </a:outerShdw>
           </a:effectLst>
         </p:spPr>
+        <p:txBody>
+          <a:bodyPr/>
+          <a:p/>
+        </p:txBody>
       </p:sp>
       <p:sp>
         <p:nvSpPr>
@@ -3606,6 +3619,10 @@
           </a:solidFill>
           <a:ln/>
         </p:spPr>
+        <p:txBody>
+          <a:bodyPr/>
+          <a:p/>
+        </p:txBody>
       </p:sp>
       <p:pic>
         <p:nvPicPr>
@@ -3740,6 +3757,10 @@
             </a:outerShdw>
           </a:effectLst>
         </p:spPr>
+        <p:txBody>
+          <a:bodyPr/>
+          <a:p/>
+        </p:txBody>
       </p:sp>
       <p:sp>
         <p:nvSpPr>
@@ -3760,6 +3781,10 @@
           </a:solidFill>
           <a:ln/>
         </p:spPr>
+        <p:txBody>
+          <a:bodyPr/>
+          <a:p/>
+        </p:txBody>
       </p:sp>
       <p:pic>
         <p:nvPicPr>
@@ -3887,6 +3912,10 @@
           </a:solidFill>
           <a:ln/>
         </p:spPr>
+        <p:txBody>
+          <a:bodyPr/>
+          <a:p/>
+        </p:txBody>
       </p:sp>
       <p:sp>
         <p:nvSpPr>
@@ -3907,6 +3936,10 @@
           </a:solidFill>
           <a:ln/>
         </p:spPr>
+        <p:txBody>
+          <a:bodyPr/>
+          <a:p/>
+        </p:txBody>
       </p:sp>
       <p:pic>
         <p:nvPicPr>
@@ -4046,7 +4079,7 @@
                 <a:ea typeface="Calibri" pitchFamily="34" charset="-122"/>
                 <a:cs typeface="Calibri" pitchFamily="34" charset="-120"/>
               </a:rPr>
-              <a:t>10</a:t>
+              <a:t>11</a:t>
             </a:r>
             <a:endParaRPr lang="en-US" sz="900" dirty="0"/>
           </a:p>
@@ -4246,6 +4279,10 @@
             </a:outerShdw>
           </a:effectLst>
         </p:spPr>
+        <p:txBody>
+          <a:bodyPr/>
+          <a:p/>
+        </p:txBody>
       </p:sp>
       <p:sp>
         <p:nvSpPr>
@@ -4266,6 +4303,10 @@
           </a:solidFill>
           <a:ln/>
         </p:spPr>
+        <p:txBody>
+          <a:bodyPr/>
+          <a:p/>
+        </p:txBody>
       </p:sp>
       <p:pic>
         <p:nvPicPr>
@@ -4400,6 +4441,10 @@
             </a:outerShdw>
           </a:effectLst>
         </p:spPr>
+        <p:txBody>
+          <a:bodyPr/>
+          <a:p/>
+        </p:txBody>
       </p:sp>
       <p:sp>
         <p:nvSpPr>
@@ -4420,6 +4465,10 @@
           </a:solidFill>
           <a:ln/>
         </p:spPr>
+        <p:txBody>
+          <a:bodyPr/>
+          <a:p/>
+        </p:txBody>
       </p:sp>
       <p:pic>
         <p:nvPicPr>
@@ -4554,6 +4603,10 @@
             </a:outerShdw>
           </a:effectLst>
         </p:spPr>
+        <p:txBody>
+          <a:bodyPr/>
+          <a:p/>
+        </p:txBody>
       </p:sp>
       <p:sp>
         <p:nvSpPr>
@@ -4574,6 +4627,10 @@
           </a:solidFill>
           <a:ln/>
         </p:spPr>
+        <p:txBody>
+          <a:bodyPr/>
+          <a:p/>
+        </p:txBody>
       </p:sp>
       <p:pic>
         <p:nvPicPr>
@@ -4701,6 +4758,10 @@
           </a:solidFill>
           <a:ln/>
         </p:spPr>
+        <p:txBody>
+          <a:bodyPr/>
+          <a:p/>
+        </p:txBody>
       </p:sp>
       <p:sp>
         <p:nvSpPr>
@@ -4721,6 +4782,10 @@
           </a:solidFill>
           <a:ln/>
         </p:spPr>
+        <p:txBody>
+          <a:bodyPr/>
+          <a:p/>
+        </p:txBody>
       </p:sp>
       <p:pic>
         <p:nvPicPr>
@@ -4860,7 +4925,7 @@
                 <a:ea typeface="Calibri" pitchFamily="34" charset="-122"/>
                 <a:cs typeface="Calibri" pitchFamily="34" charset="-120"/>
               </a:rPr>
-              <a:t>11</a:t>
+              <a:t>12</a:t>
             </a:r>
             <a:endParaRPr lang="en-US" sz="900" dirty="0"/>
           </a:p>
@@ -5018,6 +5083,10 @@
             </a:outerShdw>
           </a:effectLst>
         </p:spPr>
+        <p:txBody>
+          <a:bodyPr/>
+          <a:p/>
+        </p:txBody>
       </p:sp>
       <p:sp>
         <p:nvSpPr>
@@ -5038,6 +5107,10 @@
           </a:solidFill>
           <a:ln/>
         </p:spPr>
+        <p:txBody>
+          <a:bodyPr/>
+          <a:p/>
+        </p:txBody>
       </p:sp>
       <p:pic>
         <p:nvPicPr>
@@ -5202,6 +5275,10 @@
           </a:solidFill>
           <a:ln/>
         </p:spPr>
+        <p:txBody>
+          <a:bodyPr/>
+          <a:p/>
+        </p:txBody>
       </p:sp>
       <p:pic>
         <p:nvPicPr>
@@ -5327,6 +5404,10 @@
           </a:solidFill>
           <a:ln/>
         </p:spPr>
+        <p:txBody>
+          <a:bodyPr/>
+          <a:p/>
+        </p:txBody>
       </p:sp>
       <p:pic>
         <p:nvPicPr>
@@ -5452,6 +5533,10 @@
           </a:solidFill>
           <a:ln/>
         </p:spPr>
+        <p:txBody>
+          <a:bodyPr/>
+          <a:p/>
+        </p:txBody>
       </p:sp>
       <p:pic>
         <p:nvPicPr>
@@ -5577,6 +5662,10 @@
           </a:solidFill>
           <a:ln/>
         </p:spPr>
+        <p:txBody>
+          <a:bodyPr/>
+          <a:p/>
+        </p:txBody>
       </p:sp>
       <p:pic>
         <p:nvPicPr>
@@ -5704,6 +5793,10 @@
           </a:solidFill>
           <a:ln/>
         </p:spPr>
+        <p:txBody>
+          <a:bodyPr/>
+          <a:p/>
+        </p:txBody>
       </p:sp>
       <p:sp>
         <p:nvSpPr>
@@ -5724,6 +5817,10 @@
           </a:solidFill>
           <a:ln/>
         </p:spPr>
+        <p:txBody>
+          <a:bodyPr/>
+          <a:p/>
+        </p:txBody>
       </p:sp>
       <p:pic>
         <p:nvPicPr>
@@ -5863,7 +5960,7 @@
                 <a:ea typeface="Calibri" pitchFamily="34" charset="-122"/>
                 <a:cs typeface="Calibri" pitchFamily="34" charset="-120"/>
               </a:rPr>
-              <a:t>12</a:t>
+              <a:t>13</a:t>
             </a:r>
             <a:endParaRPr lang="en-US" sz="900" dirty="0"/>
           </a:p>
@@ -6063,6 +6160,10 @@
             </a:outerShdw>
           </a:effectLst>
         </p:spPr>
+        <p:txBody>
+          <a:bodyPr/>
+          <a:p/>
+        </p:txBody>
       </p:sp>
       <p:sp>
         <p:nvSpPr>
@@ -6083,6 +6184,10 @@
           </a:solidFill>
           <a:ln/>
         </p:spPr>
+        <p:txBody>
+          <a:bodyPr/>
+          <a:p/>
+        </p:txBody>
       </p:sp>
       <p:pic>
         <p:nvPicPr>
@@ -6217,6 +6322,10 @@
             </a:outerShdw>
           </a:effectLst>
         </p:spPr>
+        <p:txBody>
+          <a:bodyPr/>
+          <a:p/>
+        </p:txBody>
       </p:sp>
       <p:sp>
         <p:nvSpPr>
@@ -6237,6 +6346,10 @@
           </a:solidFill>
           <a:ln/>
         </p:spPr>
+        <p:txBody>
+          <a:bodyPr/>
+          <a:p/>
+        </p:txBody>
       </p:sp>
       <p:pic>
         <p:nvPicPr>
@@ -6371,6 +6484,10 @@
             </a:outerShdw>
           </a:effectLst>
         </p:spPr>
+        <p:txBody>
+          <a:bodyPr/>
+          <a:p/>
+        </p:txBody>
       </p:sp>
       <p:sp>
         <p:nvSpPr>
@@ -6391,6 +6508,10 @@
           </a:solidFill>
           <a:ln/>
         </p:spPr>
+        <p:txBody>
+          <a:bodyPr/>
+          <a:p/>
+        </p:txBody>
       </p:sp>
       <p:pic>
         <p:nvPicPr>
@@ -6564,6 +6685,10 @@
             </a:outerShdw>
           </a:effectLst>
         </p:spPr>
+        <p:txBody>
+          <a:bodyPr/>
+          <a:p/>
+        </p:txBody>
       </p:sp>
       <p:sp>
         <p:nvSpPr>
@@ -6584,6 +6709,10 @@
           </a:solidFill>
           <a:ln/>
         </p:spPr>
+        <p:txBody>
+          <a:bodyPr/>
+          <a:p/>
+        </p:txBody>
       </p:sp>
       <p:pic>
         <p:nvPicPr>
@@ -6718,6 +6847,10 @@
             </a:outerShdw>
           </a:effectLst>
         </p:spPr>
+        <p:txBody>
+          <a:bodyPr/>
+          <a:p/>
+        </p:txBody>
       </p:sp>
       <p:sp>
         <p:nvSpPr>
@@ -6738,6 +6871,10 @@
           </a:solidFill>
           <a:ln/>
         </p:spPr>
+        <p:txBody>
+          <a:bodyPr/>
+          <a:p/>
+        </p:txBody>
       </p:sp>
       <p:pic>
         <p:nvPicPr>
@@ -6916,7 +7053,7 @@
                 <a:ea typeface="Calibri" pitchFamily="34" charset="-122"/>
                 <a:cs typeface="Calibri" pitchFamily="34" charset="-120"/>
               </a:rPr>
-              <a:t>13</a:t>
+              <a:t>14</a:t>
             </a:r>
             <a:endParaRPr lang="en-US" sz="900" dirty="0"/>
           </a:p>
@@ -7116,6 +7253,10 @@
             </a:outerShdw>
           </a:effectLst>
         </p:spPr>
+        <p:txBody>
+          <a:bodyPr/>
+          <a:p/>
+        </p:txBody>
       </p:sp>
       <p:sp>
         <p:nvSpPr>
@@ -7136,6 +7277,10 @@
           </a:solidFill>
           <a:ln/>
         </p:spPr>
+        <p:txBody>
+          <a:bodyPr/>
+          <a:p/>
+        </p:txBody>
       </p:sp>
       <p:pic>
         <p:nvPicPr>
@@ -7300,6 +7445,10 @@
           </a:solidFill>
           <a:ln/>
         </p:spPr>
+        <p:txBody>
+          <a:bodyPr/>
+          <a:p/>
+        </p:txBody>
       </p:sp>
       <p:pic>
         <p:nvPicPr>
@@ -7383,6 +7532,10 @@
           </a:solidFill>
           <a:ln/>
         </p:spPr>
+        <p:txBody>
+          <a:bodyPr/>
+          <a:p/>
+        </p:txBody>
       </p:sp>
       <p:pic>
         <p:nvPicPr>
@@ -7466,6 +7619,10 @@
           </a:solidFill>
           <a:ln/>
         </p:spPr>
+        <p:txBody>
+          <a:bodyPr/>
+          <a:p/>
+        </p:txBody>
       </p:sp>
       <p:pic>
         <p:nvPicPr>
@@ -7549,6 +7706,10 @@
           </a:solidFill>
           <a:ln/>
         </p:spPr>
+        <p:txBody>
+          <a:bodyPr/>
+          <a:p/>
+        </p:txBody>
       </p:sp>
       <p:pic>
         <p:nvPicPr>
@@ -7634,6 +7795,10 @@
           </a:solidFill>
           <a:ln/>
         </p:spPr>
+        <p:txBody>
+          <a:bodyPr/>
+          <a:p/>
+        </p:txBody>
       </p:sp>
       <p:sp>
         <p:nvSpPr>
@@ -7654,6 +7819,10 @@
           </a:solidFill>
           <a:ln/>
         </p:spPr>
+        <p:txBody>
+          <a:bodyPr/>
+          <a:p/>
+        </p:txBody>
       </p:sp>
       <p:pic>
         <p:nvPicPr>
@@ -7793,7 +7962,7 @@
                 <a:ea typeface="Calibri" pitchFamily="34" charset="-122"/>
                 <a:cs typeface="Calibri" pitchFamily="34" charset="-120"/>
               </a:rPr>
-              <a:t>14</a:t>
+              <a:t>15</a:t>
             </a:r>
             <a:endParaRPr lang="en-US" sz="900" dirty="0"/>
           </a:p>
@@ -7951,6 +8120,10 @@
             </a:outerShdw>
           </a:effectLst>
         </p:spPr>
+        <p:txBody>
+          <a:bodyPr/>
+          <a:p/>
+        </p:txBody>
       </p:sp>
       <p:sp>
         <p:nvSpPr>
@@ -7971,6 +8144,10 @@
           </a:solidFill>
           <a:ln/>
         </p:spPr>
+        <p:txBody>
+          <a:bodyPr/>
+          <a:p/>
+        </p:txBody>
       </p:sp>
       <p:pic>
         <p:nvPicPr>
@@ -8105,6 +8282,10 @@
             </a:outerShdw>
           </a:effectLst>
         </p:spPr>
+        <p:txBody>
+          <a:bodyPr/>
+          <a:p/>
+        </p:txBody>
       </p:sp>
       <p:sp>
         <p:nvSpPr>
@@ -8125,6 +8306,10 @@
           </a:solidFill>
           <a:ln/>
         </p:spPr>
+        <p:txBody>
+          <a:bodyPr/>
+          <a:p/>
+        </p:txBody>
       </p:sp>
       <p:pic>
         <p:nvPicPr>
@@ -8291,6 +8476,10 @@
           </a:solidFill>
           <a:ln/>
         </p:spPr>
+        <p:txBody>
+          <a:bodyPr/>
+          <a:p/>
+        </p:txBody>
       </p:sp>
       <p:sp>
         <p:nvSpPr>
@@ -8311,6 +8500,10 @@
           </a:solidFill>
           <a:ln/>
         </p:spPr>
+        <p:txBody>
+          <a:bodyPr/>
+          <a:p/>
+        </p:txBody>
       </p:sp>
       <p:pic>
         <p:nvPicPr>
@@ -8438,6 +8631,10 @@
           </a:solidFill>
           <a:ln/>
         </p:spPr>
+        <p:txBody>
+          <a:bodyPr/>
+          <a:p/>
+        </p:txBody>
       </p:sp>
       <p:sp>
         <p:nvSpPr>
@@ -8458,6 +8655,10 @@
           </a:solidFill>
           <a:ln/>
         </p:spPr>
+        <p:txBody>
+          <a:bodyPr/>
+          <a:p/>
+        </p:txBody>
       </p:sp>
       <p:pic>
         <p:nvPicPr>
@@ -8585,6 +8786,10 @@
           </a:solidFill>
           <a:ln/>
         </p:spPr>
+        <p:txBody>
+          <a:bodyPr/>
+          <a:p/>
+        </p:txBody>
       </p:sp>
       <p:sp>
         <p:nvSpPr>
@@ -8605,6 +8810,10 @@
           </a:solidFill>
           <a:ln/>
         </p:spPr>
+        <p:txBody>
+          <a:bodyPr/>
+          <a:p/>
+        </p:txBody>
       </p:sp>
       <p:pic>
         <p:nvPicPr>
@@ -8732,6 +8941,10 @@
           </a:solidFill>
           <a:ln/>
         </p:spPr>
+        <p:txBody>
+          <a:bodyPr/>
+          <a:p/>
+        </p:txBody>
       </p:sp>
       <p:sp>
         <p:nvSpPr>
@@ -8752,6 +8965,10 @@
           </a:solidFill>
           <a:ln/>
         </p:spPr>
+        <p:txBody>
+          <a:bodyPr/>
+          <a:p/>
+        </p:txBody>
       </p:sp>
       <p:pic>
         <p:nvPicPr>
@@ -8930,7 +9147,7 @@
                 <a:ea typeface="Calibri" pitchFamily="34" charset="-122"/>
                 <a:cs typeface="Calibri" pitchFamily="34" charset="-120"/>
               </a:rPr>
-              <a:t>15</a:t>
+              <a:t>16</a:t>
             </a:r>
             <a:endParaRPr lang="en-US" sz="900" dirty="0"/>
           </a:p>
@@ -9120,6 +9337,10 @@
           </a:solidFill>
           <a:ln/>
         </p:spPr>
+        <p:txBody>
+          <a:bodyPr/>
+          <a:p/>
+        </p:txBody>
       </p:sp>
       <p:sp>
         <p:nvSpPr>
@@ -9184,6 +9405,10 @@
           </a:solidFill>
           <a:ln/>
         </p:spPr>
+        <p:txBody>
+          <a:bodyPr/>
+          <a:p/>
+        </p:txBody>
       </p:sp>
       <p:sp>
         <p:nvSpPr>
@@ -9248,6 +9473,10 @@
           </a:solidFill>
           <a:ln/>
         </p:spPr>
+        <p:txBody>
+          <a:bodyPr/>
+          <a:p/>
+        </p:txBody>
       </p:sp>
       <p:sp>
         <p:nvSpPr>
@@ -9312,6 +9541,10 @@
           </a:solidFill>
           <a:ln/>
         </p:spPr>
+        <p:txBody>
+          <a:bodyPr/>
+          <a:p/>
+        </p:txBody>
       </p:sp>
       <p:sp>
         <p:nvSpPr>
@@ -9376,6 +9609,10 @@
           </a:solidFill>
           <a:ln/>
         </p:spPr>
+        <p:txBody>
+          <a:bodyPr/>
+          <a:p/>
+        </p:txBody>
       </p:sp>
       <p:sp>
         <p:nvSpPr>
@@ -9440,6 +9677,10 @@
           </a:solidFill>
           <a:ln/>
         </p:spPr>
+        <p:txBody>
+          <a:bodyPr/>
+          <a:p/>
+        </p:txBody>
       </p:sp>
       <p:sp>
         <p:nvSpPr>
@@ -10239,6 +10480,10 @@
           </a:solidFill>
           <a:ln/>
         </p:spPr>
+        <p:txBody>
+          <a:bodyPr/>
+          <a:p/>
+        </p:txBody>
       </p:sp>
       <p:sp>
         <p:nvSpPr>
@@ -10259,6 +10504,10 @@
           </a:solidFill>
           <a:ln/>
         </p:spPr>
+        <p:txBody>
+          <a:bodyPr/>
+          <a:p/>
+        </p:txBody>
       </p:sp>
       <p:pic>
         <p:nvPicPr>
@@ -10398,7 +10647,7 @@
                 <a:ea typeface="Calibri" pitchFamily="34" charset="-122"/>
                 <a:cs typeface="Calibri" pitchFamily="34" charset="-120"/>
               </a:rPr>
-              <a:t>16</a:t>
+              <a:t>17</a:t>
             </a:r>
             <a:endParaRPr lang="en-US" sz="900" dirty="0"/>
           </a:p>
@@ -10556,6 +10805,10 @@
             </a:outerShdw>
           </a:effectLst>
         </p:spPr>
+        <p:txBody>
+          <a:bodyPr/>
+          <a:p/>
+        </p:txBody>
       </p:sp>
       <p:sp>
         <p:nvSpPr>
@@ -10576,6 +10829,10 @@
           </a:solidFill>
           <a:ln/>
         </p:spPr>
+        <p:txBody>
+          <a:bodyPr/>
+          <a:p/>
+        </p:txBody>
       </p:sp>
       <p:pic>
         <p:nvPicPr>
@@ -10710,6 +10967,10 @@
             </a:outerShdw>
           </a:effectLst>
         </p:spPr>
+        <p:txBody>
+          <a:bodyPr/>
+          <a:p/>
+        </p:txBody>
       </p:sp>
       <p:sp>
         <p:nvSpPr>
@@ -10730,6 +10991,10 @@
           </a:solidFill>
           <a:ln/>
         </p:spPr>
+        <p:txBody>
+          <a:bodyPr/>
+          <a:p/>
+        </p:txBody>
       </p:sp>
       <p:pic>
         <p:nvPicPr>
@@ -10864,6 +11129,10 @@
             </a:outerShdw>
           </a:effectLst>
         </p:spPr>
+        <p:txBody>
+          <a:bodyPr/>
+          <a:p/>
+        </p:txBody>
       </p:sp>
       <p:sp>
         <p:nvSpPr>
@@ -10884,6 +11153,10 @@
           </a:solidFill>
           <a:ln/>
         </p:spPr>
+        <p:txBody>
+          <a:bodyPr/>
+          <a:p/>
+        </p:txBody>
       </p:sp>
       <p:pic>
         <p:nvPicPr>
@@ -11018,6 +11291,10 @@
             </a:outerShdw>
           </a:effectLst>
         </p:spPr>
+        <p:txBody>
+          <a:bodyPr/>
+          <a:p/>
+        </p:txBody>
       </p:sp>
       <p:sp>
         <p:nvSpPr>
@@ -11038,6 +11315,10 @@
           </a:solidFill>
           <a:ln/>
         </p:spPr>
+        <p:txBody>
+          <a:bodyPr/>
+          <a:p/>
+        </p:txBody>
       </p:sp>
       <p:pic>
         <p:nvPicPr>
@@ -11202,6 +11483,10 @@
           </a:solidFill>
           <a:ln/>
         </p:spPr>
+        <p:txBody>
+          <a:bodyPr/>
+          <a:p/>
+        </p:txBody>
       </p:sp>
       <p:pic>
         <p:nvPicPr>
@@ -11327,6 +11612,10 @@
           </a:solidFill>
           <a:ln/>
         </p:spPr>
+        <p:txBody>
+          <a:bodyPr/>
+          <a:p/>
+        </p:txBody>
       </p:sp>
       <p:pic>
         <p:nvPicPr>
@@ -11505,7 +11794,7 @@
                 <a:ea typeface="Calibri" pitchFamily="34" charset="-122"/>
                 <a:cs typeface="Calibri" pitchFamily="34" charset="-120"/>
               </a:rPr>
-              <a:t>17</a:t>
+              <a:t>18</a:t>
             </a:r>
             <a:endParaRPr lang="en-US" sz="900" dirty="0"/>
           </a:p>
@@ -11663,6 +11952,10 @@
             </a:outerShdw>
           </a:effectLst>
         </p:spPr>
+        <p:txBody>
+          <a:bodyPr/>
+          <a:p/>
+        </p:txBody>
       </p:sp>
       <p:sp>
         <p:nvSpPr>
@@ -11683,6 +11976,10 @@
           </a:solidFill>
           <a:ln/>
         </p:spPr>
+        <p:txBody>
+          <a:bodyPr/>
+          <a:p/>
+        </p:txBody>
       </p:sp>
       <p:pic>
         <p:nvPicPr>
@@ -11817,6 +12114,10 @@
             </a:outerShdw>
           </a:effectLst>
         </p:spPr>
+        <p:txBody>
+          <a:bodyPr/>
+          <a:p/>
+        </p:txBody>
       </p:sp>
       <p:sp>
         <p:nvSpPr>
@@ -11837,6 +12138,10 @@
           </a:solidFill>
           <a:ln/>
         </p:spPr>
+        <p:txBody>
+          <a:bodyPr/>
+          <a:p/>
+        </p:txBody>
       </p:sp>
       <p:pic>
         <p:nvPicPr>
@@ -11971,6 +12276,10 @@
             </a:outerShdw>
           </a:effectLst>
         </p:spPr>
+        <p:txBody>
+          <a:bodyPr/>
+          <a:p/>
+        </p:txBody>
       </p:sp>
       <p:sp>
         <p:nvSpPr>
@@ -11991,6 +12300,10 @@
           </a:solidFill>
           <a:ln/>
         </p:spPr>
+        <p:txBody>
+          <a:bodyPr/>
+          <a:p/>
+        </p:txBody>
       </p:sp>
       <p:pic>
         <p:nvPicPr>
@@ -12125,6 +12438,10 @@
             </a:outerShdw>
           </a:effectLst>
         </p:spPr>
+        <p:txBody>
+          <a:bodyPr/>
+          <a:p/>
+        </p:txBody>
       </p:sp>
       <p:sp>
         <p:nvSpPr>
@@ -12145,6 +12462,10 @@
           </a:solidFill>
           <a:ln/>
         </p:spPr>
+        <p:txBody>
+          <a:bodyPr/>
+          <a:p/>
+        </p:txBody>
       </p:sp>
       <p:pic>
         <p:nvPicPr>
@@ -12309,6 +12630,10 @@
           </a:solidFill>
           <a:ln/>
         </p:spPr>
+        <p:txBody>
+          <a:bodyPr/>
+          <a:p/>
+        </p:txBody>
       </p:sp>
       <p:pic>
         <p:nvPicPr>
@@ -12434,6 +12759,10 @@
           </a:solidFill>
           <a:ln/>
         </p:spPr>
+        <p:txBody>
+          <a:bodyPr/>
+          <a:p/>
+        </p:txBody>
       </p:sp>
       <p:pic>
         <p:nvPicPr>
@@ -12612,7 +12941,7 @@
                 <a:ea typeface="Calibri" pitchFamily="34" charset="-122"/>
                 <a:cs typeface="Calibri" pitchFamily="34" charset="-120"/>
               </a:rPr>
-              <a:t>18</a:t>
+              <a:t>19</a:t>
             </a:r>
             <a:endParaRPr lang="en-US" sz="900" dirty="0"/>
           </a:p>
@@ -12770,6 +13099,10 @@
             </a:outerShdw>
           </a:effectLst>
         </p:spPr>
+        <p:txBody>
+          <a:bodyPr/>
+          <a:p/>
+        </p:txBody>
       </p:sp>
       <p:sp>
         <p:nvSpPr>
@@ -12790,6 +13123,10 @@
           </a:solidFill>
           <a:ln/>
         </p:spPr>
+        <p:txBody>
+          <a:bodyPr/>
+          <a:p/>
+        </p:txBody>
       </p:sp>
       <p:pic>
         <p:nvPicPr>
@@ -12924,6 +13261,10 @@
             </a:outerShdw>
           </a:effectLst>
         </p:spPr>
+        <p:txBody>
+          <a:bodyPr/>
+          <a:p/>
+        </p:txBody>
       </p:sp>
       <p:sp>
         <p:nvSpPr>
@@ -12944,6 +13285,10 @@
           </a:solidFill>
           <a:ln/>
         </p:spPr>
+        <p:txBody>
+          <a:bodyPr/>
+          <a:p/>
+        </p:txBody>
       </p:sp>
       <p:pic>
         <p:nvPicPr>
@@ -13681,6 +14026,10 @@
             </a:outerShdw>
           </a:effectLst>
         </p:spPr>
+        <p:txBody>
+          <a:bodyPr/>
+          <a:p/>
+        </p:txBody>
       </p:sp>
       <p:sp>
         <p:nvSpPr>
@@ -13701,6 +14050,10 @@
           </a:solidFill>
           <a:ln/>
         </p:spPr>
+        <p:txBody>
+          <a:bodyPr/>
+          <a:p/>
+        </p:txBody>
       </p:sp>
       <p:pic>
         <p:nvPicPr>
@@ -13879,7 +14232,7 @@
                 <a:ea typeface="Calibri" pitchFamily="34" charset="-122"/>
                 <a:cs typeface="Calibri" pitchFamily="34" charset="-120"/>
               </a:rPr>
-              <a:t>19</a:t>
+              <a:t>20</a:t>
             </a:r>
             <a:endParaRPr lang="en-US" sz="900" dirty="0"/>
           </a:p>
@@ -14315,7 +14668,7 @@
                 <a:ea typeface="Calibri" pitchFamily="34" charset="-122"/>
                 <a:cs typeface="Calibri" pitchFamily="34" charset="-120"/>
               </a:rPr>
-              <a:t>Navegação e menu principal</a:t>
+              <a:t>Navegação, menu e comando de voz</a:t>
             </a:r>
             <a:endParaRPr lang="en-US" sz="1350" dirty="0"/>
           </a:p>
@@ -15210,6 +15563,10 @@
           </a:solidFill>
           <a:ln/>
         </p:spPr>
+        <p:txBody>
+          <a:bodyPr/>
+          <a:p/>
+        </p:txBody>
       </p:sp>
       <p:sp>
         <p:nvSpPr>
@@ -15310,6 +15667,10 @@
           </a:solidFill>
           <a:ln/>
         </p:spPr>
+        <p:txBody>
+          <a:bodyPr/>
+          <a:p/>
+        </p:txBody>
       </p:sp>
       <p:sp>
         <p:nvSpPr>
@@ -15417,6 +15778,10 @@
             </a:outerShdw>
           </a:effectLst>
         </p:spPr>
+        <p:txBody>
+          <a:bodyPr/>
+          <a:p/>
+        </p:txBody>
       </p:sp>
       <p:sp>
         <p:nvSpPr>
@@ -15437,6 +15802,10 @@
           </a:solidFill>
           <a:ln/>
         </p:spPr>
+        <p:txBody>
+          <a:bodyPr/>
+          <a:p/>
+        </p:txBody>
       </p:sp>
       <p:pic>
         <p:nvPicPr>
@@ -15571,6 +15940,10 @@
             </a:outerShdw>
           </a:effectLst>
         </p:spPr>
+        <p:txBody>
+          <a:bodyPr/>
+          <a:p/>
+        </p:txBody>
       </p:sp>
       <p:sp>
         <p:nvSpPr>
@@ -15591,6 +15964,10 @@
           </a:solidFill>
           <a:ln/>
         </p:spPr>
+        <p:txBody>
+          <a:bodyPr/>
+          <a:p/>
+        </p:txBody>
       </p:sp>
       <p:pic>
         <p:nvPicPr>
@@ -15725,6 +16102,10 @@
             </a:outerShdw>
           </a:effectLst>
         </p:spPr>
+        <p:txBody>
+          <a:bodyPr/>
+          <a:p/>
+        </p:txBody>
       </p:sp>
       <p:sp>
         <p:nvSpPr>
@@ -15745,6 +16126,10 @@
           </a:solidFill>
           <a:ln/>
         </p:spPr>
+        <p:txBody>
+          <a:bodyPr/>
+          <a:p/>
+        </p:txBody>
       </p:sp>
       <p:pic>
         <p:nvPicPr>
@@ -15923,7 +16308,7 @@
                 <a:ea typeface="Calibri" pitchFamily="34" charset="-122"/>
                 <a:cs typeface="Calibri" pitchFamily="34" charset="-120"/>
               </a:rPr>
-              <a:t>20</a:t>
+              <a:t>21</a:t>
             </a:r>
             <a:endParaRPr lang="en-US" sz="900" dirty="0"/>
           </a:p>
@@ -16116,6 +16501,10 @@
           </a:solidFill>
           <a:ln/>
         </p:spPr>
+        <p:txBody>
+          <a:bodyPr/>
+          <a:p/>
+        </p:txBody>
       </p:sp>
       <p:sp>
         <p:nvSpPr>
@@ -16216,6 +16605,10 @@
           </a:solidFill>
           <a:ln/>
         </p:spPr>
+        <p:txBody>
+          <a:bodyPr/>
+          <a:p/>
+        </p:txBody>
       </p:sp>
       <p:sp>
         <p:nvSpPr>
@@ -16323,6 +16716,10 @@
             </a:outerShdw>
           </a:effectLst>
         </p:spPr>
+        <p:txBody>
+          <a:bodyPr/>
+          <a:p/>
+        </p:txBody>
       </p:sp>
       <p:sp>
         <p:nvSpPr>
@@ -16343,6 +16740,10 @@
           </a:solidFill>
           <a:ln/>
         </p:spPr>
+        <p:txBody>
+          <a:bodyPr/>
+          <a:p/>
+        </p:txBody>
       </p:sp>
       <p:pic>
         <p:nvPicPr>
@@ -16477,6 +16878,10 @@
             </a:outerShdw>
           </a:effectLst>
         </p:spPr>
+        <p:txBody>
+          <a:bodyPr/>
+          <a:p/>
+        </p:txBody>
       </p:sp>
       <p:sp>
         <p:nvSpPr>
@@ -16497,6 +16902,10 @@
           </a:solidFill>
           <a:ln/>
         </p:spPr>
+        <p:txBody>
+          <a:bodyPr/>
+          <a:p/>
+        </p:txBody>
       </p:sp>
       <p:pic>
         <p:nvPicPr>
@@ -16631,6 +17040,10 @@
             </a:outerShdw>
           </a:effectLst>
         </p:spPr>
+        <p:txBody>
+          <a:bodyPr/>
+          <a:p/>
+        </p:txBody>
       </p:sp>
       <p:sp>
         <p:nvSpPr>
@@ -16651,6 +17064,10 @@
           </a:solidFill>
           <a:ln/>
         </p:spPr>
+        <p:txBody>
+          <a:bodyPr/>
+          <a:p/>
+        </p:txBody>
       </p:sp>
       <p:pic>
         <p:nvPicPr>
@@ -16829,7 +17246,7 @@
                 <a:ea typeface="Calibri" pitchFamily="34" charset="-122"/>
                 <a:cs typeface="Calibri" pitchFamily="34" charset="-120"/>
               </a:rPr>
-              <a:t>21</a:t>
+              <a:t>22</a:t>
             </a:r>
             <a:endParaRPr lang="en-US" sz="900" dirty="0"/>
           </a:p>
@@ -17979,6 +18396,10 @@
           </a:solidFill>
           <a:ln/>
         </p:spPr>
+        <p:txBody>
+          <a:bodyPr/>
+          <a:p/>
+        </p:txBody>
       </p:sp>
       <p:sp>
         <p:nvSpPr>
@@ -17999,6 +18420,10 @@
           </a:solidFill>
           <a:ln/>
         </p:spPr>
+        <p:txBody>
+          <a:bodyPr/>
+          <a:p/>
+        </p:txBody>
       </p:sp>
       <p:pic>
         <p:nvPicPr>
@@ -18138,7 +18563,7 @@
                 <a:ea typeface="Calibri" pitchFamily="34" charset="-122"/>
                 <a:cs typeface="Calibri" pitchFamily="34" charset="-120"/>
               </a:rPr>
-              <a:t>22</a:t>
+              <a:t>23</a:t>
             </a:r>
             <a:endParaRPr lang="en-US" sz="900" dirty="0"/>
           </a:p>
@@ -18195,6 +18620,10 @@
           </a:solidFill>
           <a:ln/>
         </p:spPr>
+        <p:txBody>
+          <a:bodyPr/>
+          <a:p/>
+        </p:txBody>
       </p:sp>
       <p:sp>
         <p:nvSpPr>
@@ -18307,6 +18736,10 @@
           </a:solidFill>
           <a:ln/>
         </p:spPr>
+        <p:txBody>
+          <a:bodyPr/>
+          <a:p/>
+        </p:txBody>
       </p:sp>
       <p:pic>
         <p:nvPicPr>
@@ -18395,6 +18828,10 @@
           </a:solidFill>
           <a:ln/>
         </p:spPr>
+        <p:txBody>
+          <a:bodyPr/>
+          <a:p/>
+        </p:txBody>
       </p:sp>
       <p:sp>
         <p:nvSpPr>
@@ -18415,6 +18852,10 @@
           </a:solidFill>
           <a:ln/>
         </p:spPr>
+        <p:txBody>
+          <a:bodyPr/>
+          <a:p/>
+        </p:txBody>
       </p:sp>
       <p:pic>
         <p:nvPicPr>
@@ -18542,6 +18983,10 @@
           </a:solidFill>
           <a:ln/>
         </p:spPr>
+        <p:txBody>
+          <a:bodyPr/>
+          <a:p/>
+        </p:txBody>
       </p:sp>
       <p:sp>
         <p:nvSpPr>
@@ -18562,6 +19007,10 @@
           </a:solidFill>
           <a:ln/>
         </p:spPr>
+        <p:txBody>
+          <a:bodyPr/>
+          <a:p/>
+        </p:txBody>
       </p:sp>
       <p:pic>
         <p:nvPicPr>
@@ -18689,6 +19138,10 @@
           </a:solidFill>
           <a:ln/>
         </p:spPr>
+        <p:txBody>
+          <a:bodyPr/>
+          <a:p/>
+        </p:txBody>
       </p:sp>
       <p:sp>
         <p:nvSpPr>
@@ -18709,6 +19162,10 @@
           </a:solidFill>
           <a:ln/>
         </p:spPr>
+        <p:txBody>
+          <a:bodyPr/>
+          <a:p/>
+        </p:txBody>
       </p:sp>
       <p:pic>
         <p:nvPicPr>
@@ -18887,7 +19344,7 @@
                 <a:ea typeface="Calibri" pitchFamily="34" charset="-122"/>
                 <a:cs typeface="Calibri" pitchFamily="34" charset="-120"/>
               </a:rPr>
-              <a:t>23</a:t>
+              <a:t>24</a:t>
             </a:r>
             <a:endParaRPr lang="en-US" sz="900" dirty="0"/>
           </a:p>
@@ -19135,7 +19592,7 @@
                 <a:ea typeface="Calibri" pitchFamily="34" charset="-122"/>
                 <a:cs typeface="Calibri" pitchFamily="34" charset="-120"/>
               </a:rPr>
-              <a:t>Manual_Operacional_BolsaTrader.docx  ·  Versão 10/2026 (rev. 09/10/2026)</a:t>
+              <a:t>Manual_Operacional_BolsaTrader.docx  ·  Versão 10/2026 (rev. 10/10/2026)</a:t>
             </a:r>
             <a:endParaRPr lang="en-US" sz="1050" dirty="0"/>
           </a:p>
@@ -19213,7 +19670,1136 @@
                 <a:ea typeface="Calibri" pitchFamily="34" charset="-122"/>
                 <a:cs typeface="Calibri" pitchFamily="34" charset="-120"/>
               </a:rPr>
-              <a:t>24</a:t>
+              <a:t>25</a:t>
+            </a:r>
+            <a:endParaRPr lang="en-US" sz="900" dirty="0"/>
+          </a:p>
+        </p:txBody>
+      </p:sp>
+    </p:spTree>
+  </p:cSld>
+  <p:clrMapOvr>
+    <a:masterClrMapping/>
+  </p:clrMapOvr>
+</p:sld>
+</file>
+
+<file path=ppt/slides/slide25.xml><?xml version="1.0" encoding="utf-8"?>
+<p:sld xmlns:a="http://schemas.openxmlformats.org/drawingml/2006/main" xmlns:p="http://schemas.openxmlformats.org/presentationml/2006/main" xmlns:r="http://schemas.openxmlformats.org/officeDocument/2006/relationships">
+  <p:cSld>
+    <p:bg>
+      <p:bgPr>
+        <a:solidFill>
+          <a:srgbClr val="FFFFFF"/>
+        </a:solidFill>
+      </p:bgPr>
+    </p:bg>
+    <p:spTree>
+      <p:nvGrpSpPr>
+        <p:cNvPr id="1" name=""/>
+        <p:cNvGrpSpPr/>
+        <p:nvPr/>
+      </p:nvGrpSpPr>
+      <p:grpSpPr/>
+      <p:sp>
+        <p:nvSpPr>
+          <p:cNvPr id="2" name="Text 0"/>
+          <p:cNvSpPr/>
+          <p:nvPr/>
+        </p:nvSpPr>
+        <p:spPr>
+          <a:xfrm>
+            <a:off x="548640" y="457200"/>
+            <a:ext cx="9144000" cy="292608"/>
+          </a:xfrm>
+          <a:prstGeom prst="rect">
+            <a:avLst/>
+          </a:prstGeom>
+          <a:noFill/>
+          <a:ln/>
+        </p:spPr>
+        <p:txBody>
+          <a:bodyPr wrap="square" lIns="0" tIns="0" rIns="0" bIns="0" rtlCol="0" anchor="ctr"/>
+          <a:lstStyle/>
+          <a:p>
+            <a:pPr indent="0" marL="0">
+              <a:buNone/>
+            </a:pPr>
+            <a:r>
+              <a:rPr lang="en-US" sz="1250" b="1" dirty="0">
+                <a:solidFill>
+                  <a:srgbClr val="00D68F"/>
+                </a:solidFill>
+                <a:latin typeface="Calibri" pitchFamily="34" charset="0"/>
+                <a:ea typeface="Calibri" pitchFamily="34" charset="-122"/>
+                <a:cs typeface="Calibri" pitchFamily="34" charset="-120"/>
+              </a:rPr>
+              <a:t>03.1  COMANDO DE VOZ</a:t>
+            </a:r>
+            <a:pPr indent="0" marL="0">
+              <a:buNone/>
+            </a:pPr>
+            <a:endParaRPr lang="en-US" sz="1250" dirty="0"/>
+          </a:p>
+        </p:txBody>
+      </p:sp>
+      <p:sp>
+        <p:nvSpPr>
+          <p:cNvPr id="3" name="Text 1"/>
+          <p:cNvSpPr/>
+          <p:nvPr/>
+        </p:nvSpPr>
+        <p:spPr>
+          <a:xfrm>
+            <a:off x="548640" y="749808"/>
+            <a:ext cx="11094415" cy="640080"/>
+          </a:xfrm>
+          <a:prstGeom prst="rect">
+            <a:avLst/>
+          </a:prstGeom>
+          <a:noFill/>
+          <a:ln/>
+        </p:spPr>
+        <p:txBody>
+          <a:bodyPr wrap="square" lIns="0" tIns="0" rIns="0" bIns="0" rtlCol="0" anchor="ctr"/>
+          <a:lstStyle/>
+          <a:p>
+            <a:pPr indent="0" marL="0">
+              <a:buNone/>
+            </a:pPr>
+            <a:r>
+              <a:rPr lang="en-US" sz="3000" b="1" dirty="0">
+                <a:solidFill>
+                  <a:srgbClr val="0D1B3E"/>
+                </a:solidFill>
+                <a:latin typeface="Calibri" pitchFamily="34" charset="0"/>
+                <a:ea typeface="Calibri" pitchFamily="34" charset="-122"/>
+                <a:cs typeface="Calibri" pitchFamily="34" charset="-120"/>
+              </a:rPr>
+              <a:t>Comando de voz em português</a:t>
+            </a:r>
+            <a:endParaRPr lang="en-US" sz="3000" dirty="0"/>
+          </a:p>
+        </p:txBody>
+      </p:sp>
+      <p:sp>
+        <p:nvSpPr>
+          <p:cNvPr id="4" name="Shape 2"/>
+          <p:cNvSpPr/>
+          <p:nvPr/>
+        </p:nvSpPr>
+        <p:spPr>
+          <a:xfrm>
+            <a:off x="548640" y="1463040"/>
+            <a:ext cx="5364328" cy="1600200"/>
+          </a:xfrm>
+          <a:prstGeom prst="roundRect">
+            <a:avLst>
+              <a:gd name="adj" fmla="val 5143"/>
+            </a:avLst>
+          </a:prstGeom>
+          <a:solidFill>
+            <a:srgbClr val="F3F6FC"/>
+          </a:solidFill>
+          <a:ln/>
+          <a:effectLst>
+            <a:outerShdw sx="100000" sy="100000" kx="0" ky="0" algn="bl" rotWithShape="0" blurRad="101600" dist="25400" dir="5400000">
+              <a:srgbClr val="1B2A55">
+                <a:alpha val="12000"/>
+              </a:srgbClr>
+            </a:outerShdw>
+          </a:effectLst>
+        </p:spPr>
+        <p:txBody>
+          <a:bodyPr/>
+          <a:p/>
+        </p:txBody>
+      </p:sp>
+      <p:sp>
+        <p:nvSpPr>
+          <p:cNvPr id="5" name="Shape 3"/>
+          <p:cNvSpPr/>
+          <p:nvPr/>
+        </p:nvSpPr>
+        <p:spPr>
+          <a:xfrm>
+            <a:off x="804672" y="1700784"/>
+            <a:ext cx="457200" cy="457200"/>
+          </a:xfrm>
+          <a:prstGeom prst="ellipse">
+            <a:avLst/>
+          </a:prstGeom>
+          <a:solidFill>
+            <a:srgbClr val="0D1B3E"/>
+          </a:solidFill>
+          <a:ln/>
+        </p:spPr>
+        <p:txBody>
+          <a:bodyPr/>
+          <a:p/>
+        </p:txBody>
+      </p:sp>
+      <p:pic>
+        <p:nvPicPr>
+          <p:cNvPr id="6" name="Image 0" descr="C:\Users\PC ANTONIO\AppData\Roaming\Claude\scratch-workspaces\f0f5d1bc-bf72-4611-a8ea-e50e459a0a45\08c0c592-3fff-44bf-a144-086c85aaeea0\scratch-2026-09-22-98642c\icons\trendUp.png">    </p:cNvPr>
+          <p:cNvPicPr>
+            <a:picLocks noChangeAspect="1"/>
+          </p:cNvPicPr>
+          <p:nvPr/>
+        </p:nvPicPr>
+        <p:blipFill>
+          <a:blip r:embed="rId2"/>
+          <a:stretch>
+            <a:fillRect/>
+          </a:stretch>
+        </p:blipFill>
+        <p:spPr>
+          <a:xfrm>
+            <a:off x="923544" y="1819656"/>
+            <a:ext cx="219456" cy="219456"/>
+          </a:xfrm>
+          <a:prstGeom prst="rect">
+            <a:avLst/>
+          </a:prstGeom>
+        </p:spPr>
+      </p:pic>
+      <p:sp>
+        <p:nvSpPr>
+          <p:cNvPr id="7" name="Text 4"/>
+          <p:cNvSpPr/>
+          <p:nvPr/>
+        </p:nvSpPr>
+        <p:spPr>
+          <a:xfrm>
+            <a:off x="1426464" y="1645920"/>
+            <a:ext cx="4257904" cy="365760"/>
+          </a:xfrm>
+          <a:prstGeom prst="rect">
+            <a:avLst/>
+          </a:prstGeom>
+          <a:noFill/>
+          <a:ln/>
+        </p:spPr>
+        <p:txBody>
+          <a:bodyPr wrap="square" lIns="0" tIns="0" rIns="0" bIns="0" rtlCol="0" anchor="ctr"/>
+          <a:lstStyle/>
+          <a:p>
+            <a:pPr indent="0" marL="0">
+              <a:buNone/>
+            </a:pPr>
+            <a:r>
+              <a:rPr lang="en-US" sz="1400" b="1" dirty="0">
+                <a:solidFill>
+                  <a:srgbClr val="0D1B3E"/>
+                </a:solidFill>
+                <a:latin typeface="Calibri" pitchFamily="34" charset="0"/>
+                <a:ea typeface="Calibri" pitchFamily="34" charset="-122"/>
+                <a:cs typeface="Calibri" pitchFamily="34" charset="-120"/>
+              </a:rPr>
+              <a:t>Botão 🎤 no cabeçalho</a:t>
+            </a:r>
+            <a:endParaRPr lang="en-US" sz="1400" dirty="0"/>
+          </a:p>
+        </p:txBody>
+      </p:sp>
+      <p:sp>
+        <p:nvSpPr>
+          <p:cNvPr id="8" name="Text 5"/>
+          <p:cNvSpPr/>
+          <p:nvPr/>
+        </p:nvSpPr>
+        <p:spPr>
+          <a:xfrm>
+            <a:off x="804672" y="2286000"/>
+            <a:ext cx="4852264" cy="612648"/>
+          </a:xfrm>
+          <a:prstGeom prst="rect">
+            <a:avLst/>
+          </a:prstGeom>
+          <a:noFill/>
+          <a:ln/>
+        </p:spPr>
+        <p:txBody>
+          <a:bodyPr wrap="square" lIns="0" tIns="0" rIns="0" bIns="0" rtlCol="0" anchor="t"/>
+          <a:lstStyle/>
+          <a:p>
+            <a:pPr indent="0" marL="0">
+              <a:lnSpc>
+                <a:spcPct val="112000"/>
+              </a:lnSpc>
+              <a:buNone/>
+            </a:pPr>
+            <a:r>
+              <a:rPr lang="en-US" sz="1050" dirty="0">
+                <a:solidFill>
+                  <a:srgbClr val="40496B"/>
+                </a:solidFill>
+                <a:latin typeface="Calibri" pitchFamily="34" charset="0"/>
+                <a:ea typeface="Calibri" pitchFamily="34" charset="-122"/>
+                <a:cs typeface="Calibri" pitchFamily="34" charset="-120"/>
+              </a:rPr>
+              <a:t>Clique no 🎤 (ou Ctrl+Espaço) e fale um comando. O botão pulsa em vermelho enquanto escuta e um balão mostra o que foi entendido.</a:t>
+            </a:r>
+            <a:endParaRPr lang="en-US" sz="1050" dirty="0"/>
+          </a:p>
+        </p:txBody>
+      </p:sp>
+      <p:sp>
+        <p:nvSpPr>
+          <p:cNvPr id="9" name="Shape 6"/>
+          <p:cNvSpPr/>
+          <p:nvPr/>
+        </p:nvSpPr>
+        <p:spPr>
+          <a:xfrm>
+            <a:off x="6278728" y="1463040"/>
+            <a:ext cx="5364328" cy="1600200"/>
+          </a:xfrm>
+          <a:prstGeom prst="roundRect">
+            <a:avLst>
+              <a:gd name="adj" fmla="val 5143"/>
+            </a:avLst>
+          </a:prstGeom>
+          <a:solidFill>
+            <a:srgbClr val="F3F6FC"/>
+          </a:solidFill>
+          <a:ln/>
+          <a:effectLst>
+            <a:outerShdw sx="100000" sy="100000" kx="0" ky="0" algn="bl" rotWithShape="0" blurRad="101600" dist="25400" dir="5400000">
+              <a:srgbClr val="1B2A55">
+                <a:alpha val="12000"/>
+              </a:srgbClr>
+            </a:outerShdw>
+          </a:effectLst>
+        </p:spPr>
+        <p:txBody>
+          <a:bodyPr/>
+          <a:p/>
+        </p:txBody>
+      </p:sp>
+      <p:sp>
+        <p:nvSpPr>
+          <p:cNvPr id="10" name="Shape 7"/>
+          <p:cNvSpPr/>
+          <p:nvPr/>
+        </p:nvSpPr>
+        <p:spPr>
+          <a:xfrm>
+            <a:off x="6534760" y="1700784"/>
+            <a:ext cx="457200" cy="457200"/>
+          </a:xfrm>
+          <a:prstGeom prst="ellipse">
+            <a:avLst/>
+          </a:prstGeom>
+          <a:solidFill>
+            <a:srgbClr val="00D68F"/>
+          </a:solidFill>
+          <a:ln/>
+        </p:spPr>
+        <p:txBody>
+          <a:bodyPr/>
+          <a:p/>
+        </p:txBody>
+      </p:sp>
+      <p:pic>
+        <p:nvPicPr>
+          <p:cNvPr id="11" name="Image 1" descr="C:\Users\PC ANTONIO\AppData\Roaming\Claude\scratch-workspaces\f0f5d1bc-bf72-4611-a8ea-e50e459a0a45\08c0c592-3fff-44bf-a144-086c85aaeea0\scratch-2026-09-22-98642c\icons\list.png">    </p:cNvPr>
+          <p:cNvPicPr>
+            <a:picLocks noChangeAspect="1"/>
+          </p:cNvPicPr>
+          <p:nvPr/>
+        </p:nvPicPr>
+        <p:blipFill>
+          <a:blip r:embed="rId3"/>
+          <a:stretch>
+            <a:fillRect/>
+          </a:stretch>
+        </p:blipFill>
+        <p:spPr>
+          <a:xfrm>
+            <a:off x="6653632" y="1819656"/>
+            <a:ext cx="219456" cy="219456"/>
+          </a:xfrm>
+          <a:prstGeom prst="rect">
+            <a:avLst/>
+          </a:prstGeom>
+        </p:spPr>
+      </p:pic>
+      <p:sp>
+        <p:nvSpPr>
+          <p:cNvPr id="12" name="Text 8"/>
+          <p:cNvSpPr/>
+          <p:nvPr/>
+        </p:nvSpPr>
+        <p:spPr>
+          <a:xfrm>
+            <a:off x="7156552" y="1645920"/>
+            <a:ext cx="4257904" cy="365760"/>
+          </a:xfrm>
+          <a:prstGeom prst="rect">
+            <a:avLst/>
+          </a:prstGeom>
+          <a:noFill/>
+          <a:ln/>
+        </p:spPr>
+        <p:txBody>
+          <a:bodyPr wrap="square" lIns="0" tIns="0" rIns="0" bIns="0" rtlCol="0" anchor="ctr"/>
+          <a:lstStyle/>
+          <a:p>
+            <a:pPr indent="0" marL="0">
+              <a:buNone/>
+            </a:pPr>
+            <a:r>
+              <a:rPr lang="en-US" sz="1400" b="1" dirty="0">
+                <a:solidFill>
+                  <a:srgbClr val="0D1B3E"/>
+                </a:solidFill>
+                <a:latin typeface="Calibri" pitchFamily="34" charset="0"/>
+                <a:ea typeface="Calibri" pitchFamily="34" charset="-122"/>
+                <a:cs typeface="Calibri" pitchFamily="34" charset="-120"/>
+              </a:rPr>
+              <a:t>Navegar falando</a:t>
+            </a:r>
+            <a:endParaRPr lang="en-US" sz="1400" dirty="0"/>
+          </a:p>
+        </p:txBody>
+      </p:sp>
+      <p:sp>
+        <p:nvSpPr>
+          <p:cNvPr id="13" name="Text 9"/>
+          <p:cNvSpPr/>
+          <p:nvPr/>
+        </p:nvSpPr>
+        <p:spPr>
+          <a:xfrm>
+            <a:off x="6534760" y="2286000"/>
+            <a:ext cx="4852264" cy="612648"/>
+          </a:xfrm>
+          <a:prstGeom prst="rect">
+            <a:avLst/>
+          </a:prstGeom>
+          <a:noFill/>
+          <a:ln/>
+        </p:spPr>
+        <p:txBody>
+          <a:bodyPr wrap="square" lIns="0" tIns="0" rIns="0" bIns="0" rtlCol="0" anchor="t"/>
+          <a:lstStyle/>
+          <a:p>
+            <a:pPr indent="0" marL="0">
+              <a:lnSpc>
+                <a:spcPct val="112000"/>
+              </a:lnSpc>
+              <a:buNone/>
+            </a:pPr>
+            <a:r>
+              <a:rPr lang="en-US" sz="1050" dirty="0">
+                <a:solidFill>
+                  <a:srgbClr val="40496B"/>
+                </a:solidFill>
+                <a:latin typeface="Calibri" pitchFamily="34" charset="0"/>
+                <a:ea typeface="Calibri" pitchFamily="34" charset="-122"/>
+                <a:cs typeface="Calibri" pitchFamily="34" charset="-120"/>
+              </a:rPr>
+              <a:t>"posições", "operações", "nova operação", "alertas", "notícias", "conta corrente", "cripto", "scanner", "menu", "voltar"...</a:t>
+            </a:r>
+            <a:endParaRPr lang="en-US" sz="1050" dirty="0"/>
+          </a:p>
+        </p:txBody>
+      </p:sp>
+      <p:sp>
+        <p:nvSpPr>
+          <p:cNvPr id="14" name="Shape 10"/>
+          <p:cNvSpPr/>
+          <p:nvPr/>
+        </p:nvSpPr>
+        <p:spPr>
+          <a:xfrm>
+            <a:off x="548640" y="3246120"/>
+            <a:ext cx="5364328" cy="1280160"/>
+          </a:xfrm>
+          <a:prstGeom prst="roundRect">
+            <a:avLst>
+              <a:gd name="adj" fmla="val 6429"/>
+            </a:avLst>
+          </a:prstGeom>
+          <a:solidFill>
+            <a:srgbClr val="F3F6FC"/>
+          </a:solidFill>
+          <a:ln/>
+          <a:effectLst>
+            <a:outerShdw sx="100000" sy="100000" kx="0" ky="0" algn="bl" rotWithShape="0" blurRad="101600" dist="25400" dir="5400000">
+              <a:srgbClr val="1B2A55">
+                <a:alpha val="12000"/>
+              </a:srgbClr>
+            </a:outerShdw>
+          </a:effectLst>
+        </p:spPr>
+        <p:txBody>
+          <a:bodyPr/>
+          <a:p/>
+        </p:txBody>
+      </p:sp>
+      <p:sp>
+        <p:nvSpPr>
+          <p:cNvPr id="15" name="Shape 11"/>
+          <p:cNvSpPr/>
+          <p:nvPr/>
+        </p:nvSpPr>
+        <p:spPr>
+          <a:xfrm>
+            <a:off x="804672" y="3483864"/>
+            <a:ext cx="310896" cy="310896"/>
+          </a:xfrm>
+          <a:prstGeom prst="ellipse">
+            <a:avLst/>
+          </a:prstGeom>
+          <a:solidFill>
+            <a:srgbClr val="0D1B3E"/>
+          </a:solidFill>
+          <a:ln/>
+        </p:spPr>
+        <p:txBody>
+          <a:bodyPr/>
+          <a:p/>
+        </p:txBody>
+      </p:sp>
+      <p:pic>
+        <p:nvPicPr>
+          <p:cNvPr id="16" name="Image 2" descr="C:\Users\PC ANTONIO\AppData\Roaming\Claude\scratch-workspaces\f0f5d1bc-bf72-4611-a8ea-e50e459a0a45\08c0c592-3fff-44bf-a144-086c85aaeea0\scratch-2026-09-22-98642c\icons\search.png">    </p:cNvPr>
+          <p:cNvPicPr>
+            <a:picLocks noChangeAspect="1"/>
+          </p:cNvPicPr>
+          <p:nvPr/>
+        </p:nvPicPr>
+        <p:blipFill>
+          <a:blip r:embed="rId4"/>
+          <a:stretch>
+            <a:fillRect/>
+          </a:stretch>
+        </p:blipFill>
+        <p:spPr>
+          <a:xfrm>
+            <a:off x="885505" y="3564697"/>
+            <a:ext cx="149230" cy="149230"/>
+          </a:xfrm>
+          <a:prstGeom prst="rect">
+            <a:avLst/>
+          </a:prstGeom>
+        </p:spPr>
+      </p:pic>
+      <p:sp>
+        <p:nvSpPr>
+          <p:cNvPr id="17" name="Text 12"/>
+          <p:cNvSpPr/>
+          <p:nvPr/>
+        </p:nvSpPr>
+        <p:spPr>
+          <a:xfrm>
+            <a:off x="1280160" y="3429000"/>
+            <a:ext cx="4404208" cy="365760"/>
+          </a:xfrm>
+          <a:prstGeom prst="rect">
+            <a:avLst/>
+          </a:prstGeom>
+          <a:noFill/>
+          <a:ln/>
+        </p:spPr>
+        <p:txBody>
+          <a:bodyPr wrap="square" lIns="0" tIns="0" rIns="0" bIns="0" rtlCol="0" anchor="ctr"/>
+          <a:lstStyle/>
+          <a:p>
+            <a:pPr indent="0" marL="0">
+              <a:buNone/>
+            </a:pPr>
+            <a:r>
+              <a:rPr lang="en-US" sz="1350" b="1" dirty="0">
+                <a:solidFill>
+                  <a:srgbClr val="0D1B3E"/>
+                </a:solidFill>
+                <a:latin typeface="Calibri" pitchFamily="34" charset="0"/>
+                <a:ea typeface="Calibri" pitchFamily="34" charset="-122"/>
+                <a:cs typeface="Calibri" pitchFamily="34" charset="-120"/>
+              </a:rPr>
+              <a:t>Atualizar</a:t>
+            </a:r>
+            <a:endParaRPr lang="en-US" sz="1350" dirty="0"/>
+          </a:p>
+        </p:txBody>
+      </p:sp>
+      <p:sp>
+        <p:nvSpPr>
+          <p:cNvPr id="18" name="Text 13"/>
+          <p:cNvSpPr/>
+          <p:nvPr/>
+        </p:nvSpPr>
+        <p:spPr>
+          <a:xfrm>
+            <a:off x="804672" y="3922776"/>
+            <a:ext cx="4852264" cy="438912"/>
+          </a:xfrm>
+          <a:prstGeom prst="rect">
+            <a:avLst/>
+          </a:prstGeom>
+          <a:noFill/>
+          <a:ln/>
+        </p:spPr>
+        <p:txBody>
+          <a:bodyPr wrap="square" lIns="0" tIns="0" rIns="0" bIns="0" rtlCol="0" anchor="t"/>
+          <a:lstStyle/>
+          <a:p>
+            <a:pPr indent="0" marL="0">
+              <a:lnSpc>
+                <a:spcPct val="112000"/>
+              </a:lnSpc>
+              <a:buNone/>
+            </a:pPr>
+            <a:r>
+              <a:rPr lang="en-US" sz="1050" dirty="0">
+                <a:solidFill>
+                  <a:srgbClr val="40496B"/>
+                </a:solidFill>
+                <a:latin typeface="Calibri" pitchFamily="34" charset="0"/>
+                <a:ea typeface="Calibri" pitchFamily="34" charset="-122"/>
+                <a:cs typeface="Calibri" pitchFamily="34" charset="-120"/>
+              </a:rPr>
+              <a:t>"atualizar cotações", "atualizar cripto" e "atualizar notícias" — o mesmo efeito dos botões.</a:t>
+            </a:r>
+            <a:endParaRPr lang="en-US" sz="1050" dirty="0"/>
+          </a:p>
+        </p:txBody>
+      </p:sp>
+      <p:sp>
+        <p:nvSpPr>
+          <p:cNvPr id="19" name="Shape 14"/>
+          <p:cNvSpPr/>
+          <p:nvPr/>
+        </p:nvSpPr>
+        <p:spPr>
+          <a:xfrm>
+            <a:off x="6278728" y="3246120"/>
+            <a:ext cx="5364328" cy="1280160"/>
+          </a:xfrm>
+          <a:prstGeom prst="roundRect">
+            <a:avLst>
+              <a:gd name="adj" fmla="val 6429"/>
+            </a:avLst>
+          </a:prstGeom>
+          <a:solidFill>
+            <a:srgbClr val="F3F6FC"/>
+          </a:solidFill>
+          <a:ln/>
+          <a:effectLst>
+            <a:outerShdw sx="100000" sy="100000" kx="0" ky="0" algn="bl" rotWithShape="0" blurRad="101600" dist="25400" dir="5400000">
+              <a:srgbClr val="1B2A55">
+                <a:alpha val="12000"/>
+              </a:srgbClr>
+            </a:outerShdw>
+          </a:effectLst>
+        </p:spPr>
+        <p:txBody>
+          <a:bodyPr/>
+          <a:p/>
+        </p:txBody>
+      </p:sp>
+      <p:sp>
+        <p:nvSpPr>
+          <p:cNvPr id="20" name="Shape 15"/>
+          <p:cNvSpPr/>
+          <p:nvPr/>
+        </p:nvSpPr>
+        <p:spPr>
+          <a:xfrm>
+            <a:off x="6534760" y="3483864"/>
+            <a:ext cx="310896" cy="310896"/>
+          </a:xfrm>
+          <a:prstGeom prst="ellipse">
+            <a:avLst/>
+          </a:prstGeom>
+          <a:solidFill>
+            <a:srgbClr val="00D68F"/>
+          </a:solidFill>
+          <a:ln/>
+        </p:spPr>
+        <p:txBody>
+          <a:bodyPr/>
+          <a:p/>
+        </p:txBody>
+      </p:sp>
+      <p:pic>
+        <p:nvPicPr>
+          <p:cNvPr id="21" name="Image 3" descr="C:\Users\PC ANTONIO\AppData\Roaming\Claude\scratch-workspaces\f0f5d1bc-bf72-4611-a8ea-e50e459a0a45\08c0c592-3fff-44bf-a144-086c85aaeea0\scratch-2026-09-22-98642c\icons\activity.png">    </p:cNvPr>
+          <p:cNvPicPr>
+            <a:picLocks noChangeAspect="1"/>
+          </p:cNvPicPr>
+          <p:nvPr/>
+        </p:nvPicPr>
+        <p:blipFill>
+          <a:blip r:embed="rId5"/>
+          <a:stretch>
+            <a:fillRect/>
+          </a:stretch>
+        </p:blipFill>
+        <p:spPr>
+          <a:xfrm>
+            <a:off x="6615593" y="3564697"/>
+            <a:ext cx="149230" cy="149230"/>
+          </a:xfrm>
+          <a:prstGeom prst="rect">
+            <a:avLst/>
+          </a:prstGeom>
+        </p:spPr>
+      </p:pic>
+      <p:sp>
+        <p:nvSpPr>
+          <p:cNvPr id="22" name="Text 16"/>
+          <p:cNvSpPr/>
+          <p:nvPr/>
+        </p:nvSpPr>
+        <p:spPr>
+          <a:xfrm>
+            <a:off x="7010248" y="3429000"/>
+            <a:ext cx="4404208" cy="365760"/>
+          </a:xfrm>
+          <a:prstGeom prst="rect">
+            <a:avLst/>
+          </a:prstGeom>
+          <a:noFill/>
+          <a:ln/>
+        </p:spPr>
+        <p:txBody>
+          <a:bodyPr wrap="square" lIns="0" tIns="0" rIns="0" bIns="0" rtlCol="0" anchor="ctr"/>
+          <a:lstStyle/>
+          <a:p>
+            <a:pPr indent="0" marL="0">
+              <a:buNone/>
+            </a:pPr>
+            <a:r>
+              <a:rPr lang="en-US" sz="1350" b="1" dirty="0">
+                <a:solidFill>
+                  <a:srgbClr val="0D1B3E"/>
+                </a:solidFill>
+                <a:latin typeface="Calibri" pitchFamily="34" charset="0"/>
+                <a:ea typeface="Calibri" pitchFamily="34" charset="-122"/>
+                <a:cs typeface="Calibri" pitchFamily="34" charset="-120"/>
+              </a:rPr>
+              <a:t>Consultar uma cotação</a:t>
+            </a:r>
+            <a:endParaRPr lang="en-US" sz="1350" dirty="0"/>
+          </a:p>
+        </p:txBody>
+      </p:sp>
+      <p:sp>
+        <p:nvSpPr>
+          <p:cNvPr id="23" name="Text 17"/>
+          <p:cNvSpPr/>
+          <p:nvPr/>
+        </p:nvSpPr>
+        <p:spPr>
+          <a:xfrm>
+            <a:off x="6534760" y="3922776"/>
+            <a:ext cx="4852264" cy="438912"/>
+          </a:xfrm>
+          <a:prstGeom prst="rect">
+            <a:avLst/>
+          </a:prstGeom>
+          <a:noFill/>
+          <a:ln/>
+        </p:spPr>
+        <p:txBody>
+          <a:bodyPr wrap="square" lIns="0" tIns="0" rIns="0" bIns="0" rtlCol="0" anchor="t"/>
+          <a:lstStyle/>
+          <a:p>
+            <a:pPr indent="0" marL="0">
+              <a:lnSpc>
+                <a:spcPct val="112000"/>
+              </a:lnSpc>
+              <a:buNone/>
+            </a:pPr>
+            <a:r>
+              <a:rPr lang="en-US" sz="1050" dirty="0">
+                <a:solidFill>
+                  <a:srgbClr val="40496B"/>
+                </a:solidFill>
+                <a:latin typeface="Calibri" pitchFamily="34" charset="0"/>
+                <a:ea typeface="Calibri" pitchFamily="34" charset="-122"/>
+                <a:cs typeface="Calibri" pitchFamily="34" charset="-120"/>
+              </a:rPr>
+              <a:t>"cotação de PETR4" ou "preço do BOVA 11" abrem Detalhes de Cotações já pesquisando o ticker.</a:t>
+            </a:r>
+            <a:endParaRPr lang="en-US" sz="1050" dirty="0"/>
+          </a:p>
+        </p:txBody>
+      </p:sp>
+      <p:sp>
+        <p:nvSpPr>
+          <p:cNvPr id="24" name="Text 18"/>
+          <p:cNvSpPr/>
+          <p:nvPr/>
+        </p:nvSpPr>
+        <p:spPr>
+          <a:xfrm>
+            <a:off x="548640" y="4709160"/>
+            <a:ext cx="7315200" cy="274320"/>
+          </a:xfrm>
+          <a:prstGeom prst="rect">
+            <a:avLst/>
+          </a:prstGeom>
+          <a:noFill/>
+          <a:ln/>
+        </p:spPr>
+        <p:txBody>
+          <a:bodyPr wrap="square" lIns="0" tIns="0" rIns="0" bIns="0" rtlCol="0" anchor="ctr"/>
+          <a:lstStyle/>
+          <a:p>
+            <a:pPr indent="0" marL="0">
+              <a:buNone/>
+            </a:pPr>
+            <a:r>
+              <a:rPr lang="en-US" sz="1350" b="1" dirty="0">
+                <a:solidFill>
+                  <a:srgbClr val="0D1B3E"/>
+                </a:solidFill>
+                <a:latin typeface="Calibri" pitchFamily="34" charset="0"/>
+                <a:ea typeface="Calibri" pitchFamily="34" charset="-122"/>
+                <a:cs typeface="Calibri" pitchFamily="34" charset="-120"/>
+              </a:rPr>
+              <a:t>Dicas e requisitos</a:t>
+            </a:r>
+            <a:endParaRPr lang="en-US" sz="1350" dirty="0"/>
+          </a:p>
+        </p:txBody>
+      </p:sp>
+      <p:sp>
+        <p:nvSpPr>
+          <p:cNvPr id="25" name="Shape 19"/>
+          <p:cNvSpPr/>
+          <p:nvPr/>
+        </p:nvSpPr>
+        <p:spPr>
+          <a:xfrm>
+            <a:off x="548640" y="5074920"/>
+            <a:ext cx="384048" cy="384048"/>
+          </a:xfrm>
+          <a:prstGeom prst="ellipse">
+            <a:avLst/>
+          </a:prstGeom>
+          <a:solidFill>
+            <a:srgbClr val="00D68F"/>
+          </a:solidFill>
+          <a:ln/>
+        </p:spPr>
+        <p:txBody>
+          <a:bodyPr/>
+          <a:p/>
+        </p:txBody>
+      </p:sp>
+      <p:pic>
+        <p:nvPicPr>
+          <p:cNvPr id="26" name="Image 4" descr="C:\Users\PC ANTONIO\AppData\Roaming\Claude\scratch-workspaces\f0f5d1bc-bf72-4611-a8ea-e50e459a0a45\08c0c592-3fff-44bf-a144-086c85aaeea0\scratch-2026-09-22-98642c\icons\trendUp.png">    </p:cNvPr>
+          <p:cNvPicPr>
+            <a:picLocks noChangeAspect="1"/>
+          </p:cNvPicPr>
+          <p:nvPr/>
+        </p:nvPicPr>
+        <p:blipFill>
+          <a:blip r:embed="rId6"/>
+          <a:stretch>
+            <a:fillRect/>
+          </a:stretch>
+        </p:blipFill>
+        <p:spPr>
+          <a:xfrm>
+            <a:off x="640812" y="5167092"/>
+            <a:ext cx="199705" cy="199705"/>
+          </a:xfrm>
+          <a:prstGeom prst="rect">
+            <a:avLst/>
+          </a:prstGeom>
+        </p:spPr>
+      </p:pic>
+      <p:sp>
+        <p:nvSpPr>
+          <p:cNvPr id="27" name="Text 20"/>
+          <p:cNvSpPr/>
+          <p:nvPr/>
+        </p:nvSpPr>
+        <p:spPr>
+          <a:xfrm>
+            <a:off x="1078992" y="5038344"/>
+            <a:ext cx="4833976" cy="256032"/>
+          </a:xfrm>
+          <a:prstGeom prst="rect">
+            <a:avLst/>
+          </a:prstGeom>
+          <a:noFill/>
+          <a:ln/>
+        </p:spPr>
+        <p:txBody>
+          <a:bodyPr wrap="square" lIns="0" tIns="0" rIns="0" bIns="0" rtlCol="0" anchor="ctr"/>
+          <a:lstStyle/>
+          <a:p>
+            <a:pPr indent="0" marL="0">
+              <a:buNone/>
+            </a:pPr>
+            <a:r>
+              <a:rPr lang="en-US" sz="1250" b="1" dirty="0">
+                <a:solidFill>
+                  <a:srgbClr val="0D1B3E"/>
+                </a:solidFill>
+                <a:latin typeface="Calibri" pitchFamily="34" charset="0"/>
+                <a:ea typeface="Calibri" pitchFamily="34" charset="-122"/>
+                <a:cs typeface="Calibri" pitchFamily="34" charset="-120"/>
+              </a:rPr>
+              <a:t>Diga "ajuda"</a:t>
+            </a:r>
+            <a:endParaRPr lang="en-US" sz="1250" dirty="0"/>
+          </a:p>
+        </p:txBody>
+      </p:sp>
+      <p:sp>
+        <p:nvSpPr>
+          <p:cNvPr id="28" name="Text 21"/>
+          <p:cNvSpPr/>
+          <p:nvPr/>
+        </p:nvSpPr>
+        <p:spPr>
+          <a:xfrm>
+            <a:off x="1078992" y="5294376"/>
+            <a:ext cx="4833976" cy="640080"/>
+          </a:xfrm>
+          <a:prstGeom prst="rect">
+            <a:avLst/>
+          </a:prstGeom>
+          <a:noFill/>
+          <a:ln/>
+        </p:spPr>
+        <p:txBody>
+          <a:bodyPr wrap="square" lIns="0" tIns="0" rIns="0" bIns="0" rtlCol="0" anchor="ctr"/>
+          <a:lstStyle/>
+          <a:p>
+            <a:pPr indent="0" marL="0">
+              <a:lnSpc>
+                <a:spcPct val="110000"/>
+              </a:lnSpc>
+              <a:buNone/>
+            </a:pPr>
+            <a:r>
+              <a:rPr lang="en-US" sz="1000" dirty="0">
+                <a:solidFill>
+                  <a:srgbClr val="40496B"/>
+                </a:solidFill>
+                <a:latin typeface="Calibri" pitchFamily="34" charset="0"/>
+                <a:ea typeface="Calibri" pitchFamily="34" charset="-122"/>
+                <a:cs typeface="Calibri" pitchFamily="34" charset="-120"/>
+              </a:rPr>
+              <a:t>O balão lista os comandos disponíveis. Se a frase não for reconhecida, o sistema avisa e nada é executado.</a:t>
+            </a:r>
+            <a:endParaRPr lang="en-US" sz="1000" dirty="0"/>
+          </a:p>
+        </p:txBody>
+      </p:sp>
+      <p:sp>
+        <p:nvSpPr>
+          <p:cNvPr id="29" name="Shape 22"/>
+          <p:cNvSpPr/>
+          <p:nvPr/>
+        </p:nvSpPr>
+        <p:spPr>
+          <a:xfrm>
+            <a:off x="6278728" y="5074920"/>
+            <a:ext cx="384048" cy="384048"/>
+          </a:xfrm>
+          <a:prstGeom prst="ellipse">
+            <a:avLst/>
+          </a:prstGeom>
+          <a:solidFill>
+            <a:srgbClr val="E1495A"/>
+          </a:solidFill>
+          <a:ln/>
+        </p:spPr>
+        <p:txBody>
+          <a:bodyPr/>
+          <a:p/>
+        </p:txBody>
+      </p:sp>
+      <p:pic>
+        <p:nvPicPr>
+          <p:cNvPr id="30" name="Image 5" descr="C:\Users\PC ANTONIO\AppData\Roaming\Claude\scratch-workspaces\f0f5d1bc-bf72-4611-a8ea-e50e459a0a45\08c0c592-3fff-44bf-a144-086c85aaeea0\scratch-2026-09-22-98642c\icons\trendDown.png">    </p:cNvPr>
+          <p:cNvPicPr>
+            <a:picLocks noChangeAspect="1"/>
+          </p:cNvPicPr>
+          <p:nvPr/>
+        </p:nvPicPr>
+        <p:blipFill>
+          <a:blip r:embed="rId7"/>
+          <a:stretch>
+            <a:fillRect/>
+          </a:stretch>
+        </p:blipFill>
+        <p:spPr>
+          <a:xfrm>
+            <a:off x="6370899" y="5167092"/>
+            <a:ext cx="199705" cy="199705"/>
+          </a:xfrm>
+          <a:prstGeom prst="rect">
+            <a:avLst/>
+          </a:prstGeom>
+        </p:spPr>
+      </p:pic>
+      <p:sp>
+        <p:nvSpPr>
+          <p:cNvPr id="31" name="Text 23"/>
+          <p:cNvSpPr/>
+          <p:nvPr/>
+        </p:nvSpPr>
+        <p:spPr>
+          <a:xfrm>
+            <a:off x="6809080" y="5038344"/>
+            <a:ext cx="4833976" cy="256032"/>
+          </a:xfrm>
+          <a:prstGeom prst="rect">
+            <a:avLst/>
+          </a:prstGeom>
+          <a:noFill/>
+          <a:ln/>
+        </p:spPr>
+        <p:txBody>
+          <a:bodyPr wrap="square" lIns="0" tIns="0" rIns="0" bIns="0" rtlCol="0" anchor="ctr"/>
+          <a:lstStyle/>
+          <a:p>
+            <a:pPr indent="0" marL="0">
+              <a:buNone/>
+            </a:pPr>
+            <a:r>
+              <a:rPr lang="en-US" sz="1250" b="1" dirty="0">
+                <a:solidFill>
+                  <a:srgbClr val="0D1B3E"/>
+                </a:solidFill>
+                <a:latin typeface="Calibri" pitchFamily="34" charset="0"/>
+                <a:ea typeface="Calibri" pitchFamily="34" charset="-122"/>
+                <a:cs typeface="Calibri" pitchFamily="34" charset="-120"/>
+              </a:rPr>
+              <a:t>Chrome ou Edge, com microfone</a:t>
+            </a:r>
+            <a:endParaRPr lang="en-US" sz="1250" dirty="0"/>
+          </a:p>
+        </p:txBody>
+      </p:sp>
+      <p:sp>
+        <p:nvSpPr>
+          <p:cNvPr id="32" name="Text 24"/>
+          <p:cNvSpPr/>
+          <p:nvPr/>
+        </p:nvSpPr>
+        <p:spPr>
+          <a:xfrm>
+            <a:off x="6809080" y="5294376"/>
+            <a:ext cx="4833976" cy="640080"/>
+          </a:xfrm>
+          <a:prstGeom prst="rect">
+            <a:avLst/>
+          </a:prstGeom>
+          <a:noFill/>
+          <a:ln/>
+        </p:spPr>
+        <p:txBody>
+          <a:bodyPr wrap="square" lIns="0" tIns="0" rIns="0" bIns="0" rtlCol="0" anchor="ctr"/>
+          <a:lstStyle/>
+          <a:p>
+            <a:pPr indent="0" marL="0">
+              <a:lnSpc>
+                <a:spcPct val="110000"/>
+              </a:lnSpc>
+              <a:buNone/>
+            </a:pPr>
+            <a:r>
+              <a:rPr lang="en-US" sz="1000" dirty="0">
+                <a:solidFill>
+                  <a:srgbClr val="40496B"/>
+                </a:solidFill>
+                <a:latin typeface="Calibri" pitchFamily="34" charset="0"/>
+                <a:ea typeface="Calibri" pitchFamily="34" charset="-122"/>
+                <a:cs typeface="Calibri" pitchFamily="34" charset="-120"/>
+              </a:rPr>
+              <a:t>Permitir o microfone na 1ª vez; fora do computador local o site precisa estar em HTTPS. No Firefox o botão não aparece.</a:t>
+            </a:r>
+            <a:endParaRPr lang="en-US" sz="1000" dirty="0"/>
+          </a:p>
+        </p:txBody>
+      </p:sp>
+      <p:sp>
+        <p:nvSpPr>
+          <p:cNvPr id="33" name="Text 25"/>
+          <p:cNvSpPr/>
+          <p:nvPr/>
+        </p:nvSpPr>
+        <p:spPr>
+          <a:xfrm>
+            <a:off x="548640" y="6473952"/>
+            <a:ext cx="7315200" cy="274320"/>
+          </a:xfrm>
+          <a:prstGeom prst="rect">
+            <a:avLst/>
+          </a:prstGeom>
+          <a:noFill/>
+          <a:ln/>
+        </p:spPr>
+        <p:txBody>
+          <a:bodyPr wrap="square" lIns="0" tIns="0" rIns="0" bIns="0" rtlCol="0" anchor="ctr"/>
+          <a:lstStyle/>
+          <a:p>
+            <a:pPr algn="l" indent="0" marL="0">
+              <a:buNone/>
+            </a:pPr>
+            <a:r>
+              <a:rPr lang="en-US" sz="900" dirty="0">
+                <a:solidFill>
+                  <a:srgbClr val="7C89A8"/>
+                </a:solidFill>
+                <a:latin typeface="Calibri" pitchFamily="34" charset="0"/>
+                <a:ea typeface="Calibri" pitchFamily="34" charset="-122"/>
+                <a:cs typeface="Calibri" pitchFamily="34" charset="-120"/>
+              </a:rPr>
+              <a:t>BolsaTrader  ·  Manual Operacional do Sistema</a:t>
+            </a:r>
+            <a:endParaRPr lang="en-US" sz="900" dirty="0"/>
+          </a:p>
+        </p:txBody>
+      </p:sp>
+      <p:sp>
+        <p:nvSpPr>
+          <p:cNvPr id="34" name="Text 26"/>
+          <p:cNvSpPr/>
+          <p:nvPr/>
+        </p:nvSpPr>
+        <p:spPr>
+          <a:xfrm>
+            <a:off x="10728655" y="6473952"/>
+            <a:ext cx="914400" cy="274320"/>
+          </a:xfrm>
+          <a:prstGeom prst="rect">
+            <a:avLst/>
+          </a:prstGeom>
+          <a:noFill/>
+          <a:ln/>
+        </p:spPr>
+        <p:txBody>
+          <a:bodyPr wrap="square" lIns="0" tIns="0" rIns="0" bIns="0" rtlCol="0" anchor="ctr"/>
+          <a:lstStyle/>
+          <a:p>
+            <a:pPr algn="r" indent="0" marL="0">
+              <a:buNone/>
+            </a:pPr>
+            <a:r>
+              <a:rPr lang="en-US" sz="900" dirty="0">
+                <a:solidFill>
+                  <a:srgbClr val="7C89A8"/>
+                </a:solidFill>
+                <a:latin typeface="Calibri" pitchFamily="34" charset="0"/>
+                <a:ea typeface="Calibri" pitchFamily="34" charset="-122"/>
+                <a:cs typeface="Calibri" pitchFamily="34" charset="-120"/>
+              </a:rPr>
+              <a:t>07</a:t>
             </a:r>
             <a:endParaRPr lang="en-US" sz="900" dirty="0"/>
           </a:p>
@@ -19413,6 +20999,10 @@
             </a:outerShdw>
           </a:effectLst>
         </p:spPr>
+        <p:txBody>
+          <a:bodyPr/>
+          <a:p/>
+        </p:txBody>
       </p:sp>
       <p:sp>
         <p:nvSpPr>
@@ -19433,6 +21023,10 @@
           </a:solidFill>
           <a:ln/>
         </p:spPr>
+        <p:txBody>
+          <a:bodyPr/>
+          <a:p/>
+        </p:txBody>
       </p:sp>
       <p:pic>
         <p:nvPicPr>
@@ -19567,6 +21161,10 @@
             </a:outerShdw>
           </a:effectLst>
         </p:spPr>
+        <p:txBody>
+          <a:bodyPr/>
+          <a:p/>
+        </p:txBody>
       </p:sp>
       <p:sp>
         <p:nvSpPr>
@@ -19587,6 +21185,10 @@
           </a:solidFill>
           <a:ln/>
         </p:spPr>
+        <p:txBody>
+          <a:bodyPr/>
+          <a:p/>
+        </p:txBody>
       </p:sp>
       <p:pic>
         <p:nvPicPr>
@@ -19721,6 +21323,10 @@
             </a:outerShdw>
           </a:effectLst>
         </p:spPr>
+        <p:txBody>
+          <a:bodyPr/>
+          <a:p/>
+        </p:txBody>
       </p:sp>
       <p:sp>
         <p:nvSpPr>
@@ -19741,6 +21347,10 @@
           </a:solidFill>
           <a:ln/>
         </p:spPr>
+        <p:txBody>
+          <a:bodyPr/>
+          <a:p/>
+        </p:txBody>
       </p:sp>
       <p:pic>
         <p:nvPicPr>
@@ -19875,6 +21485,10 @@
             </a:outerShdw>
           </a:effectLst>
         </p:spPr>
+        <p:txBody>
+          <a:bodyPr/>
+          <a:p/>
+        </p:txBody>
       </p:sp>
       <p:sp>
         <p:nvSpPr>
@@ -19895,6 +21509,10 @@
           </a:solidFill>
           <a:ln/>
         </p:spPr>
+        <p:txBody>
+          <a:bodyPr/>
+          <a:p/>
+        </p:txBody>
       </p:sp>
       <p:pic>
         <p:nvPicPr>
@@ -20022,6 +21640,10 @@
           </a:solidFill>
           <a:ln/>
         </p:spPr>
+        <p:txBody>
+          <a:bodyPr/>
+          <a:p/>
+        </p:txBody>
       </p:sp>
       <p:sp>
         <p:nvSpPr>
@@ -20042,6 +21664,10 @@
           </a:solidFill>
           <a:ln/>
         </p:spPr>
+        <p:txBody>
+          <a:bodyPr/>
+          <a:p/>
+        </p:txBody>
       </p:sp>
       <p:pic>
         <p:nvPicPr>
@@ -20339,6 +21965,10 @@
             </a:outerShdw>
           </a:effectLst>
         </p:spPr>
+        <p:txBody>
+          <a:bodyPr/>
+          <a:p/>
+        </p:txBody>
       </p:sp>
       <p:sp>
         <p:nvSpPr>
@@ -20359,6 +21989,10 @@
           </a:solidFill>
           <a:ln/>
         </p:spPr>
+        <p:txBody>
+          <a:bodyPr/>
+          <a:p/>
+        </p:txBody>
       </p:sp>
       <p:pic>
         <p:nvPicPr>
@@ -20493,6 +22127,10 @@
             </a:outerShdw>
           </a:effectLst>
         </p:spPr>
+        <p:txBody>
+          <a:bodyPr/>
+          <a:p/>
+        </p:txBody>
       </p:sp>
       <p:sp>
         <p:nvSpPr>
@@ -20513,6 +22151,10 @@
           </a:solidFill>
           <a:ln/>
         </p:spPr>
+        <p:txBody>
+          <a:bodyPr/>
+          <a:p/>
+        </p:txBody>
       </p:sp>
       <p:pic>
         <p:nvPicPr>
@@ -20677,6 +22319,10 @@
           </a:solidFill>
           <a:ln/>
         </p:spPr>
+        <p:txBody>
+          <a:bodyPr/>
+          <a:p/>
+        </p:txBody>
       </p:sp>
       <p:pic>
         <p:nvPicPr>
@@ -20802,6 +22448,10 @@
           </a:solidFill>
           <a:ln/>
         </p:spPr>
+        <p:txBody>
+          <a:bodyPr/>
+          <a:p/>
+        </p:txBody>
       </p:sp>
       <p:pic>
         <p:nvPicPr>
@@ -20927,6 +22577,10 @@
           </a:solidFill>
           <a:ln/>
         </p:spPr>
+        <p:txBody>
+          <a:bodyPr/>
+          <a:p/>
+        </p:txBody>
       </p:sp>
       <p:pic>
         <p:nvPicPr>
@@ -21254,6 +22908,10 @@
           </a:solidFill>
           <a:ln/>
         </p:spPr>
+        <p:txBody>
+          <a:bodyPr/>
+          <a:p/>
+        </p:txBody>
       </p:sp>
       <p:pic>
         <p:nvPicPr>
@@ -21379,6 +23037,10 @@
           </a:solidFill>
           <a:ln/>
         </p:spPr>
+        <p:txBody>
+          <a:bodyPr/>
+          <a:p/>
+        </p:txBody>
       </p:sp>
       <p:pic>
         <p:nvPicPr>
@@ -21504,6 +23166,10 @@
           </a:solidFill>
           <a:ln/>
         </p:spPr>
+        <p:txBody>
+          <a:bodyPr/>
+          <a:p/>
+        </p:txBody>
       </p:sp>
       <p:pic>
         <p:nvPicPr>
@@ -21629,6 +23295,10 @@
           </a:solidFill>
           <a:ln/>
         </p:spPr>
+        <p:txBody>
+          <a:bodyPr/>
+          <a:p/>
+        </p:txBody>
       </p:sp>
       <p:pic>
         <p:nvPicPr>
@@ -21763,6 +23433,10 @@
             </a:outerShdw>
           </a:effectLst>
         </p:spPr>
+        <p:txBody>
+          <a:bodyPr/>
+          <a:p/>
+        </p:txBody>
       </p:sp>
       <p:sp>
         <p:nvSpPr>
@@ -21783,6 +23457,10 @@
           </a:solidFill>
           <a:ln/>
         </p:spPr>
+        <p:txBody>
+          <a:bodyPr/>
+          <a:p/>
+        </p:txBody>
       </p:sp>
       <p:pic>
         <p:nvPicPr>
@@ -21910,6 +23588,10 @@
           </a:solidFill>
           <a:ln/>
         </p:spPr>
+        <p:txBody>
+          <a:bodyPr/>
+          <a:p/>
+        </p:txBody>
       </p:sp>
       <p:sp>
         <p:nvSpPr>
@@ -21930,6 +23612,10 @@
           </a:solidFill>
           <a:ln/>
         </p:spPr>
+        <p:txBody>
+          <a:bodyPr/>
+          <a:p/>
+        </p:txBody>
       </p:sp>
       <p:pic>
         <p:nvPicPr>
@@ -22259,6 +23945,10 @@
           </a:solidFill>
           <a:ln/>
         </p:spPr>
+        <p:txBody>
+          <a:bodyPr/>
+          <a:p/>
+        </p:txBody>
       </p:sp>
       <p:sp>
         <p:nvSpPr>
@@ -22279,6 +23969,10 @@
           </a:solidFill>
           <a:ln/>
         </p:spPr>
+        <p:txBody>
+          <a:bodyPr/>
+          <a:p/>
+        </p:txBody>
       </p:sp>
       <p:pic>
         <p:nvPicPr>
@@ -22406,6 +24100,10 @@
           </a:solidFill>
           <a:ln/>
         </p:spPr>
+        <p:txBody>
+          <a:bodyPr/>
+          <a:p/>
+        </p:txBody>
       </p:sp>
       <p:sp>
         <p:nvSpPr>
@@ -22426,6 +24124,10 @@
           </a:solidFill>
           <a:ln/>
         </p:spPr>
+        <p:txBody>
+          <a:bodyPr/>
+          <a:p/>
+        </p:txBody>
       </p:sp>
       <p:pic>
         <p:nvPicPr>
@@ -22553,6 +24255,10 @@
           </a:solidFill>
           <a:ln/>
         </p:spPr>
+        <p:txBody>
+          <a:bodyPr/>
+          <a:p/>
+        </p:txBody>
       </p:sp>
       <p:sp>
         <p:nvSpPr>
@@ -22573,6 +24279,10 @@
           </a:solidFill>
           <a:ln/>
         </p:spPr>
+        <p:txBody>
+          <a:bodyPr/>
+          <a:p/>
+        </p:txBody>
       </p:sp>
       <p:pic>
         <p:nvPicPr>
@@ -22700,6 +24410,10 @@
           </a:solidFill>
           <a:ln/>
         </p:spPr>
+        <p:txBody>
+          <a:bodyPr/>
+          <a:p/>
+        </p:txBody>
       </p:sp>
       <p:sp>
         <p:nvSpPr>
@@ -22720,6 +24434,10 @@
           </a:solidFill>
           <a:ln/>
         </p:spPr>
+        <p:txBody>
+          <a:bodyPr/>
+          <a:p/>
+        </p:txBody>
       </p:sp>
       <p:pic>
         <p:nvPicPr>
@@ -22847,6 +24565,10 @@
           </a:solidFill>
           <a:ln/>
         </p:spPr>
+        <p:txBody>
+          <a:bodyPr/>
+          <a:p/>
+        </p:txBody>
       </p:sp>
       <p:sp>
         <p:nvSpPr>
@@ -22867,6 +24589,10 @@
           </a:solidFill>
           <a:ln/>
         </p:spPr>
+        <p:txBody>
+          <a:bodyPr/>
+          <a:p/>
+        </p:txBody>
       </p:sp>
       <p:pic>
         <p:nvPicPr>
@@ -22994,6 +24720,10 @@
           </a:solidFill>
           <a:ln/>
         </p:spPr>
+        <p:txBody>
+          <a:bodyPr/>
+          <a:p/>
+        </p:txBody>
       </p:sp>
       <p:sp>
         <p:nvSpPr>
@@ -23014,6 +24744,10 @@
           </a:solidFill>
           <a:ln/>
         </p:spPr>
+        <p:txBody>
+          <a:bodyPr/>
+          <a:p/>
+        </p:txBody>
       </p:sp>
       <p:pic>
         <p:nvPicPr>
@@ -23141,6 +24875,10 @@
           </a:solidFill>
           <a:ln/>
         </p:spPr>
+        <p:txBody>
+          <a:bodyPr/>
+          <a:p/>
+        </p:txBody>
       </p:sp>
       <p:sp>
         <p:nvSpPr>
@@ -23161,6 +24899,10 @@
           </a:solidFill>
           <a:ln/>
         </p:spPr>
+        <p:txBody>
+          <a:bodyPr/>
+          <a:p/>
+        </p:txBody>
       </p:sp>
       <p:pic>
         <p:nvPicPr>
@@ -23288,6 +25030,10 @@
           </a:solidFill>
           <a:ln/>
         </p:spPr>
+        <p:txBody>
+          <a:bodyPr/>
+          <a:p/>
+        </p:txBody>
       </p:sp>
       <p:sp>
         <p:nvSpPr>
@@ -23308,6 +25054,10 @@
           </a:solidFill>
           <a:ln/>
         </p:spPr>
+        <p:txBody>
+          <a:bodyPr/>
+          <a:p/>
+        </p:txBody>
       </p:sp>
       <p:pic>
         <p:nvPicPr>
@@ -23435,6 +25185,10 @@
           </a:solidFill>
           <a:ln/>
         </p:spPr>
+        <p:txBody>
+          <a:bodyPr/>
+          <a:p/>
+        </p:txBody>
       </p:sp>
       <p:sp>
         <p:nvSpPr>
@@ -23455,6 +25209,10 @@
           </a:solidFill>
           <a:ln/>
         </p:spPr>
+        <p:txBody>
+          <a:bodyPr/>
+          <a:p/>
+        </p:txBody>
       </p:sp>
       <p:pic>
         <p:nvPicPr>
@@ -23582,6 +25340,10 @@
           </a:solidFill>
           <a:ln/>
         </p:spPr>
+        <p:txBody>
+          <a:bodyPr/>
+          <a:p/>
+        </p:txBody>
       </p:sp>
       <p:sp>
         <p:nvSpPr>
@@ -23602,6 +25364,10 @@
           </a:solidFill>
           <a:ln/>
         </p:spPr>
+        <p:txBody>
+          <a:bodyPr/>
+          <a:p/>
+        </p:txBody>
       </p:sp>
       <p:pic>
         <p:nvPicPr>
@@ -23729,6 +25495,10 @@
           </a:solidFill>
           <a:ln/>
         </p:spPr>
+        <p:txBody>
+          <a:bodyPr/>
+          <a:p/>
+        </p:txBody>
       </p:sp>
       <p:sp>
         <p:nvSpPr>
@@ -23749,6 +25519,10 @@
           </a:solidFill>
           <a:ln/>
         </p:spPr>
+        <p:txBody>
+          <a:bodyPr/>
+          <a:p/>
+        </p:txBody>
       </p:sp>
       <p:pic>
         <p:nvPicPr>
@@ -23876,6 +25650,10 @@
           </a:solidFill>
           <a:ln/>
         </p:spPr>
+        <p:txBody>
+          <a:bodyPr/>
+          <a:p/>
+        </p:txBody>
       </p:sp>
       <p:sp>
         <p:nvSpPr>
@@ -23896,6 +25674,10 @@
           </a:solidFill>
           <a:ln/>
         </p:spPr>
+        <p:txBody>
+          <a:bodyPr/>
+          <a:p/>
+        </p:txBody>
       </p:sp>
       <p:pic>
         <p:nvPicPr>
@@ -24023,6 +25805,10 @@
           </a:solidFill>
           <a:ln/>
         </p:spPr>
+        <p:txBody>
+          <a:bodyPr/>
+          <a:p/>
+        </p:txBody>
       </p:sp>
       <p:sp>
         <p:nvSpPr>
@@ -24043,6 +25829,10 @@
           </a:solidFill>
           <a:ln/>
         </p:spPr>
+        <p:txBody>
+          <a:bodyPr/>
+          <a:p/>
+        </p:txBody>
       </p:sp>
       <p:pic>
         <p:nvPicPr>
@@ -24170,6 +25960,10 @@
           </a:solidFill>
           <a:ln/>
         </p:spPr>
+        <p:txBody>
+          <a:bodyPr/>
+          <a:p/>
+        </p:txBody>
       </p:sp>
       <p:sp>
         <p:nvSpPr>
@@ -24190,6 +25984,10 @@
           </a:solidFill>
           <a:ln/>
         </p:spPr>
+        <p:txBody>
+          <a:bodyPr/>
+          <a:p/>
+        </p:txBody>
       </p:sp>
       <p:pic>
         <p:nvPicPr>
@@ -24317,6 +26115,10 @@
           </a:solidFill>
           <a:ln/>
         </p:spPr>
+        <p:txBody>
+          <a:bodyPr/>
+          <a:p/>
+        </p:txBody>
       </p:sp>
       <p:sp>
         <p:nvSpPr>
@@ -24337,6 +26139,10 @@
           </a:solidFill>
           <a:ln/>
         </p:spPr>
+        <p:txBody>
+          <a:bodyPr/>
+          <a:p/>
+        </p:txBody>
       </p:sp>
       <p:pic>
         <p:nvPicPr>
@@ -24464,6 +26270,10 @@
           </a:solidFill>
           <a:ln/>
         </p:spPr>
+        <p:txBody>
+          <a:bodyPr/>
+          <a:p/>
+        </p:txBody>
       </p:sp>
       <p:sp>
         <p:nvSpPr>
@@ -24484,6 +26294,10 @@
           </a:solidFill>
           <a:ln/>
         </p:spPr>
+        <p:txBody>
+          <a:bodyPr/>
+          <a:p/>
+        </p:txBody>
       </p:sp>
       <p:pic>
         <p:nvPicPr>
@@ -24891,6 +26705,10 @@
           </a:solidFill>
           <a:ln/>
         </p:spPr>
+        <p:txBody>
+          <a:bodyPr/>
+          <a:p/>
+        </p:txBody>
       </p:sp>
       <p:sp>
         <p:nvSpPr>
@@ -24997,6 +26815,10 @@
           </a:solidFill>
           <a:ln/>
         </p:spPr>
+        <p:txBody>
+          <a:bodyPr/>
+          <a:p/>
+        </p:txBody>
       </p:sp>
       <p:sp>
         <p:nvSpPr>
@@ -25103,6 +26925,10 @@
           </a:solidFill>
           <a:ln/>
         </p:spPr>
+        <p:txBody>
+          <a:bodyPr/>
+          <a:p/>
+        </p:txBody>
       </p:sp>
       <p:sp>
         <p:nvSpPr>
@@ -25209,6 +27035,10 @@
           </a:solidFill>
           <a:ln/>
         </p:spPr>
+        <p:txBody>
+          <a:bodyPr/>
+          <a:p/>
+        </p:txBody>
       </p:sp>
       <p:sp>
         <p:nvSpPr>
@@ -25322,6 +27152,10 @@
             </a:outerShdw>
           </a:effectLst>
         </p:spPr>
+        <p:txBody>
+          <a:bodyPr/>
+          <a:p/>
+        </p:txBody>
       </p:sp>
       <p:sp>
         <p:nvSpPr>
@@ -25342,6 +27176,10 @@
           </a:solidFill>
           <a:ln/>
         </p:spPr>
+        <p:txBody>
+          <a:bodyPr/>
+          <a:p/>
+        </p:txBody>
       </p:sp>
       <p:pic>
         <p:nvPicPr>
@@ -25476,6 +27314,10 @@
             </a:outerShdw>
           </a:effectLst>
         </p:spPr>
+        <p:txBody>
+          <a:bodyPr/>
+          <a:p/>
+        </p:txBody>
       </p:sp>
       <p:sp>
         <p:nvSpPr>
@@ -25496,6 +27338,10 @@
           </a:solidFill>
           <a:ln/>
         </p:spPr>
+        <p:txBody>
+          <a:bodyPr/>
+          <a:p/>
+        </p:txBody>
       </p:sp>
       <p:pic>
         <p:nvPicPr>
@@ -25630,6 +27476,10 @@
             </a:outerShdw>
           </a:effectLst>
         </p:spPr>
+        <p:txBody>
+          <a:bodyPr/>
+          <a:p/>
+        </p:txBody>
       </p:sp>
       <p:sp>
         <p:nvSpPr>
@@ -25650,6 +27500,10 @@
           </a:solidFill>
           <a:ln/>
         </p:spPr>
+        <p:txBody>
+          <a:bodyPr/>
+          <a:p/>
+        </p:txBody>
       </p:sp>
       <p:pic>
         <p:nvPicPr>
@@ -25828,7 +27682,7 @@
                 <a:ea typeface="Calibri" pitchFamily="34" charset="-122"/>
                 <a:cs typeface="Calibri" pitchFamily="34" charset="-120"/>
               </a:rPr>
-              <a:t>07</a:t>
+              <a:t>08</a:t>
             </a:r>
             <a:endParaRPr lang="en-US" sz="900" dirty="0"/>
           </a:p>
@@ -26849,6 +28703,10 @@
           </a:solidFill>
           <a:ln/>
         </p:spPr>
+        <p:txBody>
+          <a:bodyPr/>
+          <a:p/>
+        </p:txBody>
       </p:sp>
       <p:sp>
         <p:nvSpPr>
@@ -26869,6 +28727,10 @@
           </a:solidFill>
           <a:ln/>
         </p:spPr>
+        <p:txBody>
+          <a:bodyPr/>
+          <a:p/>
+        </p:txBody>
       </p:sp>
       <p:pic>
         <p:nvPicPr>
@@ -26964,6 +28826,10 @@
             </a:outerShdw>
           </a:effectLst>
         </p:spPr>
+        <p:txBody>
+          <a:bodyPr/>
+          <a:p/>
+        </p:txBody>
       </p:sp>
       <p:sp>
         <p:nvSpPr>
@@ -26984,6 +28850,10 @@
           </a:solidFill>
           <a:ln/>
         </p:spPr>
+        <p:txBody>
+          <a:bodyPr/>
+          <a:p/>
+        </p:txBody>
       </p:sp>
       <p:pic>
         <p:nvPicPr>
@@ -27162,7 +29032,7 @@
                 <a:ea typeface="Calibri" pitchFamily="34" charset="-122"/>
                 <a:cs typeface="Calibri" pitchFamily="34" charset="-120"/>
               </a:rPr>
-              <a:t>08</a:t>
+              <a:t>09</a:t>
             </a:r>
             <a:endParaRPr lang="en-US" sz="900" dirty="0"/>
           </a:p>
@@ -27320,6 +29190,10 @@
             </a:outerShdw>
           </a:effectLst>
         </p:spPr>
+        <p:txBody>
+          <a:bodyPr/>
+          <a:p/>
+        </p:txBody>
       </p:sp>
       <p:sp>
         <p:nvSpPr>
@@ -27340,6 +29214,10 @@
           </a:solidFill>
           <a:ln/>
         </p:spPr>
+        <p:txBody>
+          <a:bodyPr/>
+          <a:p/>
+        </p:txBody>
       </p:sp>
       <p:pic>
         <p:nvPicPr>
@@ -27465,6 +29343,10 @@
           </a:solidFill>
           <a:ln/>
         </p:spPr>
+        <p:txBody>
+          <a:bodyPr/>
+          <a:p/>
+        </p:txBody>
       </p:sp>
       <p:pic>
         <p:nvPicPr>
@@ -27590,6 +29472,10 @@
           </a:solidFill>
           <a:ln/>
         </p:spPr>
+        <p:txBody>
+          <a:bodyPr/>
+          <a:p/>
+        </p:txBody>
       </p:sp>
       <p:pic>
         <p:nvPicPr>
@@ -28371,7 +30257,7 @@
                 <a:ea typeface="Calibri" pitchFamily="34" charset="-122"/>
                 <a:cs typeface="Calibri" pitchFamily="34" charset="-120"/>
               </a:rPr>
-              <a:t>09</a:t>
+              <a:t>10</a:t>
             </a:r>
             <a:endParaRPr lang="en-US" sz="900" dirty="0"/>
           </a:p>

</xml_diff>

<commit_message>
Atualiza manuais e apresentacao com os avisos de compra pelo Telegram
- Manual operacional: nova 15.5 (Avisos pelo Telegram) e entrada no
  sumario; tipos de alerta novos na 15.1; notas em 2.3, 7.3, 8.3 e 18.2;
  TELEGRAM_IA_DIARIA(_HORA) na secao 19; 2 FAQs
- Manual comercial: diferencial, itens em 3.4 e 3.6 e nova secao 3.23
- Apresentacao: slide novo "Mensagens de compra no celular" (31 slides)

Co-Authored-By: Claude Opus 5.5 <noreply@anthropic.com>
</commit_message>
<xml_diff>
--- a/docs/BolsaTrader_Manual_Operacional.pptx
+++ b/docs/BolsaTrader_Manual_Operacional.pptx
@@ -27,6 +27,7 @@
     <p:sldId id="272" r:id="rId18"/>
     <p:sldId id="279" r:id="rId30"/>
     <p:sldId id="273" r:id="rId19"/>
+    <p:sldId id="286" r:id="rId37"/>
     <p:sldId id="274" r:id="rId20"/>
     <p:sldId id="278" r:id="rId29"/>
     <p:sldId id="282" r:id="rId33"/>
@@ -19912,7 +19913,7 @@
                 <a:ea typeface="Calibri" pitchFamily="34" charset="-122"/>
                 <a:cs typeface="Calibri" pitchFamily="34" charset="-120"/>
               </a:rPr>
-              <a:t>23</a:t>
+              <a:t>24</a:t>
             </a:r>
             <a:endParaRPr lang="en-US" sz="900" dirty="0"/>
           </a:p>
@@ -20850,7 +20851,7 @@
                 <a:ea typeface="Calibri" pitchFamily="34" charset="-122"/>
                 <a:cs typeface="Calibri" pitchFamily="34" charset="-120"/>
               </a:rPr>
-              <a:t>24</a:t>
+              <a:t>25</a:t>
             </a:r>
             <a:endParaRPr lang="en-US" sz="900" dirty="0"/>
           </a:p>
@@ -22299,7 +22300,7 @@
                 <a:ea typeface="Calibri" pitchFamily="34" charset="-122"/>
                 <a:cs typeface="Calibri" pitchFamily="34" charset="-120"/>
               </a:rPr>
-              <a:t>25</a:t>
+              <a:t>26</a:t>
             </a:r>
             <a:endParaRPr lang="en-US" sz="900" dirty="0"/>
           </a:p>
@@ -23334,7 +23335,7 @@
                 <a:ea typeface="Calibri" pitchFamily="34" charset="-122"/>
                 <a:cs typeface="Calibri" pitchFamily="34" charset="-120"/>
               </a:rPr>
-              <a:t>26</a:t>
+              <a:t>27</a:t>
             </a:r>
             <a:endParaRPr lang="en-US" sz="900" dirty="0"/>
           </a:p>
@@ -24651,7 +24652,7 @@
                 <a:ea typeface="Calibri" pitchFamily="34" charset="-122"/>
                 <a:cs typeface="Calibri" pitchFamily="34" charset="-120"/>
               </a:rPr>
-              <a:t>27</a:t>
+              <a:t>28</a:t>
             </a:r>
             <a:endParaRPr lang="en-US" sz="900" dirty="0"/>
           </a:p>
@@ -25968,7 +25969,7 @@
                 <a:ea typeface="Calibri" pitchFamily="34" charset="-122"/>
                 <a:cs typeface="Calibri" pitchFamily="34" charset="-120"/>
               </a:rPr>
-              <a:t>28</a:t>
+              <a:t>29</a:t>
             </a:r>
             <a:endParaRPr lang="en-US" sz="900" dirty="0"/>
           </a:p>
@@ -26749,7 +26750,7 @@
                 <a:ea typeface="Calibri" pitchFamily="34" charset="-122"/>
                 <a:cs typeface="Calibri" pitchFamily="34" charset="-120"/>
               </a:rPr>
-              <a:t>29</a:t>
+              <a:t>30</a:t>
             </a:r>
             <a:endParaRPr lang="en-US" sz="900" dirty="0"/>
           </a:p>
@@ -28083,7 +28084,1042 @@
                 <a:ea typeface="Calibri" pitchFamily="34" charset="-122"/>
                 <a:cs typeface="Calibri" pitchFamily="34" charset="-120"/>
               </a:rPr>
-              <a:t>30</a:t>
+              <a:t>31</a:t>
+            </a:r>
+            <a:endParaRPr lang="en-US" sz="900" dirty="0"/>
+          </a:p>
+        </p:txBody>
+      </p:sp>
+    </p:spTree>
+  </p:cSld>
+  <p:clrMapOvr>
+    <a:masterClrMapping/>
+  </p:clrMapOvr>
+</p:sld>
+</file>
+
+<file path=ppt/slides/slide31.xml><?xml version="1.0" encoding="utf-8"?>
+<p:sld xmlns:a="http://schemas.openxmlformats.org/drawingml/2006/main" xmlns:r="http://schemas.openxmlformats.org/officeDocument/2006/relationships" xmlns:p="http://schemas.openxmlformats.org/presentationml/2006/main">
+  <p:cSld name="Slide 12">
+    <p:bg>
+      <p:bgPr>
+        <a:solidFill>
+          <a:srgbClr val="FFFFFF"/>
+        </a:solidFill>
+      </p:bgPr>
+    </p:bg>
+    <p:spTree>
+      <p:nvGrpSpPr>
+        <p:cNvPr id="1" name=""/>
+        <p:cNvGrpSpPr/>
+        <p:nvPr/>
+      </p:nvGrpSpPr>
+      <p:grpSpPr>
+        <a:xfrm>
+          <a:off x="0" y="0"/>
+          <a:ext cx="0" cy="0"/>
+          <a:chOff x="0" y="0"/>
+          <a:chExt cx="0" cy="0"/>
+        </a:xfrm>
+      </p:grpSpPr>
+      <p:sp>
+        <p:nvSpPr>
+          <p:cNvPr id="2" name="Text 0"/>
+          <p:cNvSpPr/>
+          <p:nvPr/>
+        </p:nvSpPr>
+        <p:spPr>
+          <a:xfrm>
+            <a:off x="548640" y="457200"/>
+            <a:ext cx="9144000" cy="292608"/>
+          </a:xfrm>
+          <a:prstGeom prst="rect">
+            <a:avLst/>
+          </a:prstGeom>
+          <a:noFill/>
+          <a:ln/>
+        </p:spPr>
+        <p:txBody>
+          <a:bodyPr wrap="square" lIns="0" tIns="0" rIns="0" bIns="0" rtlCol="0" anchor="ctr"/>
+          <a:lstStyle/>
+          <a:p>
+            <a:pPr indent="0" marL="0">
+              <a:buNone/>
+            </a:pPr>
+            <a:r>
+              <a:rPr lang="en-US" sz="1250" b="1" dirty="0">
+                <a:solidFill>
+                  <a:srgbClr val="00D68F"/>
+                </a:solidFill>
+                <a:latin typeface="Calibri" pitchFamily="34" charset="0"/>
+                <a:ea typeface="Calibri" pitchFamily="34" charset="-122"/>
+                <a:cs typeface="Calibri" pitchFamily="34" charset="-120"/>
+              </a:rPr>
+              <a:t>15.5  </a:t>
+            </a:r>
+            <a:pPr indent="0" marL="0">
+              <a:buNone/>
+            </a:pPr>
+            <a:r>
+              <a:rPr lang="en-US" sz="1250" b="1" spc="200" kern="0" dirty="0">
+                <a:solidFill>
+                  <a:srgbClr val="00D68F"/>
+                </a:solidFill>
+                <a:latin typeface="Calibri" pitchFamily="34" charset="0"/>
+                <a:ea typeface="Calibri" pitchFamily="34" charset="-122"/>
+                <a:cs typeface="Calibri" pitchFamily="34" charset="-120"/>
+              </a:rPr>
+              <a:t>AVISOS PELO TELEGRAM</a:t>
+            </a:r>
+            <a:endParaRPr lang="en-US" sz="1250" dirty="0"/>
+          </a:p>
+        </p:txBody>
+      </p:sp>
+      <p:sp>
+        <p:nvSpPr>
+          <p:cNvPr id="3" name="Text 1"/>
+          <p:cNvSpPr/>
+          <p:nvPr/>
+        </p:nvSpPr>
+        <p:spPr>
+          <a:xfrm>
+            <a:off x="548640" y="749808"/>
+            <a:ext cx="11094415" cy="640080"/>
+          </a:xfrm>
+          <a:prstGeom prst="rect">
+            <a:avLst/>
+          </a:prstGeom>
+          <a:noFill/>
+          <a:ln/>
+        </p:spPr>
+        <p:txBody>
+          <a:bodyPr wrap="square" lIns="0" tIns="0" rIns="0" bIns="0" rtlCol="0" anchor="ctr"/>
+          <a:lstStyle/>
+          <a:p>
+            <a:pPr indent="0" marL="0">
+              <a:buNone/>
+            </a:pPr>
+            <a:r>
+              <a:rPr lang="en-US" sz="3000" b="1" dirty="0">
+                <a:solidFill>
+                  <a:srgbClr val="0D1B3E"/>
+                </a:solidFill>
+                <a:latin typeface="Calibri" pitchFamily="34" charset="0"/>
+                <a:ea typeface="Calibri" pitchFamily="34" charset="-122"/>
+                <a:cs typeface="Calibri" pitchFamily="34" charset="-120"/>
+              </a:rPr>
+              <a:t>Mensagens de compra no celular</a:t>
+            </a:r>
+            <a:endParaRPr lang="en-US" sz="3000" dirty="0"/>
+          </a:p>
+        </p:txBody>
+      </p:sp>
+      <p:sp>
+        <p:nvSpPr>
+          <p:cNvPr id="4" name="Shape 2"/>
+          <p:cNvSpPr/>
+          <p:nvPr/>
+        </p:nvSpPr>
+        <p:spPr>
+          <a:xfrm>
+            <a:off x="548640" y="1463040"/>
+            <a:ext cx="11094415" cy="1371600"/>
+          </a:xfrm>
+          <a:prstGeom prst="roundRect">
+            <a:avLst>
+              <a:gd name="adj" fmla="val 6000"/>
+            </a:avLst>
+          </a:prstGeom>
+          <a:solidFill>
+            <a:srgbClr val="F3F6FC"/>
+          </a:solidFill>
+          <a:ln/>
+          <a:effectLst>
+            <a:outerShdw sx="100000" sy="100000" kx="0" ky="0" algn="bl" rotWithShape="0" blurRad="101600" dist="25400" dir="5400000">
+              <a:srgbClr val="1B2A55">
+                <a:alpha val="12000"/>
+              </a:srgbClr>
+            </a:outerShdw>
+          </a:effectLst>
+        </p:spPr>
+        <p:txBody>
+          <a:bodyPr/>
+          <a:p/>
+        </p:txBody>
+      </p:sp>
+      <p:sp>
+        <p:nvSpPr>
+          <p:cNvPr id="5" name="Shape 3"/>
+          <p:cNvSpPr/>
+          <p:nvPr/>
+        </p:nvSpPr>
+        <p:spPr>
+          <a:xfrm>
+            <a:off x="804672" y="1700784"/>
+            <a:ext cx="457200" cy="457200"/>
+          </a:xfrm>
+          <a:prstGeom prst="ellipse">
+            <a:avLst/>
+          </a:prstGeom>
+          <a:solidFill>
+            <a:srgbClr val="0D1B3E"/>
+          </a:solidFill>
+          <a:ln/>
+        </p:spPr>
+        <p:txBody>
+          <a:bodyPr/>
+          <a:p/>
+        </p:txBody>
+      </p:sp>
+      <p:pic>
+        <p:nvPicPr>
+          <p:cNvPr id="6" name="Image 0" descr="">    </p:cNvPr>
+          <p:cNvPicPr>
+            <a:picLocks noChangeAspect="1"/>
+          </p:cNvPicPr>
+          <p:nvPr/>
+        </p:nvPicPr>
+        <p:blipFill>
+          <a:blip r:embed="rId1"/>
+          <a:stretch>
+            <a:fillRect/>
+          </a:stretch>
+        </p:blipFill>
+        <p:spPr>
+          <a:xfrm>
+            <a:off x="923544" y="1819656"/>
+            <a:ext cx="219456" cy="219456"/>
+          </a:xfrm>
+          <a:prstGeom prst="rect">
+            <a:avLst/>
+          </a:prstGeom>
+        </p:spPr>
+      </p:pic>
+      <p:sp>
+        <p:nvSpPr>
+          <p:cNvPr id="7" name="Text 4"/>
+          <p:cNvSpPr/>
+          <p:nvPr/>
+        </p:nvSpPr>
+        <p:spPr>
+          <a:xfrm>
+            <a:off x="1426464" y="1645920"/>
+            <a:ext cx="9987991" cy="365760"/>
+          </a:xfrm>
+          <a:prstGeom prst="rect">
+            <a:avLst/>
+          </a:prstGeom>
+          <a:noFill/>
+          <a:ln/>
+        </p:spPr>
+        <p:txBody>
+          <a:bodyPr wrap="square" lIns="0" tIns="0" rIns="0" bIns="0" rtlCol="0" anchor="ctr"/>
+          <a:lstStyle/>
+          <a:p>
+            <a:pPr indent="0" marL="0">
+              <a:buNone/>
+            </a:pPr>
+            <a:r>
+              <a:rPr lang="en-US" sz="1500" b="1" dirty="0">
+                <a:solidFill>
+                  <a:srgbClr val="0D1B3E"/>
+                </a:solidFill>
+                <a:latin typeface="Calibri" pitchFamily="34" charset="0"/>
+                <a:ea typeface="Calibri" pitchFamily="34" charset="-122"/>
+                <a:cs typeface="Calibri" pitchFamily="34" charset="-120"/>
+              </a:rPr>
+              <a:t>Ligue o seu bot em Minha Conta</a:t>
+            </a:r>
+            <a:endParaRPr lang="en-US" sz="1500" dirty="0"/>
+          </a:p>
+        </p:txBody>
+      </p:sp>
+      <p:sp>
+        <p:nvSpPr>
+          <p:cNvPr id="8" name="Text 5"/>
+          <p:cNvSpPr/>
+          <p:nvPr/>
+        </p:nvSpPr>
+        <p:spPr>
+          <a:xfrm>
+            <a:off x="804672" y="2286000"/>
+            <a:ext cx="10582351" cy="384048"/>
+          </a:xfrm>
+          <a:prstGeom prst="rect">
+            <a:avLst/>
+          </a:prstGeom>
+          <a:noFill/>
+          <a:ln/>
+        </p:spPr>
+        <p:txBody>
+          <a:bodyPr wrap="square" lIns="0" tIns="0" rIns="0" bIns="0" rtlCol="0" anchor="t"/>
+          <a:lstStyle/>
+          <a:p>
+            <a:pPr indent="0" marL="0">
+              <a:lnSpc>
+                <a:spcPct val="112000"/>
+              </a:lnSpc>
+              <a:buNone/>
+            </a:pPr>
+            <a:r>
+              <a:rPr lang="en-US" sz="1100" dirty="0">
+                <a:solidFill>
+                  <a:srgbClr val="40496B"/>
+                </a:solidFill>
+                <a:latin typeface="Calibri" pitchFamily="34" charset="0"/>
+                <a:ea typeface="Calibri" pitchFamily="34" charset="-122"/>
+                <a:cs typeface="Calibri" pitchFamily="34" charset="-120"/>
+              </a:rPr>
+              <a:t>Informe o token do bot e o Chat ID do Telegram (gravados criptografados). Cada usuário usa o próprio bot e recebe, sem abrir o sistema, as oportunidades de compra — e também a meta de lucro atingida.</a:t>
+            </a:r>
+            <a:endParaRPr lang="en-US" sz="1100" dirty="0"/>
+          </a:p>
+        </p:txBody>
+      </p:sp>
+      <p:sp>
+        <p:nvSpPr>
+          <p:cNvPr id="9" name="Text 6"/>
+          <p:cNvSpPr/>
+          <p:nvPr/>
+        </p:nvSpPr>
+        <p:spPr>
+          <a:xfrm>
+            <a:off x="548640" y="3063240"/>
+            <a:ext cx="7315200" cy="292608"/>
+          </a:xfrm>
+          <a:prstGeom prst="rect">
+            <a:avLst/>
+          </a:prstGeom>
+          <a:noFill/>
+          <a:ln/>
+        </p:spPr>
+        <p:txBody>
+          <a:bodyPr wrap="square" lIns="0" tIns="0" rIns="0" bIns="0" rtlCol="0" anchor="ctr"/>
+          <a:lstStyle/>
+          <a:p>
+            <a:pPr indent="0" marL="0">
+              <a:buNone/>
+            </a:pPr>
+            <a:r>
+              <a:rPr lang="en-US" sz="1400" b="1" dirty="0">
+                <a:solidFill>
+                  <a:srgbClr val="0D1B3E"/>
+                </a:solidFill>
+                <a:latin typeface="Calibri" pitchFamily="34" charset="0"/>
+                <a:ea typeface="Calibri" pitchFamily="34" charset="-122"/>
+                <a:cs typeface="Calibri" pitchFamily="34" charset="-120"/>
+              </a:rPr>
+              <a:t>O que chega no Telegram</a:t>
+            </a:r>
+            <a:endParaRPr lang="en-US" sz="1400" dirty="0"/>
+          </a:p>
+        </p:txBody>
+      </p:sp>
+      <p:sp>
+        <p:nvSpPr>
+          <p:cNvPr id="10" name="Shape 7"/>
+          <p:cNvSpPr/>
+          <p:nvPr/>
+        </p:nvSpPr>
+        <p:spPr>
+          <a:xfrm>
+            <a:off x="548640" y="3474720"/>
+            <a:ext cx="384048" cy="384048"/>
+          </a:xfrm>
+          <a:prstGeom prst="ellipse">
+            <a:avLst/>
+          </a:prstGeom>
+          <a:solidFill>
+            <a:srgbClr val="0D1B3E"/>
+          </a:solidFill>
+          <a:ln/>
+        </p:spPr>
+        <p:txBody>
+          <a:bodyPr/>
+          <a:p/>
+        </p:txBody>
+      </p:sp>
+      <p:pic>
+        <p:nvPicPr>
+          <p:cNvPr id="11" name="Image 1" descr="">    </p:cNvPr>
+          <p:cNvPicPr>
+            <a:picLocks noChangeAspect="1"/>
+          </p:cNvPicPr>
+          <p:nvPr/>
+        </p:nvPicPr>
+        <p:blipFill>
+          <a:blip r:embed="rId2"/>
+          <a:stretch>
+            <a:fillRect/>
+          </a:stretch>
+        </p:blipFill>
+        <p:spPr>
+          <a:xfrm>
+            <a:off x="640812" y="3566892"/>
+            <a:ext cx="199705" cy="199705"/>
+          </a:xfrm>
+          <a:prstGeom prst="rect">
+            <a:avLst/>
+          </a:prstGeom>
+        </p:spPr>
+      </p:pic>
+      <p:sp>
+        <p:nvSpPr>
+          <p:cNvPr id="12" name="Text 8"/>
+          <p:cNvSpPr/>
+          <p:nvPr/>
+        </p:nvSpPr>
+        <p:spPr>
+          <a:xfrm>
+            <a:off x="1078992" y="3438144"/>
+            <a:ext cx="4742536" cy="256032"/>
+          </a:xfrm>
+          <a:prstGeom prst="rect">
+            <a:avLst/>
+          </a:prstGeom>
+          <a:noFill/>
+          <a:ln/>
+        </p:spPr>
+        <p:txBody>
+          <a:bodyPr wrap="square" lIns="0" tIns="0" rIns="0" bIns="0" rtlCol="0" anchor="ctr"/>
+          <a:lstStyle/>
+          <a:p>
+            <a:pPr indent="0" marL="0">
+              <a:buNone/>
+            </a:pPr>
+            <a:r>
+              <a:rPr lang="en-US" sz="1250" b="1" dirty="0">
+                <a:solidFill>
+                  <a:srgbClr val="0D1B3E"/>
+                </a:solidFill>
+                <a:latin typeface="Calibri" pitchFamily="34" charset="0"/>
+                <a:ea typeface="Calibri" pitchFamily="34" charset="-122"/>
+                <a:cs typeface="Calibri" pitchFamily="34" charset="-120"/>
+              </a:rPr>
+              <a:t>Scanner Técnico</a:t>
+            </a:r>
+            <a:endParaRPr lang="en-US" sz="1250" dirty="0"/>
+          </a:p>
+        </p:txBody>
+      </p:sp>
+      <p:sp>
+        <p:nvSpPr>
+          <p:cNvPr id="13" name="Text 9"/>
+          <p:cNvSpPr/>
+          <p:nvPr/>
+        </p:nvSpPr>
+        <p:spPr>
+          <a:xfrm>
+            <a:off x="1078992" y="3694176"/>
+            <a:ext cx="4742536" cy="502920"/>
+          </a:xfrm>
+          <a:prstGeom prst="rect">
+            <a:avLst/>
+          </a:prstGeom>
+          <a:noFill/>
+          <a:ln/>
+        </p:spPr>
+        <p:txBody>
+          <a:bodyPr wrap="square" lIns="0" tIns="0" rIns="0" bIns="0" rtlCol="0" anchor="ctr"/>
+          <a:lstStyle/>
+          <a:p>
+            <a:pPr indent="0" marL="0">
+              <a:lnSpc>
+                <a:spcPct val="110000"/>
+              </a:lnSpc>
+              <a:buNone/>
+            </a:pPr>
+            <a:r>
+              <a:rPr lang="en-US" sz="1000" dirty="0">
+                <a:solidFill>
+                  <a:srgbClr val="40496B"/>
+                </a:solidFill>
+                <a:latin typeface="Calibri" pitchFamily="34" charset="0"/>
+                <a:ea typeface="Calibri" pitchFamily="34" charset="-122"/>
+                <a:cs typeface="Calibri" pitchFamily="34" charset="-120"/>
+              </a:rPr>
+              <a:t>Predomínio de alta com a cotação na entrada do plano ou abaixo — já com stop, alvo e R:R.</a:t>
+            </a:r>
+            <a:endParaRPr lang="en-US" sz="1000" dirty="0"/>
+          </a:p>
+        </p:txBody>
+      </p:sp>
+      <p:sp>
+        <p:nvSpPr>
+          <p:cNvPr id="14" name="Shape 10"/>
+          <p:cNvSpPr/>
+          <p:nvPr/>
+        </p:nvSpPr>
+        <p:spPr>
+          <a:xfrm>
+            <a:off x="6370168" y="3474720"/>
+            <a:ext cx="384048" cy="384048"/>
+          </a:xfrm>
+          <a:prstGeom prst="ellipse">
+            <a:avLst/>
+          </a:prstGeom>
+          <a:solidFill>
+            <a:srgbClr val="00D68F"/>
+          </a:solidFill>
+          <a:ln/>
+        </p:spPr>
+        <p:txBody>
+          <a:bodyPr/>
+          <a:p/>
+        </p:txBody>
+      </p:sp>
+      <p:pic>
+        <p:nvPicPr>
+          <p:cNvPr id="15" name="Image 2" descr="">    </p:cNvPr>
+          <p:cNvPicPr>
+            <a:picLocks noChangeAspect="1"/>
+          </p:cNvPicPr>
+          <p:nvPr/>
+        </p:nvPicPr>
+        <p:blipFill>
+          <a:blip r:embed="rId3"/>
+          <a:stretch>
+            <a:fillRect/>
+          </a:stretch>
+        </p:blipFill>
+        <p:spPr>
+          <a:xfrm>
+            <a:off x="6462339" y="3566892"/>
+            <a:ext cx="199705" cy="199705"/>
+          </a:xfrm>
+          <a:prstGeom prst="rect">
+            <a:avLst/>
+          </a:prstGeom>
+        </p:spPr>
+      </p:pic>
+      <p:sp>
+        <p:nvSpPr>
+          <p:cNvPr id="16" name="Text 11"/>
+          <p:cNvSpPr/>
+          <p:nvPr/>
+        </p:nvSpPr>
+        <p:spPr>
+          <a:xfrm>
+            <a:off x="6900520" y="3438144"/>
+            <a:ext cx="4742536" cy="256032"/>
+          </a:xfrm>
+          <a:prstGeom prst="rect">
+            <a:avLst/>
+          </a:prstGeom>
+          <a:noFill/>
+          <a:ln/>
+        </p:spPr>
+        <p:txBody>
+          <a:bodyPr wrap="square" lIns="0" tIns="0" rIns="0" bIns="0" rtlCol="0" anchor="ctr"/>
+          <a:lstStyle/>
+          <a:p>
+            <a:pPr indent="0" marL="0">
+              <a:buNone/>
+            </a:pPr>
+            <a:r>
+              <a:rPr lang="en-US" sz="1250" b="1" dirty="0">
+                <a:solidFill>
+                  <a:srgbClr val="0D1B3E"/>
+                </a:solidFill>
+                <a:latin typeface="Calibri" pitchFamily="34" charset="0"/>
+                <a:ea typeface="Calibri" pitchFamily="34" charset="-122"/>
+                <a:cs typeface="Calibri" pitchFamily="34" charset="-120"/>
+              </a:rPr>
+              <a:t>Robô consultor</a:t>
+            </a:r>
+            <a:endParaRPr lang="en-US" sz="1250" dirty="0"/>
+          </a:p>
+        </p:txBody>
+      </p:sp>
+      <p:sp>
+        <p:nvSpPr>
+          <p:cNvPr id="17" name="Text 12"/>
+          <p:cNvSpPr/>
+          <p:nvPr/>
+        </p:nvSpPr>
+        <p:spPr>
+          <a:xfrm>
+            <a:off x="6900520" y="3694176"/>
+            <a:ext cx="4742536" cy="502920"/>
+          </a:xfrm>
+          <a:prstGeom prst="rect">
+            <a:avLst/>
+          </a:prstGeom>
+          <a:noFill/>
+          <a:ln/>
+        </p:spPr>
+        <p:txBody>
+          <a:bodyPr wrap="square" lIns="0" tIns="0" rIns="0" bIns="0" rtlCol="0" anchor="ctr"/>
+          <a:lstStyle/>
+          <a:p>
+            <a:pPr indent="0" marL="0">
+              <a:lnSpc>
+                <a:spcPct val="110000"/>
+              </a:lnSpc>
+              <a:buNone/>
+            </a:pPr>
+            <a:r>
+              <a:rPr lang="en-US" sz="1000" dirty="0">
+                <a:solidFill>
+                  <a:srgbClr val="40496B"/>
+                </a:solidFill>
+                <a:latin typeface="Calibri" pitchFamily="34" charset="0"/>
+                <a:ea typeface="Calibri" pitchFamily="34" charset="-122"/>
+                <a:cs typeface="Calibri" pitchFamily="34" charset="-120"/>
+              </a:rPr>
+              <a:t>Sinal técnico de compra (RSI + MACD + tendência), o mesmo da tela Alertas.</a:t>
+            </a:r>
+            <a:endParaRPr lang="en-US" sz="1000" dirty="0"/>
+          </a:p>
+        </p:txBody>
+      </p:sp>
+      <p:sp>
+        <p:nvSpPr>
+          <p:cNvPr id="18" name="Shape 13"/>
+          <p:cNvSpPr/>
+          <p:nvPr/>
+        </p:nvSpPr>
+        <p:spPr>
+          <a:xfrm>
+            <a:off x="548640" y="4434840"/>
+            <a:ext cx="384048" cy="384048"/>
+          </a:xfrm>
+          <a:prstGeom prst="ellipse">
+            <a:avLst/>
+          </a:prstGeom>
+          <a:solidFill>
+            <a:srgbClr val="0D1B3E"/>
+          </a:solidFill>
+          <a:ln/>
+        </p:spPr>
+        <p:txBody>
+          <a:bodyPr/>
+          <a:p/>
+        </p:txBody>
+      </p:sp>
+      <p:pic>
+        <p:nvPicPr>
+          <p:cNvPr id="19" name="Image 3" descr="">    </p:cNvPr>
+          <p:cNvPicPr>
+            <a:picLocks noChangeAspect="1"/>
+          </p:cNvPicPr>
+          <p:nvPr/>
+        </p:nvPicPr>
+        <p:blipFill>
+          <a:blip r:embed="rId4"/>
+          <a:stretch>
+            <a:fillRect/>
+          </a:stretch>
+        </p:blipFill>
+        <p:spPr>
+          <a:xfrm>
+            <a:off x="640812" y="4527012"/>
+            <a:ext cx="199705" cy="199705"/>
+          </a:xfrm>
+          <a:prstGeom prst="rect">
+            <a:avLst/>
+          </a:prstGeom>
+        </p:spPr>
+      </p:pic>
+      <p:sp>
+        <p:nvSpPr>
+          <p:cNvPr id="20" name="Text 14"/>
+          <p:cNvSpPr/>
+          <p:nvPr/>
+        </p:nvSpPr>
+        <p:spPr>
+          <a:xfrm>
+            <a:off x="1078992" y="4398264"/>
+            <a:ext cx="4742536" cy="256032"/>
+          </a:xfrm>
+          <a:prstGeom prst="rect">
+            <a:avLst/>
+          </a:prstGeom>
+          <a:noFill/>
+          <a:ln/>
+        </p:spPr>
+        <p:txBody>
+          <a:bodyPr wrap="square" lIns="0" tIns="0" rIns="0" bIns="0" rtlCol="0" anchor="ctr"/>
+          <a:lstStyle/>
+          <a:p>
+            <a:pPr indent="0" marL="0">
+              <a:buNone/>
+            </a:pPr>
+            <a:r>
+              <a:rPr lang="en-US" sz="1250" b="1" dirty="0">
+                <a:solidFill>
+                  <a:srgbClr val="0D1B3E"/>
+                </a:solidFill>
+                <a:latin typeface="Calibri" pitchFamily="34" charset="0"/>
+                <a:ea typeface="Calibri" pitchFamily="34" charset="-122"/>
+                <a:cs typeface="Calibri" pitchFamily="34" charset="-120"/>
+              </a:rPr>
+              <a:t>Reserva atingida</a:t>
+            </a:r>
+            <a:endParaRPr lang="en-US" sz="1250" dirty="0"/>
+          </a:p>
+        </p:txBody>
+      </p:sp>
+      <p:sp>
+        <p:nvSpPr>
+          <p:cNvPr id="21" name="Text 15"/>
+          <p:cNvSpPr/>
+          <p:nvPr/>
+        </p:nvSpPr>
+        <p:spPr>
+          <a:xfrm>
+            <a:off x="1078992" y="4654296"/>
+            <a:ext cx="4742536" cy="502920"/>
+          </a:xfrm>
+          <a:prstGeom prst="rect">
+            <a:avLst/>
+          </a:prstGeom>
+          <a:noFill/>
+          <a:ln/>
+        </p:spPr>
+        <p:txBody>
+          <a:bodyPr wrap="square" lIns="0" tIns="0" rIns="0" bIns="0" rtlCol="0" anchor="ctr"/>
+          <a:lstStyle/>
+          <a:p>
+            <a:pPr indent="0" marL="0">
+              <a:lnSpc>
+                <a:spcPct val="110000"/>
+              </a:lnSpc>
+              <a:buNone/>
+            </a:pPr>
+            <a:r>
+              <a:rPr lang="en-US" sz="1000" dirty="0">
+                <a:solidFill>
+                  <a:srgbClr val="40496B"/>
+                </a:solidFill>
+                <a:latin typeface="Calibri" pitchFamily="34" charset="0"/>
+                <a:ea typeface="Calibri" pitchFamily="34" charset="-122"/>
+                <a:cs typeface="Calibri" pitchFamily="34" charset="-120"/>
+              </a:rPr>
+              <a:t>A cotação caiu até o preço que você reservou (vale o maior preço reservado).</a:t>
+            </a:r>
+            <a:endParaRPr lang="en-US" sz="1000" dirty="0"/>
+          </a:p>
+        </p:txBody>
+      </p:sp>
+      <p:sp>
+        <p:nvSpPr>
+          <p:cNvPr id="22" name="Shape 16"/>
+          <p:cNvSpPr/>
+          <p:nvPr/>
+        </p:nvSpPr>
+        <p:spPr>
+          <a:xfrm>
+            <a:off x="6370168" y="4434840"/>
+            <a:ext cx="384048" cy="384048"/>
+          </a:xfrm>
+          <a:prstGeom prst="ellipse">
+            <a:avLst/>
+          </a:prstGeom>
+          <a:solidFill>
+            <a:srgbClr val="00D68F"/>
+          </a:solidFill>
+          <a:ln/>
+        </p:spPr>
+        <p:txBody>
+          <a:bodyPr/>
+          <a:p/>
+        </p:txBody>
+      </p:sp>
+      <p:pic>
+        <p:nvPicPr>
+          <p:cNvPr id="23" name="Image 4" descr="">    </p:cNvPr>
+          <p:cNvPicPr>
+            <a:picLocks noChangeAspect="1"/>
+          </p:cNvPicPr>
+          <p:nvPr/>
+        </p:nvPicPr>
+        <p:blipFill>
+          <a:blip r:embed="rId5"/>
+          <a:stretch>
+            <a:fillRect/>
+          </a:stretch>
+        </p:blipFill>
+        <p:spPr>
+          <a:xfrm>
+            <a:off x="6462339" y="4527012"/>
+            <a:ext cx="199705" cy="199705"/>
+          </a:xfrm>
+          <a:prstGeom prst="rect">
+            <a:avLst/>
+          </a:prstGeom>
+        </p:spPr>
+      </p:pic>
+      <p:sp>
+        <p:nvSpPr>
+          <p:cNvPr id="24" name="Text 17"/>
+          <p:cNvSpPr/>
+          <p:nvPr/>
+        </p:nvSpPr>
+        <p:spPr>
+          <a:xfrm>
+            <a:off x="6900520" y="4398264"/>
+            <a:ext cx="4742536" cy="256032"/>
+          </a:xfrm>
+          <a:prstGeom prst="rect">
+            <a:avLst/>
+          </a:prstGeom>
+          <a:noFill/>
+          <a:ln/>
+        </p:spPr>
+        <p:txBody>
+          <a:bodyPr wrap="square" lIns="0" tIns="0" rIns="0" bIns="0" rtlCol="0" anchor="ctr"/>
+          <a:lstStyle/>
+          <a:p>
+            <a:pPr indent="0" marL="0">
+              <a:buNone/>
+            </a:pPr>
+            <a:r>
+              <a:rPr lang="en-US" sz="1250" b="1" dirty="0">
+                <a:solidFill>
+                  <a:srgbClr val="0D1B3E"/>
+                </a:solidFill>
+                <a:latin typeface="Calibri" pitchFamily="34" charset="0"/>
+                <a:ea typeface="Calibri" pitchFamily="34" charset="-122"/>
+                <a:cs typeface="Calibri" pitchFamily="34" charset="-120"/>
+              </a:rPr>
+              <a:t>Análise e Sugestões de hoje (IA)</a:t>
+            </a:r>
+            <a:endParaRPr lang="en-US" sz="1250" dirty="0"/>
+          </a:p>
+        </p:txBody>
+      </p:sp>
+      <p:sp>
+        <p:nvSpPr>
+          <p:cNvPr id="25" name="Text 18"/>
+          <p:cNvSpPr/>
+          <p:nvPr/>
+        </p:nvSpPr>
+        <p:spPr>
+          <a:xfrm>
+            <a:off x="6900520" y="4654296"/>
+            <a:ext cx="4742536" cy="502920"/>
+          </a:xfrm>
+          <a:prstGeom prst="rect">
+            <a:avLst/>
+          </a:prstGeom>
+          <a:noFill/>
+          <a:ln/>
+        </p:spPr>
+        <p:txBody>
+          <a:bodyPr wrap="square" lIns="0" tIns="0" rIns="0" bIns="0" rtlCol="0" anchor="ctr"/>
+          <a:lstStyle/>
+          <a:p>
+            <a:pPr indent="0" marL="0">
+              <a:lnSpc>
+                <a:spcPct val="110000"/>
+              </a:lnSpc>
+              <a:buNone/>
+            </a:pPr>
+            <a:r>
+              <a:rPr lang="en-US" sz="1000" dirty="0">
+                <a:solidFill>
+                  <a:srgbClr val="40496B"/>
+                </a:solidFill>
+                <a:latin typeface="Calibri" pitchFamily="34" charset="0"/>
+                <a:ea typeface="Calibri" pitchFamily="34" charset="-122"/>
+                <a:cs typeface="Calibri" pitchFamily="34" charset="-120"/>
+              </a:rPr>
+              <a:t>Ao clicar nos botões e sozinhas 1x por dia útil, a partir das 11h (TELEGRAM_IA_DIARIA_HORA).</a:t>
+            </a:r>
+            <a:endParaRPr lang="en-US" sz="1000" dirty="0"/>
+          </a:p>
+        </p:txBody>
+      </p:sp>
+      <p:sp>
+        <p:nvSpPr>
+          <p:cNvPr id="26" name="Shape 19"/>
+          <p:cNvSpPr/>
+          <p:nvPr/>
+        </p:nvSpPr>
+        <p:spPr>
+          <a:xfrm>
+            <a:off x="548640" y="5577840"/>
+            <a:ext cx="11094415" cy="594360"/>
+          </a:xfrm>
+          <a:prstGeom prst="roundRect">
+            <a:avLst>
+              <a:gd name="adj" fmla="val 12308"/>
+            </a:avLst>
+          </a:prstGeom>
+          <a:solidFill>
+            <a:srgbClr val="FDECEE"/>
+          </a:solidFill>
+          <a:ln/>
+        </p:spPr>
+        <p:txBody>
+          <a:bodyPr/>
+          <a:p/>
+        </p:txBody>
+      </p:sp>
+      <p:sp>
+        <p:nvSpPr>
+          <p:cNvPr id="27" name="Shape 20"/>
+          <p:cNvSpPr/>
+          <p:nvPr/>
+        </p:nvSpPr>
+        <p:spPr>
+          <a:xfrm>
+            <a:off x="731520" y="5710428"/>
+            <a:ext cx="329184" cy="329184"/>
+          </a:xfrm>
+          <a:prstGeom prst="ellipse">
+            <a:avLst/>
+          </a:prstGeom>
+          <a:solidFill>
+            <a:srgbClr val="E1495A"/>
+          </a:solidFill>
+          <a:ln/>
+        </p:spPr>
+        <p:txBody>
+          <a:bodyPr/>
+          <a:p/>
+        </p:txBody>
+      </p:sp>
+      <p:pic>
+        <p:nvPicPr>
+          <p:cNvPr id="28" name="Image 5" descr="">    </p:cNvPr>
+          <p:cNvPicPr>
+            <a:picLocks noChangeAspect="1"/>
+          </p:cNvPicPr>
+          <p:nvPr/>
+        </p:nvPicPr>
+        <p:blipFill>
+          <a:blip r:embed="rId6"/>
+          <a:stretch>
+            <a:fillRect/>
+          </a:stretch>
+        </p:blipFill>
+        <p:spPr>
+          <a:xfrm>
+            <a:off x="803940" y="5782848"/>
+            <a:ext cx="184343" cy="184343"/>
+          </a:xfrm>
+          <a:prstGeom prst="rect">
+            <a:avLst/>
+          </a:prstGeom>
+        </p:spPr>
+      </p:pic>
+      <p:sp>
+        <p:nvSpPr>
+          <p:cNvPr id="29" name="Text 21"/>
+          <p:cNvSpPr/>
+          <p:nvPr/>
+        </p:nvSpPr>
+        <p:spPr>
+          <a:xfrm>
+            <a:off x="1225296" y="5669280"/>
+            <a:ext cx="10234879" cy="411480"/>
+          </a:xfrm>
+          <a:prstGeom prst="rect">
+            <a:avLst/>
+          </a:prstGeom>
+          <a:noFill/>
+          <a:ln/>
+        </p:spPr>
+        <p:txBody>
+          <a:bodyPr wrap="square" lIns="0" tIns="0" rIns="0" bIns="0" rtlCol="0" anchor="ctr"/>
+          <a:lstStyle/>
+          <a:p>
+            <a:pPr indent="0" marL="0">
+              <a:lnSpc>
+                <a:spcPct val="115000"/>
+              </a:lnSpc>
+              <a:buNone/>
+            </a:pPr>
+            <a:r>
+              <a:rPr lang="en-US" sz="1050" dirty="0">
+                <a:solidFill>
+                  <a:srgbClr val="0D1B3E"/>
+                </a:solidFill>
+                <a:latin typeface="Calibri" pitchFamily="34" charset="0"/>
+                <a:ea typeface="Calibri" pitchFamily="34" charset="-122"/>
+                <a:cs typeface="Calibri" pitchFamily="34" charset="-120"/>
+              </a:rPr>
+              <a:t>Cada ativo é avisado no máximo 1x por dia. É apoio à decisão, não recomendação — o sistema não executa ordens na corretora.</a:t>
+            </a:r>
+            <a:endParaRPr lang="en-US" sz="1050" dirty="0"/>
+          </a:p>
+        </p:txBody>
+      </p:sp>
+      <p:sp>
+        <p:nvSpPr>
+          <p:cNvPr id="30" name="Text 22"/>
+          <p:cNvSpPr/>
+          <p:nvPr/>
+        </p:nvSpPr>
+        <p:spPr>
+          <a:xfrm>
+            <a:off x="548640" y="6473952"/>
+            <a:ext cx="7315200" cy="274320"/>
+          </a:xfrm>
+          <a:prstGeom prst="rect">
+            <a:avLst/>
+          </a:prstGeom>
+          <a:noFill/>
+          <a:ln/>
+        </p:spPr>
+        <p:txBody>
+          <a:bodyPr wrap="square" lIns="0" tIns="0" rIns="0" bIns="0" rtlCol="0" anchor="ctr"/>
+          <a:lstStyle/>
+          <a:p>
+            <a:pPr algn="l" indent="0" marL="0">
+              <a:buNone/>
+            </a:pPr>
+            <a:r>
+              <a:rPr lang="en-US" sz="900" dirty="0">
+                <a:solidFill>
+                  <a:srgbClr val="7C89A8"/>
+                </a:solidFill>
+                <a:latin typeface="Calibri" pitchFamily="34" charset="0"/>
+                <a:ea typeface="Calibri" pitchFamily="34" charset="-122"/>
+                <a:cs typeface="Calibri" pitchFamily="34" charset="-120"/>
+              </a:rPr>
+              <a:t>BolsaTrader  ·  Manual Operacional do Sistema</a:t>
+            </a:r>
+            <a:endParaRPr lang="en-US" sz="900" dirty="0"/>
+          </a:p>
+        </p:txBody>
+      </p:sp>
+      <p:sp>
+        <p:nvSpPr>
+          <p:cNvPr id="31" name="Text 23"/>
+          <p:cNvSpPr/>
+          <p:nvPr/>
+        </p:nvSpPr>
+        <p:spPr>
+          <a:xfrm>
+            <a:off x="10728655" y="6473952"/>
+            <a:ext cx="914400" cy="274320"/>
+          </a:xfrm>
+          <a:prstGeom prst="rect">
+            <a:avLst/>
+          </a:prstGeom>
+          <a:noFill/>
+          <a:ln/>
+        </p:spPr>
+        <p:txBody>
+          <a:bodyPr wrap="square" lIns="0" tIns="0" rIns="0" bIns="0" rtlCol="0" anchor="ctr"/>
+          <a:lstStyle/>
+          <a:p>
+            <a:pPr algn="r" indent="0" marL="0">
+              <a:buNone/>
+            </a:pPr>
+            <a:r>
+              <a:rPr lang="en-US" sz="900" dirty="0">
+                <a:solidFill>
+                  <a:srgbClr val="7C89A8"/>
+                </a:solidFill>
+                <a:latin typeface="Calibri" pitchFamily="34" charset="0"/>
+                <a:ea typeface="Calibri" pitchFamily="34" charset="-122"/>
+                <a:cs typeface="Calibri" pitchFamily="34" charset="-120"/>
+              </a:rPr>
+              <a:t>23</a:t>
             </a:r>
             <a:endParaRPr lang="en-US" sz="900" dirty="0"/>
           </a:p>

</xml_diff>